<commit_message>
Added external interface and other requirements to powerpoint. Also made additional slide for the example ui interface.
</commit_message>
<xml_diff>
--- a/ASGMNT3/JHET_Innovations-Assignment3-SRS-Presentation.pptx
+++ b/ASGMNT3/JHET_Innovations-Assignment3-SRS-Presentation.pptx
@@ -5,7 +5,7 @@
     <p:sldMasterId id="2147483648" r:id="rId1"/>
   </p:sldMasterIdLst>
   <p:notesMasterIdLst>
-    <p:notesMasterId r:id="rId13"/>
+    <p:notesMasterId r:id="rId14"/>
   </p:notesMasterIdLst>
   <p:sldIdLst>
     <p:sldId id="256" r:id="rId2"/>
@@ -15,10 +15,11 @@
     <p:sldId id="265" r:id="rId6"/>
     <p:sldId id="266" r:id="rId7"/>
     <p:sldId id="259" r:id="rId8"/>
-    <p:sldId id="260" r:id="rId9"/>
-    <p:sldId id="261" r:id="rId10"/>
-    <p:sldId id="262" r:id="rId11"/>
-    <p:sldId id="263" r:id="rId12"/>
+    <p:sldId id="267" r:id="rId9"/>
+    <p:sldId id="260" r:id="rId10"/>
+    <p:sldId id="261" r:id="rId11"/>
+    <p:sldId id="262" r:id="rId12"/>
+    <p:sldId id="263" r:id="rId13"/>
   </p:sldIdLst>
   <p:sldSz cx="12192000" cy="6858000"/>
   <p:notesSz cx="6858000" cy="9144000"/>
@@ -207,7 +208,7 @@
           <a:p>
             <a:fld id="{EF042C31-21ED-4F4E-BC17-8A48F1DF5930}" type="datetimeFigureOut">
               <a:rPr lang="en-US" smtClean="0"/>
-              <a:t>10/20/2025</a:t>
+              <a:t>10/21/2025</a:t>
             </a:fld>
             <a:endParaRPr lang="en-US"/>
           </a:p>
@@ -840,7 +841,7 @@
           <a:p>
             <a:fld id="{269ED01E-914A-41E4-88A0-C6BC45F53370}" type="slidenum">
               <a:rPr lang="en-US" smtClean="0"/>
-              <a:t>8</a:t>
+              <a:t>9</a:t>
             </a:fld>
             <a:endParaRPr lang="en-US"/>
           </a:p>
@@ -951,7 +952,7 @@
           <a:p>
             <a:fld id="{269ED01E-914A-41E4-88A0-C6BC45F53370}" type="slidenum">
               <a:rPr lang="en-US" smtClean="0"/>
-              <a:t>9</a:t>
+              <a:t>10</a:t>
             </a:fld>
             <a:endParaRPr lang="en-US"/>
           </a:p>
@@ -1062,7 +1063,7 @@
           <a:p>
             <a:fld id="{269ED01E-914A-41E4-88A0-C6BC45F53370}" type="slidenum">
               <a:rPr lang="en-US" smtClean="0"/>
-              <a:t>10</a:t>
+              <a:t>11</a:t>
             </a:fld>
             <a:endParaRPr lang="en-US"/>
           </a:p>
@@ -1173,7 +1174,7 @@
           <a:p>
             <a:fld id="{269ED01E-914A-41E4-88A0-C6BC45F53370}" type="slidenum">
               <a:rPr lang="en-US" smtClean="0"/>
-              <a:t>11</a:t>
+              <a:t>12</a:t>
             </a:fld>
             <a:endParaRPr lang="en-US"/>
           </a:p>
@@ -1339,7 +1340,7 @@
           <a:p>
             <a:fld id="{2592EE44-8D87-4236-A9CD-E74E4CD01E67}" type="datetimeFigureOut">
               <a:rPr lang="en-US" smtClean="0"/>
-              <a:t>10/20/2025</a:t>
+              <a:t>10/21/2025</a:t>
             </a:fld>
             <a:endParaRPr lang="en-US"/>
           </a:p>
@@ -1537,7 +1538,7 @@
           <a:p>
             <a:fld id="{2592EE44-8D87-4236-A9CD-E74E4CD01E67}" type="datetimeFigureOut">
               <a:rPr lang="en-US" smtClean="0"/>
-              <a:t>10/20/2025</a:t>
+              <a:t>10/21/2025</a:t>
             </a:fld>
             <a:endParaRPr lang="en-US"/>
           </a:p>
@@ -1745,7 +1746,7 @@
           <a:p>
             <a:fld id="{2592EE44-8D87-4236-A9CD-E74E4CD01E67}" type="datetimeFigureOut">
               <a:rPr lang="en-US" smtClean="0"/>
-              <a:t>10/20/2025</a:t>
+              <a:t>10/21/2025</a:t>
             </a:fld>
             <a:endParaRPr lang="en-US"/>
           </a:p>
@@ -1943,7 +1944,7 @@
           <a:p>
             <a:fld id="{2592EE44-8D87-4236-A9CD-E74E4CD01E67}" type="datetimeFigureOut">
               <a:rPr lang="en-US" smtClean="0"/>
-              <a:t>10/20/2025</a:t>
+              <a:t>10/21/2025</a:t>
             </a:fld>
             <a:endParaRPr lang="en-US"/>
           </a:p>
@@ -2218,7 +2219,7 @@
           <a:p>
             <a:fld id="{2592EE44-8D87-4236-A9CD-E74E4CD01E67}" type="datetimeFigureOut">
               <a:rPr lang="en-US" smtClean="0"/>
-              <a:t>10/20/2025</a:t>
+              <a:t>10/21/2025</a:t>
             </a:fld>
             <a:endParaRPr lang="en-US"/>
           </a:p>
@@ -2483,7 +2484,7 @@
           <a:p>
             <a:fld id="{2592EE44-8D87-4236-A9CD-E74E4CD01E67}" type="datetimeFigureOut">
               <a:rPr lang="en-US" smtClean="0"/>
-              <a:t>10/20/2025</a:t>
+              <a:t>10/21/2025</a:t>
             </a:fld>
             <a:endParaRPr lang="en-US"/>
           </a:p>
@@ -2895,7 +2896,7 @@
           <a:p>
             <a:fld id="{2592EE44-8D87-4236-A9CD-E74E4CD01E67}" type="datetimeFigureOut">
               <a:rPr lang="en-US" smtClean="0"/>
-              <a:t>10/20/2025</a:t>
+              <a:t>10/21/2025</a:t>
             </a:fld>
             <a:endParaRPr lang="en-US"/>
           </a:p>
@@ -3036,7 +3037,7 @@
           <a:p>
             <a:fld id="{2592EE44-8D87-4236-A9CD-E74E4CD01E67}" type="datetimeFigureOut">
               <a:rPr lang="en-US" smtClean="0"/>
-              <a:t>10/20/2025</a:t>
+              <a:t>10/21/2025</a:t>
             </a:fld>
             <a:endParaRPr lang="en-US"/>
           </a:p>
@@ -3149,7 +3150,7 @@
           <a:p>
             <a:fld id="{2592EE44-8D87-4236-A9CD-E74E4CD01E67}" type="datetimeFigureOut">
               <a:rPr lang="en-US" smtClean="0"/>
-              <a:t>10/20/2025</a:t>
+              <a:t>10/21/2025</a:t>
             </a:fld>
             <a:endParaRPr lang="en-US"/>
           </a:p>
@@ -3460,7 +3461,7 @@
           <a:p>
             <a:fld id="{2592EE44-8D87-4236-A9CD-E74E4CD01E67}" type="datetimeFigureOut">
               <a:rPr lang="en-US" smtClean="0"/>
-              <a:t>10/20/2025</a:t>
+              <a:t>10/21/2025</a:t>
             </a:fld>
             <a:endParaRPr lang="en-US"/>
           </a:p>
@@ -3748,7 +3749,7 @@
           <a:p>
             <a:fld id="{2592EE44-8D87-4236-A9CD-E74E4CD01E67}" type="datetimeFigureOut">
               <a:rPr lang="en-US" smtClean="0"/>
-              <a:t>10/20/2025</a:t>
+              <a:t>10/21/2025</a:t>
             </a:fld>
             <a:endParaRPr lang="en-US"/>
           </a:p>
@@ -3989,7 +3990,7 @@
           <a:p>
             <a:fld id="{2592EE44-8D87-4236-A9CD-E74E4CD01E67}" type="datetimeFigureOut">
               <a:rPr lang="en-US" smtClean="0"/>
-              <a:t>10/20/2025</a:t>
+              <a:t>10/21/2025</a:t>
             </a:fld>
             <a:endParaRPr lang="en-US"/>
           </a:p>
@@ -4477,6 +4478,70 @@
         <p:cNvPr id="1" name="">
           <a:extLst>
             <a:ext uri="{FF2B5EF4-FFF2-40B4-BE49-F238E27FC236}">
+              <a16:creationId xmlns:a16="http://schemas.microsoft.com/office/drawing/2014/main" id="{1A30B569-EFAB-5D0B-5805-779BF4F6045A}"/>
+            </a:ext>
+          </a:extLst>
+        </p:cNvPr>
+        <p:cNvGrpSpPr/>
+        <p:nvPr/>
+      </p:nvGrpSpPr>
+      <p:grpSpPr>
+        <a:xfrm>
+          <a:off x="0" y="0"/>
+          <a:ext cx="0" cy="0"/>
+          <a:chOff x="0" y="0"/>
+          <a:chExt cx="0" cy="0"/>
+        </a:xfrm>
+      </p:grpSpPr>
+      <p:sp>
+        <p:nvSpPr>
+          <p:cNvPr id="2" name="Title 1">
+            <a:extLst>
+              <a:ext uri="{FF2B5EF4-FFF2-40B4-BE49-F238E27FC236}">
+                <a16:creationId xmlns:a16="http://schemas.microsoft.com/office/drawing/2014/main" id="{0953CBA4-4646-FBD2-58BA-9CAEB90DA639}"/>
+              </a:ext>
+            </a:extLst>
+          </p:cNvPr>
+          <p:cNvSpPr>
+            <a:spLocks noGrp="1"/>
+          </p:cNvSpPr>
+          <p:nvPr>
+            <p:ph type="title"/>
+          </p:nvPr>
+        </p:nvSpPr>
+        <p:spPr/>
+        <p:txBody>
+          <a:bodyPr/>
+          <a:lstStyle/>
+          <a:p>
+            <a:r>
+              <a:rPr lang="en-US" dirty="0"/>
+              <a:t>Nonfunctional Requirements</a:t>
+            </a:r>
+          </a:p>
+        </p:txBody>
+      </p:sp>
+    </p:spTree>
+    <p:extLst>
+      <p:ext uri="{BB962C8B-B14F-4D97-AF65-F5344CB8AC3E}">
+        <p14:creationId xmlns:p14="http://schemas.microsoft.com/office/powerpoint/2010/main" val="739213906"/>
+      </p:ext>
+    </p:extLst>
+  </p:cSld>
+  <p:clrMapOvr>
+    <a:masterClrMapping/>
+  </p:clrMapOvr>
+</p:sld>
+</file>
+
+<file path=ppt/slides/slide11.xml><?xml version="1.0" encoding="utf-8"?>
+<p:sld xmlns:a="http://schemas.openxmlformats.org/drawingml/2006/main" xmlns:r="http://schemas.openxmlformats.org/officeDocument/2006/relationships" xmlns:p="http://schemas.openxmlformats.org/presentationml/2006/main">
+  <p:cSld>
+    <p:spTree>
+      <p:nvGrpSpPr>
+        <p:cNvPr id="1" name="">
+          <a:extLst>
+            <a:ext uri="{FF2B5EF4-FFF2-40B4-BE49-F238E27FC236}">
               <a16:creationId xmlns:a16="http://schemas.microsoft.com/office/drawing/2014/main" id="{701443C0-5831-67B6-D214-3A26D4C6E323}"/>
             </a:ext>
           </a:extLst>
@@ -4520,6 +4585,448 @@
           </a:p>
         </p:txBody>
       </p:sp>
+      <p:graphicFrame>
+        <p:nvGraphicFramePr>
+          <p:cNvPr id="4" name="Table 3">
+            <a:extLst>
+              <a:ext uri="{FF2B5EF4-FFF2-40B4-BE49-F238E27FC236}">
+                <a16:creationId xmlns:a16="http://schemas.microsoft.com/office/drawing/2014/main" id="{460E4E10-4E05-B954-5AFB-74DB054B935A}"/>
+              </a:ext>
+            </a:extLst>
+          </p:cNvPr>
+          <p:cNvGraphicFramePr>
+            <a:graphicFrameLocks noGrp="1"/>
+          </p:cNvGraphicFramePr>
+          <p:nvPr>
+            <p:extLst>
+              <p:ext uri="{D42A27DB-BD31-4B8C-83A1-F6EECF244321}">
+                <p14:modId xmlns:p14="http://schemas.microsoft.com/office/powerpoint/2010/main" val="1370184282"/>
+              </p:ext>
+            </p:extLst>
+          </p:nvPr>
+        </p:nvGraphicFramePr>
+        <p:xfrm>
+          <a:off x="838200" y="1690688"/>
+          <a:ext cx="10515600" cy="3845560"/>
+        </p:xfrm>
+        <a:graphic>
+          <a:graphicData uri="http://schemas.openxmlformats.org/drawingml/2006/table">
+            <a:tbl>
+              <a:tblPr firstRow="1" bandRow="1">
+                <a:tableStyleId>{5C22544A-7EE6-4342-B048-85BDC9FD1C3A}</a:tableStyleId>
+              </a:tblPr>
+              <a:tblGrid>
+                <a:gridCol w="1553967">
+                  <a:extLst>
+                    <a:ext uri="{9D8B030D-6E8A-4147-A177-3AD203B41FA5}">
+                      <a16:colId xmlns:a16="http://schemas.microsoft.com/office/drawing/2014/main" val="296755341"/>
+                    </a:ext>
+                  </a:extLst>
+                </a:gridCol>
+                <a:gridCol w="1768743">
+                  <a:extLst>
+                    <a:ext uri="{9D8B030D-6E8A-4147-A177-3AD203B41FA5}">
+                      <a16:colId xmlns:a16="http://schemas.microsoft.com/office/drawing/2014/main" val="752012600"/>
+                    </a:ext>
+                  </a:extLst>
+                </a:gridCol>
+                <a:gridCol w="5521005">
+                  <a:extLst>
+                    <a:ext uri="{9D8B030D-6E8A-4147-A177-3AD203B41FA5}">
+                      <a16:colId xmlns:a16="http://schemas.microsoft.com/office/drawing/2014/main" val="1806458636"/>
+                    </a:ext>
+                  </a:extLst>
+                </a:gridCol>
+                <a:gridCol w="1671885">
+                  <a:extLst>
+                    <a:ext uri="{9D8B030D-6E8A-4147-A177-3AD203B41FA5}">
+                      <a16:colId xmlns:a16="http://schemas.microsoft.com/office/drawing/2014/main" val="3708226101"/>
+                    </a:ext>
+                  </a:extLst>
+                </a:gridCol>
+              </a:tblGrid>
+              <a:tr h="370840">
+                <a:tc>
+                  <a:txBody>
+                    <a:bodyPr/>
+                    <a:lstStyle/>
+                    <a:p>
+                      <a:pPr algn="ctr"/>
+                      <a:r>
+                        <a:rPr lang="en-US" dirty="0"/>
+                        <a:t>Request #</a:t>
+                      </a:r>
+                    </a:p>
+                  </a:txBody>
+                  <a:tcPr/>
+                </a:tc>
+                <a:tc>
+                  <a:txBody>
+                    <a:bodyPr/>
+                    <a:lstStyle/>
+                    <a:p>
+                      <a:pPr algn="ctr"/>
+                      <a:r>
+                        <a:rPr lang="en-US" dirty="0"/>
+                        <a:t>Feature</a:t>
+                      </a:r>
+                    </a:p>
+                  </a:txBody>
+                  <a:tcPr/>
+                </a:tc>
+                <a:tc>
+                  <a:txBody>
+                    <a:bodyPr/>
+                    <a:lstStyle/>
+                    <a:p>
+                      <a:pPr algn="ctr"/>
+                      <a:r>
+                        <a:rPr lang="en-US" dirty="0"/>
+                        <a:t>Other Requirement Sentence</a:t>
+                      </a:r>
+                    </a:p>
+                  </a:txBody>
+                  <a:tcPr/>
+                </a:tc>
+                <a:tc>
+                  <a:txBody>
+                    <a:bodyPr/>
+                    <a:lstStyle/>
+                    <a:p>
+                      <a:pPr algn="ctr"/>
+                      <a:r>
+                        <a:rPr lang="en-US" dirty="0"/>
+                        <a:t>Priority</a:t>
+                      </a:r>
+                    </a:p>
+                  </a:txBody>
+                  <a:tcPr/>
+                </a:tc>
+                <a:extLst>
+                  <a:ext uri="{0D108BD9-81ED-4DB2-BD59-A6C34878D82A}">
+                    <a16:rowId xmlns:a16="http://schemas.microsoft.com/office/drawing/2014/main" val="1216703589"/>
+                  </a:ext>
+                </a:extLst>
+              </a:tr>
+              <a:tr h="370840">
+                <a:tc>
+                  <a:txBody>
+                    <a:bodyPr/>
+                    <a:lstStyle/>
+                    <a:p>
+                      <a:pPr algn="ctr"/>
+                      <a:r>
+                        <a:rPr lang="en-US" dirty="0"/>
+                        <a:t>OR#1</a:t>
+                      </a:r>
+                    </a:p>
+                  </a:txBody>
+                  <a:tcPr/>
+                </a:tc>
+                <a:tc>
+                  <a:txBody>
+                    <a:bodyPr/>
+                    <a:lstStyle/>
+                    <a:p>
+                      <a:pPr algn="ctr"/>
+                      <a:r>
+                        <a:rPr lang="en-US" dirty="0"/>
+                        <a:t>Documentation</a:t>
+                      </a:r>
+                    </a:p>
+                  </a:txBody>
+                  <a:tcPr/>
+                </a:tc>
+                <a:tc>
+                  <a:txBody>
+                    <a:bodyPr/>
+                    <a:lstStyle/>
+                    <a:p>
+                      <a:pPr algn="l"/>
+                      <a:r>
+                        <a:rPr lang="en-US" dirty="0"/>
+                        <a:t>The system will maintain up-to-date project documentation throughout the semester.</a:t>
+                      </a:r>
+                    </a:p>
+                  </a:txBody>
+                  <a:tcPr/>
+                </a:tc>
+                <a:tc>
+                  <a:txBody>
+                    <a:bodyPr/>
+                    <a:lstStyle/>
+                    <a:p>
+                      <a:pPr algn="ctr"/>
+                      <a:r>
+                        <a:rPr lang="en-US" dirty="0"/>
+                        <a:t>High</a:t>
+                      </a:r>
+                    </a:p>
+                  </a:txBody>
+                  <a:tcPr/>
+                </a:tc>
+                <a:extLst>
+                  <a:ext uri="{0D108BD9-81ED-4DB2-BD59-A6C34878D82A}">
+                    <a16:rowId xmlns:a16="http://schemas.microsoft.com/office/drawing/2014/main" val="1584175637"/>
+                  </a:ext>
+                </a:extLst>
+              </a:tr>
+              <a:tr h="370840">
+                <a:tc>
+                  <a:txBody>
+                    <a:bodyPr/>
+                    <a:lstStyle/>
+                    <a:p>
+                      <a:pPr algn="ctr"/>
+                      <a:r>
+                        <a:rPr lang="en-US" dirty="0"/>
+                        <a:t>OR#2</a:t>
+                      </a:r>
+                    </a:p>
+                  </a:txBody>
+                  <a:tcPr/>
+                </a:tc>
+                <a:tc>
+                  <a:txBody>
+                    <a:bodyPr/>
+                    <a:lstStyle/>
+                    <a:p>
+                      <a:pPr algn="ctr"/>
+                      <a:r>
+                        <a:rPr lang="en-US" dirty="0"/>
+                        <a:t>COSC412</a:t>
+                      </a:r>
+                    </a:p>
+                  </a:txBody>
+                  <a:tcPr/>
+                </a:tc>
+                <a:tc>
+                  <a:txBody>
+                    <a:bodyPr/>
+                    <a:lstStyle/>
+                    <a:p>
+                      <a:pPr algn="l"/>
+                      <a:r>
+                        <a:rPr lang="en-US" dirty="0"/>
+                        <a:t>The system will have all source code version-controlled using GitHub with weekly commits.</a:t>
+                      </a:r>
+                    </a:p>
+                  </a:txBody>
+                  <a:tcPr/>
+                </a:tc>
+                <a:tc>
+                  <a:txBody>
+                    <a:bodyPr/>
+                    <a:lstStyle/>
+                    <a:p>
+                      <a:pPr algn="ctr"/>
+                      <a:r>
+                        <a:rPr lang="en-US" dirty="0"/>
+                        <a:t>High</a:t>
+                      </a:r>
+                    </a:p>
+                  </a:txBody>
+                  <a:tcPr/>
+                </a:tc>
+                <a:extLst>
+                  <a:ext uri="{0D108BD9-81ED-4DB2-BD59-A6C34878D82A}">
+                    <a16:rowId xmlns:a16="http://schemas.microsoft.com/office/drawing/2014/main" val="1012845144"/>
+                  </a:ext>
+                </a:extLst>
+              </a:tr>
+              <a:tr h="370840">
+                <a:tc>
+                  <a:txBody>
+                    <a:bodyPr/>
+                    <a:lstStyle/>
+                    <a:p>
+                      <a:pPr algn="ctr"/>
+                      <a:r>
+                        <a:rPr lang="en-US" dirty="0"/>
+                        <a:t>OR#3</a:t>
+                      </a:r>
+                    </a:p>
+                  </a:txBody>
+                  <a:tcPr/>
+                </a:tc>
+                <a:tc>
+                  <a:txBody>
+                    <a:bodyPr/>
+                    <a:lstStyle/>
+                    <a:p>
+                      <a:pPr algn="ctr"/>
+                      <a:r>
+                        <a:rPr lang="en-US" dirty="0"/>
+                        <a:t>Scalability</a:t>
+                      </a:r>
+                    </a:p>
+                  </a:txBody>
+                  <a:tcPr/>
+                </a:tc>
+                <a:tc>
+                  <a:txBody>
+                    <a:bodyPr/>
+                    <a:lstStyle/>
+                    <a:p>
+                      <a:pPr algn="l"/>
+                      <a:r>
+                        <a:rPr lang="en-US" dirty="0"/>
+                        <a:t>The system must be designed to handle multiple concurrent users without performance degradation.</a:t>
+                      </a:r>
+                    </a:p>
+                  </a:txBody>
+                  <a:tcPr/>
+                </a:tc>
+                <a:tc>
+                  <a:txBody>
+                    <a:bodyPr/>
+                    <a:lstStyle/>
+                    <a:p>
+                      <a:pPr algn="ctr"/>
+                      <a:r>
+                        <a:rPr lang="en-US" dirty="0"/>
+                        <a:t>Medium</a:t>
+                      </a:r>
+                    </a:p>
+                  </a:txBody>
+                  <a:tcPr/>
+                </a:tc>
+                <a:extLst>
+                  <a:ext uri="{0D108BD9-81ED-4DB2-BD59-A6C34878D82A}">
+                    <a16:rowId xmlns:a16="http://schemas.microsoft.com/office/drawing/2014/main" val="3314131713"/>
+                  </a:ext>
+                </a:extLst>
+              </a:tr>
+              <a:tr h="370840">
+                <a:tc>
+                  <a:txBody>
+                    <a:bodyPr/>
+                    <a:lstStyle/>
+                    <a:p>
+                      <a:pPr algn="ctr"/>
+                      <a:r>
+                        <a:rPr lang="en-US" dirty="0"/>
+                        <a:t>OR#4</a:t>
+                      </a:r>
+                    </a:p>
+                  </a:txBody>
+                  <a:tcPr/>
+                </a:tc>
+                <a:tc>
+                  <a:txBody>
+                    <a:bodyPr/>
+                    <a:lstStyle/>
+                    <a:p>
+                      <a:pPr algn="ctr"/>
+                      <a:r>
+                        <a:rPr lang="en-US" dirty="0"/>
+                        <a:t>Open Source</a:t>
+                      </a:r>
+                    </a:p>
+                  </a:txBody>
+                  <a:tcPr/>
+                </a:tc>
+                <a:tc>
+                  <a:txBody>
+                    <a:bodyPr/>
+                    <a:lstStyle/>
+                    <a:p>
+                      <a:pPr algn="l"/>
+                      <a:r>
+                        <a:rPr lang="en-US" dirty="0"/>
+                        <a:t>The system will use only open-source or educational licenses for all libraries and frameworks.</a:t>
+                      </a:r>
+                    </a:p>
+                  </a:txBody>
+                  <a:tcPr/>
+                </a:tc>
+                <a:tc>
+                  <a:txBody>
+                    <a:bodyPr/>
+                    <a:lstStyle/>
+                    <a:p>
+                      <a:pPr algn="ctr"/>
+                      <a:r>
+                        <a:rPr lang="en-US" dirty="0"/>
+                        <a:t>Medium</a:t>
+                      </a:r>
+                    </a:p>
+                  </a:txBody>
+                  <a:tcPr/>
+                </a:tc>
+                <a:extLst>
+                  <a:ext uri="{0D108BD9-81ED-4DB2-BD59-A6C34878D82A}">
+                    <a16:rowId xmlns:a16="http://schemas.microsoft.com/office/drawing/2014/main" val="1946630327"/>
+                  </a:ext>
+                </a:extLst>
+              </a:tr>
+              <a:tr h="370840">
+                <a:tc>
+                  <a:txBody>
+                    <a:bodyPr/>
+                    <a:lstStyle/>
+                    <a:p>
+                      <a:pPr algn="ctr"/>
+                      <a:r>
+                        <a:rPr lang="en-US" dirty="0"/>
+                        <a:t>OR#5</a:t>
+                      </a:r>
+                    </a:p>
+                  </a:txBody>
+                  <a:tcPr/>
+                </a:tc>
+                <a:tc>
+                  <a:txBody>
+                    <a:bodyPr/>
+                    <a:lstStyle/>
+                    <a:p>
+                      <a:pPr algn="ctr"/>
+                      <a:r>
+                        <a:rPr lang="en-US" dirty="0"/>
+                        <a:t>Post-Implementation Support</a:t>
+                      </a:r>
+                    </a:p>
+                  </a:txBody>
+                  <a:tcPr/>
+                </a:tc>
+                <a:tc>
+                  <a:txBody>
+                    <a:bodyPr/>
+                    <a:lstStyle/>
+                    <a:p>
+                      <a:pPr algn="l"/>
+                      <a:r>
+                        <a:rPr lang="en-US" dirty="0"/>
+                        <a:t>The system will include a post-release maintenance plan following MVP delivery.</a:t>
+                      </a:r>
+                    </a:p>
+                  </a:txBody>
+                  <a:tcPr/>
+                </a:tc>
+                <a:tc>
+                  <a:txBody>
+                    <a:bodyPr/>
+                    <a:lstStyle/>
+                    <a:p>
+                      <a:pPr algn="ctr"/>
+                      <a:r>
+                        <a:rPr lang="en-US" dirty="0"/>
+                        <a:t>Low</a:t>
+                      </a:r>
+                    </a:p>
+                  </a:txBody>
+                  <a:tcPr/>
+                </a:tc>
+                <a:extLst>
+                  <a:ext uri="{0D108BD9-81ED-4DB2-BD59-A6C34878D82A}">
+                    <a16:rowId xmlns:a16="http://schemas.microsoft.com/office/drawing/2014/main" val="456398490"/>
+                  </a:ext>
+                </a:extLst>
+              </a:tr>
+            </a:tbl>
+          </a:graphicData>
+        </a:graphic>
+      </p:graphicFrame>
     </p:spTree>
     <p:extLst>
       <p:ext uri="{BB962C8B-B14F-4D97-AF65-F5344CB8AC3E}">
@@ -4533,7 +5040,7 @@
 </p:sld>
 </file>
 
-<file path=ppt/slides/slide11.xml><?xml version="1.0" encoding="utf-8"?>
+<file path=ppt/slides/slide12.xml><?xml version="1.0" encoding="utf-8"?>
 <p:sld xmlns:a="http://schemas.openxmlformats.org/drawingml/2006/main" xmlns:r="http://schemas.openxmlformats.org/officeDocument/2006/relationships" xmlns:p="http://schemas.openxmlformats.org/presentationml/2006/main">
   <p:cSld>
     <p:spTree>
@@ -7291,6 +7798,466 @@
           </a:p>
         </p:txBody>
       </p:sp>
+      <p:graphicFrame>
+        <p:nvGraphicFramePr>
+          <p:cNvPr id="3" name="Table 2">
+            <a:extLst>
+              <a:ext uri="{FF2B5EF4-FFF2-40B4-BE49-F238E27FC236}">
+                <a16:creationId xmlns:a16="http://schemas.microsoft.com/office/drawing/2014/main" id="{B4193D87-DB4C-A869-8F57-E3D7000A99D2}"/>
+              </a:ext>
+            </a:extLst>
+          </p:cNvPr>
+          <p:cNvGraphicFramePr>
+            <a:graphicFrameLocks noGrp="1"/>
+          </p:cNvGraphicFramePr>
+          <p:nvPr>
+            <p:extLst>
+              <p:ext uri="{D42A27DB-BD31-4B8C-83A1-F6EECF244321}">
+                <p14:modId xmlns:p14="http://schemas.microsoft.com/office/powerpoint/2010/main" val="1213446771"/>
+              </p:ext>
+            </p:extLst>
+          </p:nvPr>
+        </p:nvGraphicFramePr>
+        <p:xfrm>
+          <a:off x="838199" y="1690688"/>
+          <a:ext cx="10515600" cy="3845560"/>
+        </p:xfrm>
+        <a:graphic>
+          <a:graphicData uri="http://schemas.openxmlformats.org/drawingml/2006/table">
+            <a:tbl>
+              <a:tblPr firstRow="1" bandRow="1">
+                <a:tableStyleId>{5C22544A-7EE6-4342-B048-85BDC9FD1C3A}</a:tableStyleId>
+              </a:tblPr>
+              <a:tblGrid>
+                <a:gridCol w="1719944">
+                  <a:extLst>
+                    <a:ext uri="{9D8B030D-6E8A-4147-A177-3AD203B41FA5}">
+                      <a16:colId xmlns:a16="http://schemas.microsoft.com/office/drawing/2014/main" val="4174102130"/>
+                    </a:ext>
+                  </a:extLst>
+                </a:gridCol>
+                <a:gridCol w="1948543">
+                  <a:extLst>
+                    <a:ext uri="{9D8B030D-6E8A-4147-A177-3AD203B41FA5}">
+                      <a16:colId xmlns:a16="http://schemas.microsoft.com/office/drawing/2014/main" val="1712366548"/>
+                    </a:ext>
+                  </a:extLst>
+                </a:gridCol>
+                <a:gridCol w="5072743">
+                  <a:extLst>
+                    <a:ext uri="{9D8B030D-6E8A-4147-A177-3AD203B41FA5}">
+                      <a16:colId xmlns:a16="http://schemas.microsoft.com/office/drawing/2014/main" val="911734909"/>
+                    </a:ext>
+                  </a:extLst>
+                </a:gridCol>
+                <a:gridCol w="1774370">
+                  <a:extLst>
+                    <a:ext uri="{9D8B030D-6E8A-4147-A177-3AD203B41FA5}">
+                      <a16:colId xmlns:a16="http://schemas.microsoft.com/office/drawing/2014/main" val="3654786738"/>
+                    </a:ext>
+                  </a:extLst>
+                </a:gridCol>
+              </a:tblGrid>
+              <a:tr h="370840">
+                <a:tc>
+                  <a:txBody>
+                    <a:bodyPr/>
+                    <a:lstStyle/>
+                    <a:p>
+                      <a:pPr algn="ctr"/>
+                      <a:r>
+                        <a:rPr lang="en-US" dirty="0"/>
+                        <a:t>Request #</a:t>
+                      </a:r>
+                    </a:p>
+                  </a:txBody>
+                  <a:tcPr/>
+                </a:tc>
+                <a:tc>
+                  <a:txBody>
+                    <a:bodyPr/>
+                    <a:lstStyle/>
+                    <a:p>
+                      <a:pPr algn="ctr"/>
+                      <a:r>
+                        <a:rPr lang="en-US" dirty="0"/>
+                        <a:t>Feature</a:t>
+                      </a:r>
+                    </a:p>
+                  </a:txBody>
+                  <a:tcPr/>
+                </a:tc>
+                <a:tc>
+                  <a:txBody>
+                    <a:bodyPr/>
+                    <a:lstStyle/>
+                    <a:p>
+                      <a:pPr algn="ctr"/>
+                      <a:r>
+                        <a:rPr lang="en-US" sz="1600" dirty="0"/>
+                        <a:t>External Interface Sentence</a:t>
+                      </a:r>
+                    </a:p>
+                  </a:txBody>
+                  <a:tcPr/>
+                </a:tc>
+                <a:tc>
+                  <a:txBody>
+                    <a:bodyPr/>
+                    <a:lstStyle/>
+                    <a:p>
+                      <a:pPr algn="ctr"/>
+                      <a:r>
+                        <a:rPr lang="en-US" dirty="0"/>
+                        <a:t>Priority</a:t>
+                      </a:r>
+                    </a:p>
+                  </a:txBody>
+                  <a:tcPr/>
+                </a:tc>
+                <a:extLst>
+                  <a:ext uri="{0D108BD9-81ED-4DB2-BD59-A6C34878D82A}">
+                    <a16:rowId xmlns:a16="http://schemas.microsoft.com/office/drawing/2014/main" val="1075072847"/>
+                  </a:ext>
+                </a:extLst>
+              </a:tr>
+              <a:tr h="370840">
+                <a:tc>
+                  <a:txBody>
+                    <a:bodyPr/>
+                    <a:lstStyle/>
+                    <a:p>
+                      <a:pPr algn="ctr"/>
+                      <a:r>
+                        <a:rPr lang="en-US" dirty="0"/>
+                        <a:t>EIR#1</a:t>
+                      </a:r>
+                    </a:p>
+                  </a:txBody>
+                  <a:tcPr/>
+                </a:tc>
+                <a:tc>
+                  <a:txBody>
+                    <a:bodyPr/>
+                    <a:lstStyle/>
+                    <a:p>
+                      <a:pPr algn="ctr"/>
+                      <a:r>
+                        <a:rPr lang="en-US" dirty="0"/>
+                        <a:t>User Interface</a:t>
+                      </a:r>
+                    </a:p>
+                  </a:txBody>
+                  <a:tcPr/>
+                </a:tc>
+                <a:tc>
+                  <a:txBody>
+                    <a:bodyPr/>
+                    <a:lstStyle/>
+                    <a:p>
+                      <a:pPr algn="l"/>
+                      <a:r>
+                        <a:rPr lang="en-US" sz="1800" kern="1200" dirty="0">
+                          <a:solidFill>
+                            <a:schemeClr val="dk1"/>
+                          </a:solidFill>
+                          <a:effectLst/>
+                          <a:latin typeface="+mn-lt"/>
+                          <a:ea typeface="+mn-ea"/>
+                          <a:cs typeface="+mn-cs"/>
+                        </a:rPr>
+                        <a:t>The system must run on a web browser via desktop and tablet interfaces.</a:t>
+                      </a:r>
+                      <a:endParaRPr lang="en-US" sz="1800" dirty="0"/>
+                    </a:p>
+                  </a:txBody>
+                  <a:tcPr/>
+                </a:tc>
+                <a:tc>
+                  <a:txBody>
+                    <a:bodyPr/>
+                    <a:lstStyle/>
+                    <a:p>
+                      <a:pPr algn="ctr"/>
+                      <a:r>
+                        <a:rPr lang="en-US"/>
+                        <a:t>High</a:t>
+                      </a:r>
+                      <a:endParaRPr lang="en-US" dirty="0"/>
+                    </a:p>
+                  </a:txBody>
+                  <a:tcPr/>
+                </a:tc>
+                <a:extLst>
+                  <a:ext uri="{0D108BD9-81ED-4DB2-BD59-A6C34878D82A}">
+                    <a16:rowId xmlns:a16="http://schemas.microsoft.com/office/drawing/2014/main" val="1021050612"/>
+                  </a:ext>
+                </a:extLst>
+              </a:tr>
+              <a:tr h="370840">
+                <a:tc>
+                  <a:txBody>
+                    <a:bodyPr/>
+                    <a:lstStyle/>
+                    <a:p>
+                      <a:pPr algn="ctr"/>
+                      <a:r>
+                        <a:rPr lang="en-US" dirty="0"/>
+                        <a:t>EIR#2</a:t>
+                      </a:r>
+                    </a:p>
+                  </a:txBody>
+                  <a:tcPr/>
+                </a:tc>
+                <a:tc>
+                  <a:txBody>
+                    <a:bodyPr/>
+                    <a:lstStyle/>
+                    <a:p>
+                      <a:pPr algn="ctr"/>
+                      <a:r>
+                        <a:rPr lang="en-US" dirty="0"/>
+                        <a:t>Hardware</a:t>
+                      </a:r>
+                    </a:p>
+                  </a:txBody>
+                  <a:tcPr/>
+                </a:tc>
+                <a:tc>
+                  <a:txBody>
+                    <a:bodyPr/>
+                    <a:lstStyle/>
+                    <a:p>
+                      <a:pPr algn="l"/>
+                      <a:r>
+                        <a:rPr lang="en-US" sz="1800" dirty="0"/>
+                        <a:t>The system must operate without the use of specialized hardware.</a:t>
+                      </a:r>
+                    </a:p>
+                  </a:txBody>
+                  <a:tcPr/>
+                </a:tc>
+                <a:tc>
+                  <a:txBody>
+                    <a:bodyPr/>
+                    <a:lstStyle/>
+                    <a:p>
+                      <a:pPr algn="ctr"/>
+                      <a:r>
+                        <a:rPr lang="en-US" dirty="0"/>
+                        <a:t>High</a:t>
+                      </a:r>
+                    </a:p>
+                  </a:txBody>
+                  <a:tcPr/>
+                </a:tc>
+                <a:extLst>
+                  <a:ext uri="{0D108BD9-81ED-4DB2-BD59-A6C34878D82A}">
+                    <a16:rowId xmlns:a16="http://schemas.microsoft.com/office/drawing/2014/main" val="1060847630"/>
+                  </a:ext>
+                </a:extLst>
+              </a:tr>
+              <a:tr h="370840">
+                <a:tc>
+                  <a:txBody>
+                    <a:bodyPr/>
+                    <a:lstStyle/>
+                    <a:p>
+                      <a:pPr algn="ctr"/>
+                      <a:r>
+                        <a:rPr lang="en-US" dirty="0"/>
+                        <a:t>EIR#3</a:t>
+                      </a:r>
+                    </a:p>
+                  </a:txBody>
+                  <a:tcPr/>
+                </a:tc>
+                <a:tc>
+                  <a:txBody>
+                    <a:bodyPr/>
+                    <a:lstStyle/>
+                    <a:p>
+                      <a:pPr algn="ctr"/>
+                      <a:r>
+                        <a:rPr lang="en-US" dirty="0"/>
+                        <a:t>Software</a:t>
+                      </a:r>
+                    </a:p>
+                  </a:txBody>
+                  <a:tcPr/>
+                </a:tc>
+                <a:tc>
+                  <a:txBody>
+                    <a:bodyPr/>
+                    <a:lstStyle/>
+                    <a:p>
+                      <a:pPr algn="l"/>
+                      <a:r>
+                        <a:rPr lang="en-US" sz="1800" dirty="0"/>
+                        <a:t>The system must utilize a React based frontend hosted on </a:t>
+                      </a:r>
+                      <a:r>
+                        <a:rPr lang="en-US" sz="1800" dirty="0" err="1"/>
+                        <a:t>Vercel</a:t>
+                      </a:r>
+                      <a:r>
+                        <a:rPr lang="en-US" sz="1800" dirty="0"/>
+                        <a:t>.</a:t>
+                      </a:r>
+                    </a:p>
+                  </a:txBody>
+                  <a:tcPr/>
+                </a:tc>
+                <a:tc>
+                  <a:txBody>
+                    <a:bodyPr/>
+                    <a:lstStyle/>
+                    <a:p>
+                      <a:pPr algn="ctr"/>
+                      <a:r>
+                        <a:rPr lang="en-US" dirty="0"/>
+                        <a:t>Medium</a:t>
+                      </a:r>
+                    </a:p>
+                  </a:txBody>
+                  <a:tcPr/>
+                </a:tc>
+                <a:extLst>
+                  <a:ext uri="{0D108BD9-81ED-4DB2-BD59-A6C34878D82A}">
+                    <a16:rowId xmlns:a16="http://schemas.microsoft.com/office/drawing/2014/main" val="3533730018"/>
+                  </a:ext>
+                </a:extLst>
+              </a:tr>
+              <a:tr h="370840">
+                <a:tc>
+                  <a:txBody>
+                    <a:bodyPr/>
+                    <a:lstStyle/>
+                    <a:p>
+                      <a:pPr algn="ctr"/>
+                      <a:r>
+                        <a:rPr lang="en-US" dirty="0"/>
+                        <a:t>EIR#4</a:t>
+                      </a:r>
+                    </a:p>
+                  </a:txBody>
+                  <a:tcPr/>
+                </a:tc>
+                <a:tc>
+                  <a:txBody>
+                    <a:bodyPr/>
+                    <a:lstStyle/>
+                    <a:p>
+                      <a:pPr algn="ctr"/>
+                      <a:r>
+                        <a:rPr lang="en-US" dirty="0"/>
+                        <a:t>Security</a:t>
+                      </a:r>
+                    </a:p>
+                  </a:txBody>
+                  <a:tcPr/>
+                </a:tc>
+                <a:tc>
+                  <a:txBody>
+                    <a:bodyPr/>
+                    <a:lstStyle/>
+                    <a:p>
+                      <a:pPr algn="l"/>
+                      <a:r>
+                        <a:rPr lang="en-US" sz="1800" dirty="0"/>
+                        <a:t>The system must utilize JSON Web Tokens to support secure authentication and session management.</a:t>
+                      </a:r>
+                    </a:p>
+                  </a:txBody>
+                  <a:tcPr/>
+                </a:tc>
+                <a:tc>
+                  <a:txBody>
+                    <a:bodyPr/>
+                    <a:lstStyle/>
+                    <a:p>
+                      <a:pPr algn="ctr"/>
+                      <a:r>
+                        <a:rPr lang="en-US" dirty="0"/>
+                        <a:t>High</a:t>
+                      </a:r>
+                    </a:p>
+                  </a:txBody>
+                  <a:tcPr/>
+                </a:tc>
+                <a:extLst>
+                  <a:ext uri="{0D108BD9-81ED-4DB2-BD59-A6C34878D82A}">
+                    <a16:rowId xmlns:a16="http://schemas.microsoft.com/office/drawing/2014/main" val="2152857240"/>
+                  </a:ext>
+                </a:extLst>
+              </a:tr>
+              <a:tr h="370840">
+                <a:tc>
+                  <a:txBody>
+                    <a:bodyPr/>
+                    <a:lstStyle/>
+                    <a:p>
+                      <a:pPr algn="ctr"/>
+                      <a:r>
+                        <a:rPr lang="en-US" dirty="0"/>
+                        <a:t>EIR#5</a:t>
+                      </a:r>
+                    </a:p>
+                  </a:txBody>
+                  <a:tcPr/>
+                </a:tc>
+                <a:tc>
+                  <a:txBody>
+                    <a:bodyPr/>
+                    <a:lstStyle/>
+                    <a:p>
+                      <a:pPr algn="ctr"/>
+                      <a:r>
+                        <a:rPr lang="en-US" dirty="0"/>
+                        <a:t>Communication</a:t>
+                      </a:r>
+                    </a:p>
+                  </a:txBody>
+                  <a:tcPr/>
+                </a:tc>
+                <a:tc>
+                  <a:txBody>
+                    <a:bodyPr/>
+                    <a:lstStyle/>
+                    <a:p>
+                      <a:pPr algn="l"/>
+                      <a:r>
+                        <a:rPr lang="en-US" sz="1800" dirty="0"/>
+                        <a:t>The system must allow real-time communication using Socket.io services.</a:t>
+                      </a:r>
+                    </a:p>
+                  </a:txBody>
+                  <a:tcPr/>
+                </a:tc>
+                <a:tc>
+                  <a:txBody>
+                    <a:bodyPr/>
+                    <a:lstStyle/>
+                    <a:p>
+                      <a:pPr algn="ctr"/>
+                      <a:r>
+                        <a:rPr lang="en-US" dirty="0"/>
+                        <a:t>High</a:t>
+                      </a:r>
+                    </a:p>
+                  </a:txBody>
+                  <a:tcPr/>
+                </a:tc>
+                <a:extLst>
+                  <a:ext uri="{0D108BD9-81ED-4DB2-BD59-A6C34878D82A}">
+                    <a16:rowId xmlns:a16="http://schemas.microsoft.com/office/drawing/2014/main" val="219484715"/>
+                  </a:ext>
+                </a:extLst>
+              </a:tr>
+            </a:tbl>
+          </a:graphicData>
+        </a:graphic>
+      </p:graphicFrame>
     </p:spTree>
     <p:extLst>
       <p:ext uri="{BB962C8B-B14F-4D97-AF65-F5344CB8AC3E}">
@@ -7305,6 +8272,135 @@
 </file>
 
 <file path=ppt/slides/slide8.xml><?xml version="1.0" encoding="utf-8"?>
+<p:sld xmlns:a="http://schemas.openxmlformats.org/drawingml/2006/main" xmlns:r="http://schemas.openxmlformats.org/officeDocument/2006/relationships" xmlns:p="http://schemas.openxmlformats.org/presentationml/2006/main">
+  <p:cSld>
+    <p:spTree>
+      <p:nvGrpSpPr>
+        <p:cNvPr id="1" name=""/>
+        <p:cNvGrpSpPr/>
+        <p:nvPr/>
+      </p:nvGrpSpPr>
+      <p:grpSpPr>
+        <a:xfrm>
+          <a:off x="0" y="0"/>
+          <a:ext cx="0" cy="0"/>
+          <a:chOff x="0" y="0"/>
+          <a:chExt cx="0" cy="0"/>
+        </a:xfrm>
+      </p:grpSpPr>
+      <p:sp>
+        <p:nvSpPr>
+          <p:cNvPr id="2" name="Title 1">
+            <a:extLst>
+              <a:ext uri="{FF2B5EF4-FFF2-40B4-BE49-F238E27FC236}">
+                <a16:creationId xmlns:a16="http://schemas.microsoft.com/office/drawing/2014/main" id="{5FE7BAE4-E3CA-059B-74F1-47CA2D040E20}"/>
+              </a:ext>
+            </a:extLst>
+          </p:cNvPr>
+          <p:cNvSpPr>
+            <a:spLocks noGrp="1"/>
+          </p:cNvSpPr>
+          <p:nvPr>
+            <p:ph type="title"/>
+          </p:nvPr>
+        </p:nvSpPr>
+        <p:spPr/>
+        <p:txBody>
+          <a:bodyPr/>
+          <a:lstStyle/>
+          <a:p>
+            <a:r>
+              <a:rPr lang="en-US" dirty="0"/>
+              <a:t>Example Interface</a:t>
+            </a:r>
+          </a:p>
+        </p:txBody>
+      </p:sp>
+      <p:pic>
+        <p:nvPicPr>
+          <p:cNvPr id="4" name="Picture 3" descr="A screenshot of a computer&#10;&#10;AI-generated content may be incorrect.">
+            <a:extLst>
+              <a:ext uri="{FF2B5EF4-FFF2-40B4-BE49-F238E27FC236}">
+                <a16:creationId xmlns:a16="http://schemas.microsoft.com/office/drawing/2014/main" id="{2D73204C-A872-569B-154D-3EA03810F4CB}"/>
+              </a:ext>
+            </a:extLst>
+          </p:cNvPr>
+          <p:cNvPicPr>
+            <a:picLocks noChangeAspect="1"/>
+          </p:cNvPicPr>
+          <p:nvPr/>
+        </p:nvPicPr>
+        <p:blipFill>
+          <a:blip r:embed="rId2">
+            <a:extLst>
+              <a:ext uri="{28A0092B-C50C-407E-A947-70E740481C1C}">
+                <a14:useLocalDpi xmlns:a14="http://schemas.microsoft.com/office/drawing/2010/main" val="0"/>
+              </a:ext>
+            </a:extLst>
+          </a:blip>
+          <a:stretch>
+            <a:fillRect/>
+          </a:stretch>
+        </p:blipFill>
+        <p:spPr>
+          <a:xfrm>
+            <a:off x="544285" y="1690688"/>
+            <a:ext cx="7120115" cy="4750978"/>
+          </a:xfrm>
+          <a:prstGeom prst="rect">
+            <a:avLst/>
+          </a:prstGeom>
+        </p:spPr>
+      </p:pic>
+      <p:sp>
+        <p:nvSpPr>
+          <p:cNvPr id="6" name="TextBox 5">
+            <a:extLst>
+              <a:ext uri="{FF2B5EF4-FFF2-40B4-BE49-F238E27FC236}">
+                <a16:creationId xmlns:a16="http://schemas.microsoft.com/office/drawing/2014/main" id="{D16A59E9-6AB7-3E7D-C42D-7D303489BE89}"/>
+              </a:ext>
+            </a:extLst>
+          </p:cNvPr>
+          <p:cNvSpPr txBox="1"/>
+          <p:nvPr/>
+        </p:nvSpPr>
+        <p:spPr>
+          <a:xfrm>
+            <a:off x="7903029" y="1926771"/>
+            <a:ext cx="3744686" cy="2308324"/>
+          </a:xfrm>
+          <a:prstGeom prst="rect">
+            <a:avLst/>
+          </a:prstGeom>
+          <a:noFill/>
+        </p:spPr>
+        <p:txBody>
+          <a:bodyPr wrap="square" rtlCol="0">
+            <a:spAutoFit/>
+          </a:bodyPr>
+          <a:lstStyle/>
+          <a:p>
+            <a:r>
+              <a:rPr lang="en-US" dirty="0"/>
+              <a:t>To the left is an example of the interface we plan to implement. Here is the messaging page, where users can message other individual users or complete groups. You can view your message history, create quizzes, flashcards and polls with each messaging subpage, as well.</a:t>
+            </a:r>
+          </a:p>
+        </p:txBody>
+      </p:sp>
+    </p:spTree>
+    <p:extLst>
+      <p:ext uri="{BB962C8B-B14F-4D97-AF65-F5344CB8AC3E}">
+        <p14:creationId xmlns:p14="http://schemas.microsoft.com/office/powerpoint/2010/main" val="2753164882"/>
+      </p:ext>
+    </p:extLst>
+  </p:cSld>
+  <p:clrMapOvr>
+    <a:masterClrMapping/>
+  </p:clrMapOvr>
+</p:sld>
+</file>
+
+<file path=ppt/slides/slide9.xml><?xml version="1.0" encoding="utf-8"?>
 <p:sld xmlns:a="http://schemas.openxmlformats.org/drawingml/2006/main" xmlns:r="http://schemas.openxmlformats.org/officeDocument/2006/relationships" xmlns:p="http://schemas.openxmlformats.org/presentationml/2006/main">
   <p:cSld>
     <p:spTree>
@@ -7359,70 +8455,6 @@
     <p:extLst>
       <p:ext uri="{BB962C8B-B14F-4D97-AF65-F5344CB8AC3E}">
         <p14:creationId xmlns:p14="http://schemas.microsoft.com/office/powerpoint/2010/main" val="4161723360"/>
-      </p:ext>
-    </p:extLst>
-  </p:cSld>
-  <p:clrMapOvr>
-    <a:masterClrMapping/>
-  </p:clrMapOvr>
-</p:sld>
-</file>
-
-<file path=ppt/slides/slide9.xml><?xml version="1.0" encoding="utf-8"?>
-<p:sld xmlns:a="http://schemas.openxmlformats.org/drawingml/2006/main" xmlns:r="http://schemas.openxmlformats.org/officeDocument/2006/relationships" xmlns:p="http://schemas.openxmlformats.org/presentationml/2006/main">
-  <p:cSld>
-    <p:spTree>
-      <p:nvGrpSpPr>
-        <p:cNvPr id="1" name="">
-          <a:extLst>
-            <a:ext uri="{FF2B5EF4-FFF2-40B4-BE49-F238E27FC236}">
-              <a16:creationId xmlns:a16="http://schemas.microsoft.com/office/drawing/2014/main" id="{1A30B569-EFAB-5D0B-5805-779BF4F6045A}"/>
-            </a:ext>
-          </a:extLst>
-        </p:cNvPr>
-        <p:cNvGrpSpPr/>
-        <p:nvPr/>
-      </p:nvGrpSpPr>
-      <p:grpSpPr>
-        <a:xfrm>
-          <a:off x="0" y="0"/>
-          <a:ext cx="0" cy="0"/>
-          <a:chOff x="0" y="0"/>
-          <a:chExt cx="0" cy="0"/>
-        </a:xfrm>
-      </p:grpSpPr>
-      <p:sp>
-        <p:nvSpPr>
-          <p:cNvPr id="2" name="Title 1">
-            <a:extLst>
-              <a:ext uri="{FF2B5EF4-FFF2-40B4-BE49-F238E27FC236}">
-                <a16:creationId xmlns:a16="http://schemas.microsoft.com/office/drawing/2014/main" id="{0953CBA4-4646-FBD2-58BA-9CAEB90DA639}"/>
-              </a:ext>
-            </a:extLst>
-          </p:cNvPr>
-          <p:cNvSpPr>
-            <a:spLocks noGrp="1"/>
-          </p:cNvSpPr>
-          <p:nvPr>
-            <p:ph type="title"/>
-          </p:nvPr>
-        </p:nvSpPr>
-        <p:spPr/>
-        <p:txBody>
-          <a:bodyPr/>
-          <a:lstStyle/>
-          <a:p>
-            <a:r>
-              <a:rPr lang="en-US" dirty="0"/>
-              <a:t>Nonfunctional Requirements</a:t>
-            </a:r>
-          </a:p>
-        </p:txBody>
-      </p:sp>
-    </p:spTree>
-    <p:extLst>
-      <p:ext uri="{BB962C8B-B14F-4D97-AF65-F5344CB8AC3E}">
-        <p14:creationId xmlns:p14="http://schemas.microsoft.com/office/powerpoint/2010/main" val="739213906"/>
       </p:ext>
     </p:extLst>
   </p:cSld>

</xml_diff>

<commit_message>
Added cover slide and JHET Innovations logo to powerpoint
</commit_message>
<xml_diff>
--- a/ASGMNT3/JHET_Innovations-Assignment3-SRS-Presentation.pptx
+++ b/ASGMNT3/JHET_Innovations-Assignment3-SRS-Presentation.pptx
@@ -5159,10 +5159,20 @@
         </p:nvSpPr>
         <p:spPr/>
         <p:txBody>
-          <a:bodyPr/>
+          <a:bodyPr>
+            <a:normAutofit/>
+          </a:bodyPr>
           <a:lstStyle/>
           <a:p>
-            <a:endParaRPr lang="en-US"/>
+            <a:pPr algn="ctr"/>
+            <a:br>
+              <a:rPr lang="en-US" sz="6600" dirty="0"/>
+            </a:br>
+            <a:r>
+              <a:rPr lang="en-US" sz="4000" dirty="0"/>
+              <a:t>Software Requirements Specifications</a:t>
+            </a:r>
+            <a:endParaRPr lang="en-US" sz="6600" dirty="0"/>
           </a:p>
         </p:txBody>
       </p:sp>
@@ -5184,13 +5194,91 @@
         </p:nvSpPr>
         <p:spPr/>
         <p:txBody>
-          <a:bodyPr/>
+          <a:bodyPr>
+            <a:normAutofit/>
+          </a:bodyPr>
           <a:lstStyle/>
           <a:p>
-            <a:endParaRPr lang="en-US"/>
-          </a:p>
-        </p:txBody>
-      </p:sp>
+            <a:pPr algn="ctr"/>
+            <a:r>
+              <a:rPr lang="en-US" sz="2000" dirty="0"/>
+              <a:t>Presented by</a:t>
+            </a:r>
+          </a:p>
+        </p:txBody>
+      </p:sp>
+      <p:pic>
+        <p:nvPicPr>
+          <p:cNvPr id="5" name="Picture 4" descr="A logo of a book and a graduation cap&#10;&#10;AI-generated content may be incorrect.">
+            <a:extLst>
+              <a:ext uri="{FF2B5EF4-FFF2-40B4-BE49-F238E27FC236}">
+                <a16:creationId xmlns:a16="http://schemas.microsoft.com/office/drawing/2014/main" id="{44549FAA-CA75-6362-F088-B9475873E1E3}"/>
+              </a:ext>
+            </a:extLst>
+          </p:cNvPr>
+          <p:cNvPicPr>
+            <a:picLocks noChangeAspect="1"/>
+          </p:cNvPicPr>
+          <p:nvPr/>
+        </p:nvPicPr>
+        <p:blipFill>
+          <a:blip r:embed="rId2">
+            <a:extLst>
+              <a:ext uri="{28A0092B-C50C-407E-A947-70E740481C1C}">
+                <a14:useLocalDpi xmlns:a14="http://schemas.microsoft.com/office/drawing/2010/main" val="0"/>
+              </a:ext>
+            </a:extLst>
+          </a:blip>
+          <a:stretch>
+            <a:fillRect/>
+          </a:stretch>
+        </p:blipFill>
+        <p:spPr>
+          <a:xfrm>
+            <a:off x="3856295" y="0"/>
+            <a:ext cx="4479409" cy="4479409"/>
+          </a:xfrm>
+          <a:prstGeom prst="rect">
+            <a:avLst/>
+          </a:prstGeom>
+        </p:spPr>
+      </p:pic>
+      <p:pic>
+        <p:nvPicPr>
+          <p:cNvPr id="7" name="Picture 6" descr="A logo with a light bulb and text&#10;&#10;AI-generated content may be incorrect.">
+            <a:extLst>
+              <a:ext uri="{FF2B5EF4-FFF2-40B4-BE49-F238E27FC236}">
+                <a16:creationId xmlns:a16="http://schemas.microsoft.com/office/drawing/2014/main" id="{B5FA12E1-F8E4-6543-9985-963DD88C3388}"/>
+              </a:ext>
+            </a:extLst>
+          </p:cNvPr>
+          <p:cNvPicPr>
+            <a:picLocks noChangeAspect="1"/>
+          </p:cNvPicPr>
+          <p:nvPr/>
+        </p:nvPicPr>
+        <p:blipFill>
+          <a:blip r:embed="rId3">
+            <a:extLst>
+              <a:ext uri="{28A0092B-C50C-407E-A947-70E740481C1C}">
+                <a14:useLocalDpi xmlns:a14="http://schemas.microsoft.com/office/drawing/2010/main" val="0"/>
+              </a:ext>
+            </a:extLst>
+          </a:blip>
+          <a:stretch>
+            <a:fillRect/>
+          </a:stretch>
+        </p:blipFill>
+        <p:spPr>
+          <a:xfrm>
+            <a:off x="5402143" y="4814679"/>
+            <a:ext cx="1387713" cy="1387713"/>
+          </a:xfrm>
+          <a:prstGeom prst="rect">
+            <a:avLst/>
+          </a:prstGeom>
+        </p:spPr>
+      </p:pic>
     </p:spTree>
     <p:extLst>
       <p:ext uri="{BB962C8B-B14F-4D97-AF65-F5344CB8AC3E}">
@@ -5464,6 +5552,42 @@
           </a:prstGeom>
         </p:spPr>
       </p:pic>
+      <p:pic>
+        <p:nvPicPr>
+          <p:cNvPr id="3" name="Picture 2" descr="A logo with a light bulb and text&#10;&#10;AI-generated content may be incorrect.">
+            <a:extLst>
+              <a:ext uri="{FF2B5EF4-FFF2-40B4-BE49-F238E27FC236}">
+                <a16:creationId xmlns:a16="http://schemas.microsoft.com/office/drawing/2014/main" id="{4071D38F-4514-2501-A71E-4063E8D25C58}"/>
+              </a:ext>
+            </a:extLst>
+          </p:cNvPr>
+          <p:cNvPicPr>
+            <a:picLocks noChangeAspect="1"/>
+          </p:cNvPicPr>
+          <p:nvPr/>
+        </p:nvPicPr>
+        <p:blipFill>
+          <a:blip r:embed="rId6">
+            <a:extLst>
+              <a:ext uri="{28A0092B-C50C-407E-A947-70E740481C1C}">
+                <a14:useLocalDpi xmlns:a14="http://schemas.microsoft.com/office/drawing/2010/main" val="0"/>
+              </a:ext>
+            </a:extLst>
+          </a:blip>
+          <a:stretch>
+            <a:fillRect/>
+          </a:stretch>
+        </p:blipFill>
+        <p:spPr>
+          <a:xfrm>
+            <a:off x="11354417" y="0"/>
+            <a:ext cx="837583" cy="837583"/>
+          </a:xfrm>
+          <a:prstGeom prst="rect">
+            <a:avLst/>
+          </a:prstGeom>
+        </p:spPr>
+      </p:pic>
     </p:spTree>
     <p:extLst>
       <p:ext uri="{BB962C8B-B14F-4D97-AF65-F5344CB8AC3E}">
@@ -5528,6 +5652,42 @@
           </a:p>
         </p:txBody>
       </p:sp>
+      <p:pic>
+        <p:nvPicPr>
+          <p:cNvPr id="3" name="Picture 2" descr="A logo with a light bulb and text&#10;&#10;AI-generated content may be incorrect.">
+            <a:extLst>
+              <a:ext uri="{FF2B5EF4-FFF2-40B4-BE49-F238E27FC236}">
+                <a16:creationId xmlns:a16="http://schemas.microsoft.com/office/drawing/2014/main" id="{B0EF75C4-38CF-B684-CD2E-9E607FDF86E2}"/>
+              </a:ext>
+            </a:extLst>
+          </p:cNvPr>
+          <p:cNvPicPr>
+            <a:picLocks noChangeAspect="1"/>
+          </p:cNvPicPr>
+          <p:nvPr/>
+        </p:nvPicPr>
+        <p:blipFill>
+          <a:blip r:embed="rId3">
+            <a:extLst>
+              <a:ext uri="{28A0092B-C50C-407E-A947-70E740481C1C}">
+                <a14:useLocalDpi xmlns:a14="http://schemas.microsoft.com/office/drawing/2010/main" val="0"/>
+              </a:ext>
+            </a:extLst>
+          </a:blip>
+          <a:stretch>
+            <a:fillRect/>
+          </a:stretch>
+        </p:blipFill>
+        <p:spPr>
+          <a:xfrm>
+            <a:off x="11354417" y="0"/>
+            <a:ext cx="837583" cy="837583"/>
+          </a:xfrm>
+          <a:prstGeom prst="rect">
+            <a:avLst/>
+          </a:prstGeom>
+        </p:spPr>
+      </p:pic>
     </p:spTree>
     <p:extLst>
       <p:ext uri="{BB962C8B-B14F-4D97-AF65-F5344CB8AC3E}">
@@ -5592,6 +5752,42 @@
           </a:p>
         </p:txBody>
       </p:sp>
+      <p:pic>
+        <p:nvPicPr>
+          <p:cNvPr id="3" name="Picture 2" descr="A logo with a light bulb and text&#10;&#10;AI-generated content may be incorrect.">
+            <a:extLst>
+              <a:ext uri="{FF2B5EF4-FFF2-40B4-BE49-F238E27FC236}">
+                <a16:creationId xmlns:a16="http://schemas.microsoft.com/office/drawing/2014/main" id="{75E0B5E4-75C9-5EE6-4F84-3BA9D2CC166F}"/>
+              </a:ext>
+            </a:extLst>
+          </p:cNvPr>
+          <p:cNvPicPr>
+            <a:picLocks noChangeAspect="1"/>
+          </p:cNvPicPr>
+          <p:nvPr/>
+        </p:nvPicPr>
+        <p:blipFill>
+          <a:blip r:embed="rId3">
+            <a:extLst>
+              <a:ext uri="{28A0092B-C50C-407E-A947-70E740481C1C}">
+                <a14:useLocalDpi xmlns:a14="http://schemas.microsoft.com/office/drawing/2010/main" val="0"/>
+              </a:ext>
+            </a:extLst>
+          </a:blip>
+          <a:stretch>
+            <a:fillRect/>
+          </a:stretch>
+        </p:blipFill>
+        <p:spPr>
+          <a:xfrm>
+            <a:off x="11354417" y="0"/>
+            <a:ext cx="837583" cy="837583"/>
+          </a:xfrm>
+          <a:prstGeom prst="rect">
+            <a:avLst/>
+          </a:prstGeom>
+        </p:spPr>
+      </p:pic>
     </p:spTree>
     <p:extLst>
       <p:ext uri="{BB962C8B-B14F-4D97-AF65-F5344CB8AC3E}">
@@ -5656,6 +5852,42 @@
           </a:p>
         </p:txBody>
       </p:sp>
+      <p:pic>
+        <p:nvPicPr>
+          <p:cNvPr id="3" name="Picture 2" descr="A logo with a light bulb and text&#10;&#10;AI-generated content may be incorrect.">
+            <a:extLst>
+              <a:ext uri="{FF2B5EF4-FFF2-40B4-BE49-F238E27FC236}">
+                <a16:creationId xmlns:a16="http://schemas.microsoft.com/office/drawing/2014/main" id="{9AF740B4-CFF1-4ACB-0272-82E2BC257637}"/>
+              </a:ext>
+            </a:extLst>
+          </p:cNvPr>
+          <p:cNvPicPr>
+            <a:picLocks noChangeAspect="1"/>
+          </p:cNvPicPr>
+          <p:nvPr/>
+        </p:nvPicPr>
+        <p:blipFill>
+          <a:blip r:embed="rId3">
+            <a:extLst>
+              <a:ext uri="{28A0092B-C50C-407E-A947-70E740481C1C}">
+                <a14:useLocalDpi xmlns:a14="http://schemas.microsoft.com/office/drawing/2010/main" val="0"/>
+              </a:ext>
+            </a:extLst>
+          </a:blip>
+          <a:stretch>
+            <a:fillRect/>
+          </a:stretch>
+        </p:blipFill>
+        <p:spPr>
+          <a:xfrm>
+            <a:off x="11354417" y="0"/>
+            <a:ext cx="837583" cy="837583"/>
+          </a:xfrm>
+          <a:prstGeom prst="rect">
+            <a:avLst/>
+          </a:prstGeom>
+        </p:spPr>
+      </p:pic>
     </p:spTree>
     <p:extLst>
       <p:ext uri="{BB962C8B-B14F-4D97-AF65-F5344CB8AC3E}">
@@ -5886,6 +6118,42 @@
           </a:p>
         </p:txBody>
       </p:sp>
+      <p:pic>
+        <p:nvPicPr>
+          <p:cNvPr id="4" name="Picture 3" descr="A logo with a light bulb and text&#10;&#10;AI-generated content may be incorrect.">
+            <a:extLst>
+              <a:ext uri="{FF2B5EF4-FFF2-40B4-BE49-F238E27FC236}">
+                <a16:creationId xmlns:a16="http://schemas.microsoft.com/office/drawing/2014/main" id="{C2D3A9C6-7014-BCBB-5C4F-02FE8B87A955}"/>
+              </a:ext>
+            </a:extLst>
+          </p:cNvPr>
+          <p:cNvPicPr>
+            <a:picLocks noChangeAspect="1"/>
+          </p:cNvPicPr>
+          <p:nvPr/>
+        </p:nvPicPr>
+        <p:blipFill>
+          <a:blip r:embed="rId3">
+            <a:extLst>
+              <a:ext uri="{28A0092B-C50C-407E-A947-70E740481C1C}">
+                <a14:useLocalDpi xmlns:a14="http://schemas.microsoft.com/office/drawing/2010/main" val="0"/>
+              </a:ext>
+            </a:extLst>
+          </a:blip>
+          <a:stretch>
+            <a:fillRect/>
+          </a:stretch>
+        </p:blipFill>
+        <p:spPr>
+          <a:xfrm>
+            <a:off x="11354417" y="0"/>
+            <a:ext cx="837583" cy="837583"/>
+          </a:xfrm>
+          <a:prstGeom prst="rect">
+            <a:avLst/>
+          </a:prstGeom>
+        </p:spPr>
+      </p:pic>
     </p:spTree>
     <p:extLst>
       <p:ext uri="{BB962C8B-B14F-4D97-AF65-F5344CB8AC3E}">
@@ -6169,6 +6437,42 @@
           </a:p>
         </p:txBody>
       </p:sp>
+      <p:pic>
+        <p:nvPicPr>
+          <p:cNvPr id="4" name="Picture 3" descr="A logo with a light bulb and text&#10;&#10;AI-generated content may be incorrect.">
+            <a:extLst>
+              <a:ext uri="{FF2B5EF4-FFF2-40B4-BE49-F238E27FC236}">
+                <a16:creationId xmlns:a16="http://schemas.microsoft.com/office/drawing/2014/main" id="{18E6143B-91CD-41A6-08DE-5339F4035925}"/>
+              </a:ext>
+            </a:extLst>
+          </p:cNvPr>
+          <p:cNvPicPr>
+            <a:picLocks noChangeAspect="1"/>
+          </p:cNvPicPr>
+          <p:nvPr/>
+        </p:nvPicPr>
+        <p:blipFill>
+          <a:blip r:embed="rId6">
+            <a:extLst>
+              <a:ext uri="{28A0092B-C50C-407E-A947-70E740481C1C}">
+                <a14:useLocalDpi xmlns:a14="http://schemas.microsoft.com/office/drawing/2010/main" val="0"/>
+              </a:ext>
+            </a:extLst>
+          </a:blip>
+          <a:stretch>
+            <a:fillRect/>
+          </a:stretch>
+        </p:blipFill>
+        <p:spPr>
+          <a:xfrm>
+            <a:off x="11354417" y="0"/>
+            <a:ext cx="837583" cy="837583"/>
+          </a:xfrm>
+          <a:prstGeom prst="rect">
+            <a:avLst/>
+          </a:prstGeom>
+        </p:spPr>
+      </p:pic>
     </p:spTree>
     <p:extLst>
       <p:ext uri="{BB962C8B-B14F-4D97-AF65-F5344CB8AC3E}">
@@ -6396,6 +6700,42 @@
           <a:xfrm>
             <a:off x="156541" y="4678561"/>
             <a:ext cx="8074514" cy="2487552"/>
+          </a:xfrm>
+          <a:prstGeom prst="rect">
+            <a:avLst/>
+          </a:prstGeom>
+        </p:spPr>
+      </p:pic>
+      <p:pic>
+        <p:nvPicPr>
+          <p:cNvPr id="3" name="Picture 2" descr="A logo with a light bulb and text&#10;&#10;AI-generated content may be incorrect.">
+            <a:extLst>
+              <a:ext uri="{FF2B5EF4-FFF2-40B4-BE49-F238E27FC236}">
+                <a16:creationId xmlns:a16="http://schemas.microsoft.com/office/drawing/2014/main" id="{65CD8835-198C-C063-6032-B138E179B376}"/>
+              </a:ext>
+            </a:extLst>
+          </p:cNvPr>
+          <p:cNvPicPr>
+            <a:picLocks noChangeAspect="1"/>
+          </p:cNvPicPr>
+          <p:nvPr/>
+        </p:nvPicPr>
+        <p:blipFill>
+          <a:blip r:embed="rId4">
+            <a:extLst>
+              <a:ext uri="{28A0092B-C50C-407E-A947-70E740481C1C}">
+                <a14:useLocalDpi xmlns:a14="http://schemas.microsoft.com/office/drawing/2010/main" val="0"/>
+              </a:ext>
+            </a:extLst>
+          </a:blip>
+          <a:stretch>
+            <a:fillRect/>
+          </a:stretch>
+        </p:blipFill>
+        <p:spPr>
+          <a:xfrm>
+            <a:off x="11354417" y="0"/>
+            <a:ext cx="837583" cy="837583"/>
           </a:xfrm>
           <a:prstGeom prst="rect">
             <a:avLst/>
@@ -7431,6 +7771,42 @@
           </a:graphicData>
         </a:graphic>
       </p:graphicFrame>
+      <p:pic>
+        <p:nvPicPr>
+          <p:cNvPr id="5" name="Picture 4" descr="A logo with a light bulb and text&#10;&#10;AI-generated content may be incorrect.">
+            <a:extLst>
+              <a:ext uri="{FF2B5EF4-FFF2-40B4-BE49-F238E27FC236}">
+                <a16:creationId xmlns:a16="http://schemas.microsoft.com/office/drawing/2014/main" id="{1533204A-1E2B-A761-CF90-1CB784E3803D}"/>
+              </a:ext>
+            </a:extLst>
+          </p:cNvPr>
+          <p:cNvPicPr>
+            <a:picLocks noChangeAspect="1"/>
+          </p:cNvPicPr>
+          <p:nvPr/>
+        </p:nvPicPr>
+        <p:blipFill>
+          <a:blip r:embed="rId2">
+            <a:extLst>
+              <a:ext uri="{28A0092B-C50C-407E-A947-70E740481C1C}">
+                <a14:useLocalDpi xmlns:a14="http://schemas.microsoft.com/office/drawing/2010/main" val="0"/>
+              </a:ext>
+            </a:extLst>
+          </a:blip>
+          <a:stretch>
+            <a:fillRect/>
+          </a:stretch>
+        </p:blipFill>
+        <p:spPr>
+          <a:xfrm>
+            <a:off x="11354417" y="0"/>
+            <a:ext cx="837583" cy="837583"/>
+          </a:xfrm>
+          <a:prstGeom prst="rect">
+            <a:avLst/>
+          </a:prstGeom>
+        </p:spPr>
+      </p:pic>
     </p:spTree>
     <p:extLst>
       <p:ext uri="{BB962C8B-B14F-4D97-AF65-F5344CB8AC3E}">
@@ -7915,6 +8291,42 @@
           </a:p>
         </p:txBody>
       </p:sp>
+      <p:pic>
+        <p:nvPicPr>
+          <p:cNvPr id="4" name="Picture 3" descr="A logo with a light bulb and text&#10;&#10;AI-generated content may be incorrect.">
+            <a:extLst>
+              <a:ext uri="{FF2B5EF4-FFF2-40B4-BE49-F238E27FC236}">
+                <a16:creationId xmlns:a16="http://schemas.microsoft.com/office/drawing/2014/main" id="{C19250EB-AB88-B1C6-7BE3-3E1C8F0390F6}"/>
+              </a:ext>
+            </a:extLst>
+          </p:cNvPr>
+          <p:cNvPicPr>
+            <a:picLocks noChangeAspect="1"/>
+          </p:cNvPicPr>
+          <p:nvPr/>
+        </p:nvPicPr>
+        <p:blipFill>
+          <a:blip r:embed="rId2">
+            <a:extLst>
+              <a:ext uri="{28A0092B-C50C-407E-A947-70E740481C1C}">
+                <a14:useLocalDpi xmlns:a14="http://schemas.microsoft.com/office/drawing/2010/main" val="0"/>
+              </a:ext>
+            </a:extLst>
+          </a:blip>
+          <a:stretch>
+            <a:fillRect/>
+          </a:stretch>
+        </p:blipFill>
+        <p:spPr>
+          <a:xfrm>
+            <a:off x="11354417" y="0"/>
+            <a:ext cx="837583" cy="837583"/>
+          </a:xfrm>
+          <a:prstGeom prst="rect">
+            <a:avLst/>
+          </a:prstGeom>
+        </p:spPr>
+      </p:pic>
     </p:spTree>
     <p:extLst>
       <p:ext uri="{BB962C8B-B14F-4D97-AF65-F5344CB8AC3E}">
@@ -8439,6 +8851,42 @@
           </a:graphicData>
         </a:graphic>
       </p:graphicFrame>
+      <p:pic>
+        <p:nvPicPr>
+          <p:cNvPr id="4" name="Picture 3" descr="A logo with a light bulb and text&#10;&#10;AI-generated content may be incorrect.">
+            <a:extLst>
+              <a:ext uri="{FF2B5EF4-FFF2-40B4-BE49-F238E27FC236}">
+                <a16:creationId xmlns:a16="http://schemas.microsoft.com/office/drawing/2014/main" id="{1F15CE3F-E8DF-6032-BBCF-19926C2BF22D}"/>
+              </a:ext>
+            </a:extLst>
+          </p:cNvPr>
+          <p:cNvPicPr>
+            <a:picLocks noChangeAspect="1"/>
+          </p:cNvPicPr>
+          <p:nvPr/>
+        </p:nvPicPr>
+        <p:blipFill>
+          <a:blip r:embed="rId3">
+            <a:extLst>
+              <a:ext uri="{28A0092B-C50C-407E-A947-70E740481C1C}">
+                <a14:useLocalDpi xmlns:a14="http://schemas.microsoft.com/office/drawing/2010/main" val="0"/>
+              </a:ext>
+            </a:extLst>
+          </a:blip>
+          <a:stretch>
+            <a:fillRect/>
+          </a:stretch>
+        </p:blipFill>
+        <p:spPr>
+          <a:xfrm>
+            <a:off x="11354417" y="0"/>
+            <a:ext cx="837583" cy="837583"/>
+          </a:xfrm>
+          <a:prstGeom prst="rect">
+            <a:avLst/>
+          </a:prstGeom>
+        </p:spPr>
+      </p:pic>
     </p:spTree>
     <p:extLst>
       <p:ext uri="{BB962C8B-B14F-4D97-AF65-F5344CB8AC3E}">
@@ -8574,6 +9022,42 @@
           </a:p>
         </p:txBody>
       </p:sp>
+      <p:pic>
+        <p:nvPicPr>
+          <p:cNvPr id="3" name="Picture 2" descr="A logo with a light bulb and text&#10;&#10;AI-generated content may be incorrect.">
+            <a:extLst>
+              <a:ext uri="{FF2B5EF4-FFF2-40B4-BE49-F238E27FC236}">
+                <a16:creationId xmlns:a16="http://schemas.microsoft.com/office/drawing/2014/main" id="{AD4499B7-0923-C343-A39C-E60EFB19352E}"/>
+              </a:ext>
+            </a:extLst>
+          </p:cNvPr>
+          <p:cNvPicPr>
+            <a:picLocks noChangeAspect="1"/>
+          </p:cNvPicPr>
+          <p:nvPr/>
+        </p:nvPicPr>
+        <p:blipFill>
+          <a:blip r:embed="rId4">
+            <a:extLst>
+              <a:ext uri="{28A0092B-C50C-407E-A947-70E740481C1C}">
+                <a14:useLocalDpi xmlns:a14="http://schemas.microsoft.com/office/drawing/2010/main" val="0"/>
+              </a:ext>
+            </a:extLst>
+          </a:blip>
+          <a:stretch>
+            <a:fillRect/>
+          </a:stretch>
+        </p:blipFill>
+        <p:spPr>
+          <a:xfrm>
+            <a:off x="11354417" y="0"/>
+            <a:ext cx="837583" cy="837583"/>
+          </a:xfrm>
+          <a:prstGeom prst="rect">
+            <a:avLst/>
+          </a:prstGeom>
+        </p:spPr>
+      </p:pic>
     </p:spTree>
     <p:extLst>
       <p:ext uri="{BB962C8B-B14F-4D97-AF65-F5344CB8AC3E}">
@@ -8786,6 +9270,42 @@
           <a:xfrm>
             <a:off x="7934960" y="2552764"/>
             <a:ext cx="1752472" cy="1752472"/>
+          </a:xfrm>
+          <a:prstGeom prst="rect">
+            <a:avLst/>
+          </a:prstGeom>
+        </p:spPr>
+      </p:pic>
+      <p:pic>
+        <p:nvPicPr>
+          <p:cNvPr id="3" name="Picture 2" descr="A logo with a light bulb and text&#10;&#10;AI-generated content may be incorrect.">
+            <a:extLst>
+              <a:ext uri="{FF2B5EF4-FFF2-40B4-BE49-F238E27FC236}">
+                <a16:creationId xmlns:a16="http://schemas.microsoft.com/office/drawing/2014/main" id="{56081F13-F316-7C6C-F476-CF44C7811B1F}"/>
+              </a:ext>
+            </a:extLst>
+          </p:cNvPr>
+          <p:cNvPicPr>
+            <a:picLocks noChangeAspect="1"/>
+          </p:cNvPicPr>
+          <p:nvPr/>
+        </p:nvPicPr>
+        <p:blipFill>
+          <a:blip r:embed="rId5">
+            <a:extLst>
+              <a:ext uri="{28A0092B-C50C-407E-A947-70E740481C1C}">
+                <a14:useLocalDpi xmlns:a14="http://schemas.microsoft.com/office/drawing/2010/main" val="0"/>
+              </a:ext>
+            </a:extLst>
+          </a:blip>
+          <a:stretch>
+            <a:fillRect/>
+          </a:stretch>
+        </p:blipFill>
+        <p:spPr>
+          <a:xfrm>
+            <a:off x="11354417" y="0"/>
+            <a:ext cx="837583" cy="837583"/>
           </a:xfrm>
           <a:prstGeom prst="rect">
             <a:avLst/>

</xml_diff>

<commit_message>
Fixed formatting issues in the SRS document and made slight adjustments to task 3 slides in the ppt
</commit_message>
<xml_diff>
--- a/ASGMNT3/JHET_Innovations-Assignment3-SRS-Presentation.pptx
+++ b/ASGMNT3/JHET_Innovations-Assignment3-SRS-Presentation.pptx
@@ -5357,8 +5357,8 @@
         </p:nvSpPr>
         <p:spPr>
           <a:xfrm>
-            <a:off x="1036320" y="1737360"/>
-            <a:ext cx="6267450" cy="3699474"/>
+            <a:off x="1097280" y="1737360"/>
+            <a:ext cx="6267450" cy="3083921"/>
           </a:xfrm>
           <a:prstGeom prst="rect">
             <a:avLst/>
@@ -5393,7 +5393,7 @@
             </a:pPr>
             <a:r>
               <a:rPr lang="en-US" sz="2000" dirty="0"/>
-              <a:t>Security</a:t>
+              <a:t>Administrative tools</a:t>
             </a:r>
           </a:p>
           <a:p>
@@ -5406,7 +5406,7 @@
             </a:pPr>
             <a:r>
               <a:rPr lang="en-US" sz="2000" dirty="0"/>
-              <a:t>Search</a:t>
+              <a:t>System requirements</a:t>
             </a:r>
           </a:p>
           <a:p>
@@ -5432,30 +5432,17 @@
             </a:pPr>
             <a:r>
               <a:rPr lang="en-US" sz="2000" dirty="0"/>
-              <a:t>Administrative tools</a:t>
-            </a:r>
-          </a:p>
-          <a:p>
-            <a:pPr marL="285750" indent="-285750">
-              <a:lnSpc>
-                <a:spcPct val="200000"/>
-              </a:lnSpc>
-              <a:buFont typeface="Arial" panose="020B0604020202020204" pitchFamily="34" charset="0"/>
-              <a:buChar char="•"/>
-            </a:pPr>
-            <a:r>
-              <a:rPr lang="en-US" sz="2000" dirty="0"/>
-              <a:t>System requirements</a:t>
+              <a:t>Security</a:t>
             </a:r>
           </a:p>
         </p:txBody>
       </p:sp>
       <p:pic>
         <p:nvPicPr>
-          <p:cNvPr id="8" name="Picture 7" descr="A blue magnifying glass&#10;&#10;AI-generated content may be incorrect.">
+          <p:cNvPr id="12" name="Picture 11" descr="A blue lock and shield with check mark&#10;&#10;AI-generated content may be incorrect.">
             <a:extLst>
               <a:ext uri="{FF2B5EF4-FFF2-40B4-BE49-F238E27FC236}">
-                <a16:creationId xmlns:a16="http://schemas.microsoft.com/office/drawing/2014/main" id="{19B5C3A0-FC38-1EE1-50E7-A15BAAE73AF5}"/>
+                <a16:creationId xmlns:a16="http://schemas.microsoft.com/office/drawing/2014/main" id="{ECE98841-D245-BA0C-FBCE-5C6E05758561}"/>
               </a:ext>
             </a:extLst>
           </p:cNvPr>
@@ -5478,43 +5465,7 @@
         </p:blipFill>
         <p:spPr>
           <a:xfrm>
-            <a:off x="6427534" y="2710861"/>
-            <a:ext cx="1752472" cy="1752472"/>
-          </a:xfrm>
-          <a:prstGeom prst="rect">
-            <a:avLst/>
-          </a:prstGeom>
-        </p:spPr>
-      </p:pic>
-      <p:pic>
-        <p:nvPicPr>
-          <p:cNvPr id="12" name="Picture 11" descr="A blue lock and shield with check mark&#10;&#10;AI-generated content may be incorrect.">
-            <a:extLst>
-              <a:ext uri="{FF2B5EF4-FFF2-40B4-BE49-F238E27FC236}">
-                <a16:creationId xmlns:a16="http://schemas.microsoft.com/office/drawing/2014/main" id="{ECE98841-D245-BA0C-FBCE-5C6E05758561}"/>
-              </a:ext>
-            </a:extLst>
-          </p:cNvPr>
-          <p:cNvPicPr>
-            <a:picLocks noChangeAspect="1"/>
-          </p:cNvPicPr>
-          <p:nvPr/>
-        </p:nvPicPr>
-        <p:blipFill>
-          <a:blip r:embed="rId4">
-            <a:extLst>
-              <a:ext uri="{28A0092B-C50C-407E-A947-70E740481C1C}">
-                <a14:useLocalDpi xmlns:a14="http://schemas.microsoft.com/office/drawing/2010/main" val="0"/>
-              </a:ext>
-            </a:extLst>
-          </a:blip>
-          <a:stretch>
-            <a:fillRect/>
-          </a:stretch>
-        </p:blipFill>
-        <p:spPr>
-          <a:xfrm>
-            <a:off x="4170045" y="2552764"/>
+            <a:off x="5396169" y="2552764"/>
             <a:ext cx="1752472" cy="1752472"/>
           </a:xfrm>
           <a:prstGeom prst="rect">
@@ -5537,14 +5488,14 @@
           <p:nvPr/>
         </p:nvPicPr>
         <p:blipFill>
-          <a:blip r:embed="rId5"/>
+          <a:blip r:embed="rId4"/>
           <a:stretch>
             <a:fillRect/>
           </a:stretch>
         </p:blipFill>
         <p:spPr>
           <a:xfrm>
-            <a:off x="8685023" y="2552764"/>
+            <a:off x="7619621" y="2552764"/>
             <a:ext cx="1752472" cy="1752472"/>
           </a:xfrm>
           <a:prstGeom prst="rect">
@@ -5567,7 +5518,7 @@
           <p:nvPr/>
         </p:nvPicPr>
         <p:blipFill>
-          <a:blip r:embed="rId6">
+          <a:blip r:embed="rId5">
             <a:extLst>
               <a:ext uri="{28A0092B-C50C-407E-A947-70E740481C1C}">
                 <a14:useLocalDpi xmlns:a14="http://schemas.microsoft.com/office/drawing/2010/main" val="0"/>
@@ -9137,7 +9088,7 @@
         <p:spPr>
           <a:xfrm>
             <a:off x="1097280" y="1737360"/>
-            <a:ext cx="3220720" cy="3083921"/>
+            <a:ext cx="3220720" cy="3699474"/>
           </a:xfrm>
           <a:prstGeom prst="rect">
             <a:avLst/>
@@ -9173,6 +9124,19 @@
             <a:r>
               <a:rPr lang="en-US" sz="2000" dirty="0"/>
               <a:t>Communication</a:t>
+            </a:r>
+          </a:p>
+          <a:p>
+            <a:pPr marL="285750" indent="-285750">
+              <a:lnSpc>
+                <a:spcPct val="200000"/>
+              </a:lnSpc>
+              <a:buFont typeface="Arial" panose="020B0604020202020204" pitchFamily="34" charset="0"/>
+              <a:buChar char="•"/>
+            </a:pPr>
+            <a:r>
+              <a:rPr lang="en-US" sz="2000" dirty="0"/>
+              <a:t>Search</a:t>
             </a:r>
           </a:p>
           <a:p>
@@ -9238,7 +9202,7 @@
         </p:blipFill>
         <p:spPr>
           <a:xfrm>
-            <a:off x="5250244" y="2552764"/>
+            <a:off x="4318000" y="2552764"/>
             <a:ext cx="1752472" cy="1752472"/>
           </a:xfrm>
           <a:prstGeom prst="rect">
@@ -9268,7 +9232,7 @@
         </p:blipFill>
         <p:spPr>
           <a:xfrm>
-            <a:off x="7934960" y="2552764"/>
+            <a:off x="8815804" y="2552764"/>
             <a:ext cx="1752472" cy="1752472"/>
           </a:xfrm>
           <a:prstGeom prst="rect">
@@ -9306,6 +9270,42 @@
           <a:xfrm>
             <a:off x="11354417" y="0"/>
             <a:ext cx="837583" cy="837583"/>
+          </a:xfrm>
+          <a:prstGeom prst="rect">
+            <a:avLst/>
+          </a:prstGeom>
+        </p:spPr>
+      </p:pic>
+      <p:pic>
+        <p:nvPicPr>
+          <p:cNvPr id="8" name="Picture 7" descr="A blue magnifying glass&#10;&#10;AI-generated content may be incorrect.">
+            <a:extLst>
+              <a:ext uri="{FF2B5EF4-FFF2-40B4-BE49-F238E27FC236}">
+                <a16:creationId xmlns:a16="http://schemas.microsoft.com/office/drawing/2014/main" id="{19B5C3A0-FC38-1EE1-50E7-A15BAAE73AF5}"/>
+              </a:ext>
+            </a:extLst>
+          </p:cNvPr>
+          <p:cNvPicPr>
+            <a:picLocks noChangeAspect="1"/>
+          </p:cNvPicPr>
+          <p:nvPr/>
+        </p:nvPicPr>
+        <p:blipFill>
+          <a:blip r:embed="rId6">
+            <a:extLst>
+              <a:ext uri="{28A0092B-C50C-407E-A947-70E740481C1C}">
+                <a14:useLocalDpi xmlns:a14="http://schemas.microsoft.com/office/drawing/2010/main" val="0"/>
+              </a:ext>
+            </a:extLst>
+          </a:blip>
+          <a:stretch>
+            <a:fillRect/>
+          </a:stretch>
+        </p:blipFill>
+        <p:spPr>
+          <a:xfrm>
+            <a:off x="6566902" y="2591318"/>
+            <a:ext cx="1752472" cy="1752472"/>
           </a:xfrm>
           <a:prstGeom prst="rect">
             <a:avLst/>

</xml_diff>

<commit_message>
started filling out contribution summary, reordered powerpoint for clarity
</commit_message>
<xml_diff>
--- a/ASGMNT3/JHET_Innovations-Assignment3-SRS-Presentation.pptx
+++ b/ASGMNT3/JHET_Innovations-Assignment3-SRS-Presentation.pptx
@@ -14,11 +14,11 @@
     <p:sldId id="258" r:id="rId5"/>
     <p:sldId id="265" r:id="rId6"/>
     <p:sldId id="266" r:id="rId7"/>
-    <p:sldId id="259" r:id="rId8"/>
-    <p:sldId id="269" r:id="rId9"/>
-    <p:sldId id="260" r:id="rId10"/>
-    <p:sldId id="267" r:id="rId11"/>
-    <p:sldId id="261" r:id="rId12"/>
+    <p:sldId id="260" r:id="rId8"/>
+    <p:sldId id="267" r:id="rId9"/>
+    <p:sldId id="270" r:id="rId10"/>
+    <p:sldId id="259" r:id="rId11"/>
+    <p:sldId id="269" r:id="rId12"/>
     <p:sldId id="262" r:id="rId13"/>
     <p:sldId id="263" r:id="rId14"/>
   </p:sldIdLst>
@@ -668,6 +668,339 @@
   <p:cSld>
     <p:spTree>
       <p:nvGrpSpPr>
+        <p:cNvPr id="1" name="">
+          <a:extLst>
+            <a:ext uri="{FF2B5EF4-FFF2-40B4-BE49-F238E27FC236}">
+              <a16:creationId xmlns:a16="http://schemas.microsoft.com/office/drawing/2014/main" id="{1D7245B7-3D8A-8032-03F4-33B854321006}"/>
+            </a:ext>
+          </a:extLst>
+        </p:cNvPr>
+        <p:cNvGrpSpPr/>
+        <p:nvPr/>
+      </p:nvGrpSpPr>
+      <p:grpSpPr>
+        <a:xfrm>
+          <a:off x="0" y="0"/>
+          <a:ext cx="0" cy="0"/>
+          <a:chOff x="0" y="0"/>
+          <a:chExt cx="0" cy="0"/>
+        </a:xfrm>
+      </p:grpSpPr>
+      <p:sp>
+        <p:nvSpPr>
+          <p:cNvPr id="2" name="Slide Image Placeholder 1">
+            <a:extLst>
+              <a:ext uri="{FF2B5EF4-FFF2-40B4-BE49-F238E27FC236}">
+                <a16:creationId xmlns:a16="http://schemas.microsoft.com/office/drawing/2014/main" id="{25C6BC70-9552-09E2-0132-76BA9EA604B0}"/>
+              </a:ext>
+            </a:extLst>
+          </p:cNvPr>
+          <p:cNvSpPr>
+            <a:spLocks noGrp="1" noRot="1" noChangeAspect="1"/>
+          </p:cNvSpPr>
+          <p:nvPr>
+            <p:ph type="sldImg"/>
+          </p:nvPr>
+        </p:nvSpPr>
+        <p:spPr/>
+      </p:sp>
+      <p:sp>
+        <p:nvSpPr>
+          <p:cNvPr id="3" name="Notes Placeholder 2">
+            <a:extLst>
+              <a:ext uri="{FF2B5EF4-FFF2-40B4-BE49-F238E27FC236}">
+                <a16:creationId xmlns:a16="http://schemas.microsoft.com/office/drawing/2014/main" id="{5DE4CDBF-D4E2-1072-D835-5D8F0C40A857}"/>
+              </a:ext>
+            </a:extLst>
+          </p:cNvPr>
+          <p:cNvSpPr>
+            <a:spLocks noGrp="1"/>
+          </p:cNvSpPr>
+          <p:nvPr>
+            <p:ph type="body" idx="1"/>
+          </p:nvPr>
+        </p:nvSpPr>
+        <p:spPr/>
+        <p:txBody>
+          <a:bodyPr/>
+          <a:lstStyle/>
+          <a:p>
+            <a:r>
+              <a:rPr lang="en-US" dirty="0"/>
+              <a:t>Sketch of UI, show what we want it to look like</a:t>
+            </a:r>
+          </a:p>
+        </p:txBody>
+      </p:sp>
+      <p:sp>
+        <p:nvSpPr>
+          <p:cNvPr id="4" name="Slide Number Placeholder 3">
+            <a:extLst>
+              <a:ext uri="{FF2B5EF4-FFF2-40B4-BE49-F238E27FC236}">
+                <a16:creationId xmlns:a16="http://schemas.microsoft.com/office/drawing/2014/main" id="{CCA56F95-4142-614B-0AB3-D322E87CB4D7}"/>
+              </a:ext>
+            </a:extLst>
+          </p:cNvPr>
+          <p:cNvSpPr>
+            <a:spLocks noGrp="1"/>
+          </p:cNvSpPr>
+          <p:nvPr>
+            <p:ph type="sldNum" sz="quarter" idx="5"/>
+          </p:nvPr>
+        </p:nvSpPr>
+        <p:spPr/>
+        <p:txBody>
+          <a:bodyPr/>
+          <a:lstStyle/>
+          <a:p>
+            <a:fld id="{269ED01E-914A-41E4-88A0-C6BC45F53370}" type="slidenum">
+              <a:rPr lang="en-US" smtClean="0"/>
+              <a:t>7</a:t>
+            </a:fld>
+            <a:endParaRPr lang="en-US"/>
+          </a:p>
+        </p:txBody>
+      </p:sp>
+    </p:spTree>
+    <p:extLst>
+      <p:ext uri="{BB962C8B-B14F-4D97-AF65-F5344CB8AC3E}">
+        <p14:creationId xmlns:p14="http://schemas.microsoft.com/office/powerpoint/2010/main" val="747901256"/>
+      </p:ext>
+    </p:extLst>
+  </p:cSld>
+  <p:clrMapOvr>
+    <a:masterClrMapping/>
+  </p:clrMapOvr>
+</p:notes>
+</file>
+
+<file path=ppt/notesSlides/notesSlide4.xml><?xml version="1.0" encoding="utf-8"?>
+<p:notes xmlns:a="http://schemas.openxmlformats.org/drawingml/2006/main" xmlns:r="http://schemas.openxmlformats.org/officeDocument/2006/relationships" xmlns:p="http://schemas.openxmlformats.org/presentationml/2006/main">
+  <p:cSld>
+    <p:spTree>
+      <p:nvGrpSpPr>
+        <p:cNvPr id="1" name="">
+          <a:extLst>
+            <a:ext uri="{FF2B5EF4-FFF2-40B4-BE49-F238E27FC236}">
+              <a16:creationId xmlns:a16="http://schemas.microsoft.com/office/drawing/2014/main" id="{377AACC5-A7FB-200E-5EA1-6A75548EDA53}"/>
+            </a:ext>
+          </a:extLst>
+        </p:cNvPr>
+        <p:cNvGrpSpPr/>
+        <p:nvPr/>
+      </p:nvGrpSpPr>
+      <p:grpSpPr>
+        <a:xfrm>
+          <a:off x="0" y="0"/>
+          <a:ext cx="0" cy="0"/>
+          <a:chOff x="0" y="0"/>
+          <a:chExt cx="0" cy="0"/>
+        </a:xfrm>
+      </p:grpSpPr>
+      <p:sp>
+        <p:nvSpPr>
+          <p:cNvPr id="2" name="Slide Image Placeholder 1">
+            <a:extLst>
+              <a:ext uri="{FF2B5EF4-FFF2-40B4-BE49-F238E27FC236}">
+                <a16:creationId xmlns:a16="http://schemas.microsoft.com/office/drawing/2014/main" id="{310A09DC-800F-2354-F496-FE621C156D8A}"/>
+              </a:ext>
+            </a:extLst>
+          </p:cNvPr>
+          <p:cNvSpPr>
+            <a:spLocks noGrp="1" noRot="1" noChangeAspect="1"/>
+          </p:cNvSpPr>
+          <p:nvPr>
+            <p:ph type="sldImg"/>
+          </p:nvPr>
+        </p:nvSpPr>
+        <p:spPr/>
+      </p:sp>
+      <p:sp>
+        <p:nvSpPr>
+          <p:cNvPr id="3" name="Notes Placeholder 2">
+            <a:extLst>
+              <a:ext uri="{FF2B5EF4-FFF2-40B4-BE49-F238E27FC236}">
+                <a16:creationId xmlns:a16="http://schemas.microsoft.com/office/drawing/2014/main" id="{58DED33A-1E02-D300-3CE2-EA66F3797700}"/>
+              </a:ext>
+            </a:extLst>
+          </p:cNvPr>
+          <p:cNvSpPr>
+            <a:spLocks noGrp="1"/>
+          </p:cNvSpPr>
+          <p:nvPr>
+            <p:ph type="body" idx="1"/>
+          </p:nvPr>
+        </p:nvSpPr>
+        <p:spPr/>
+        <p:txBody>
+          <a:bodyPr/>
+          <a:lstStyle/>
+          <a:p>
+            <a:r>
+              <a:rPr lang="en-US" dirty="0"/>
+              <a:t>Sketch of UI, show what we want it to look like</a:t>
+            </a:r>
+          </a:p>
+        </p:txBody>
+      </p:sp>
+      <p:sp>
+        <p:nvSpPr>
+          <p:cNvPr id="4" name="Slide Number Placeholder 3">
+            <a:extLst>
+              <a:ext uri="{FF2B5EF4-FFF2-40B4-BE49-F238E27FC236}">
+                <a16:creationId xmlns:a16="http://schemas.microsoft.com/office/drawing/2014/main" id="{30EB9F64-8659-F14D-480E-4259F49B888B}"/>
+              </a:ext>
+            </a:extLst>
+          </p:cNvPr>
+          <p:cNvSpPr>
+            <a:spLocks noGrp="1"/>
+          </p:cNvSpPr>
+          <p:nvPr>
+            <p:ph type="sldNum" sz="quarter" idx="5"/>
+          </p:nvPr>
+        </p:nvSpPr>
+        <p:spPr/>
+        <p:txBody>
+          <a:bodyPr/>
+          <a:lstStyle/>
+          <a:p>
+            <a:fld id="{269ED01E-914A-41E4-88A0-C6BC45F53370}" type="slidenum">
+              <a:rPr lang="en-US" smtClean="0"/>
+              <a:t>8</a:t>
+            </a:fld>
+            <a:endParaRPr lang="en-US"/>
+          </a:p>
+        </p:txBody>
+      </p:sp>
+    </p:spTree>
+    <p:extLst>
+      <p:ext uri="{BB962C8B-B14F-4D97-AF65-F5344CB8AC3E}">
+        <p14:creationId xmlns:p14="http://schemas.microsoft.com/office/powerpoint/2010/main" val="2755344917"/>
+      </p:ext>
+    </p:extLst>
+  </p:cSld>
+  <p:clrMapOvr>
+    <a:masterClrMapping/>
+  </p:clrMapOvr>
+</p:notes>
+</file>
+
+<file path=ppt/notesSlides/notesSlide5.xml><?xml version="1.0" encoding="utf-8"?>
+<p:notes xmlns:a="http://schemas.openxmlformats.org/drawingml/2006/main" xmlns:r="http://schemas.openxmlformats.org/officeDocument/2006/relationships" xmlns:p="http://schemas.openxmlformats.org/presentationml/2006/main">
+  <p:cSld>
+    <p:spTree>
+      <p:nvGrpSpPr>
+        <p:cNvPr id="1" name="">
+          <a:extLst>
+            <a:ext uri="{FF2B5EF4-FFF2-40B4-BE49-F238E27FC236}">
+              <a16:creationId xmlns:a16="http://schemas.microsoft.com/office/drawing/2014/main" id="{98C5076A-1D4F-834C-3AE3-837DA5A18215}"/>
+            </a:ext>
+          </a:extLst>
+        </p:cNvPr>
+        <p:cNvGrpSpPr/>
+        <p:nvPr/>
+      </p:nvGrpSpPr>
+      <p:grpSpPr>
+        <a:xfrm>
+          <a:off x="0" y="0"/>
+          <a:ext cx="0" cy="0"/>
+          <a:chOff x="0" y="0"/>
+          <a:chExt cx="0" cy="0"/>
+        </a:xfrm>
+      </p:grpSpPr>
+      <p:sp>
+        <p:nvSpPr>
+          <p:cNvPr id="2" name="Slide Image Placeholder 1">
+            <a:extLst>
+              <a:ext uri="{FF2B5EF4-FFF2-40B4-BE49-F238E27FC236}">
+                <a16:creationId xmlns:a16="http://schemas.microsoft.com/office/drawing/2014/main" id="{9721C253-4650-B304-9F8B-34BBA090048C}"/>
+              </a:ext>
+            </a:extLst>
+          </p:cNvPr>
+          <p:cNvSpPr>
+            <a:spLocks noGrp="1" noRot="1" noChangeAspect="1"/>
+          </p:cNvSpPr>
+          <p:nvPr>
+            <p:ph type="sldImg"/>
+          </p:nvPr>
+        </p:nvSpPr>
+        <p:spPr/>
+      </p:sp>
+      <p:sp>
+        <p:nvSpPr>
+          <p:cNvPr id="3" name="Notes Placeholder 2">
+            <a:extLst>
+              <a:ext uri="{FF2B5EF4-FFF2-40B4-BE49-F238E27FC236}">
+                <a16:creationId xmlns:a16="http://schemas.microsoft.com/office/drawing/2014/main" id="{08500FF0-5FA4-EDD7-901D-F10189155CB5}"/>
+              </a:ext>
+            </a:extLst>
+          </p:cNvPr>
+          <p:cNvSpPr>
+            <a:spLocks noGrp="1"/>
+          </p:cNvSpPr>
+          <p:nvPr>
+            <p:ph type="body" idx="1"/>
+          </p:nvPr>
+        </p:nvSpPr>
+        <p:spPr/>
+        <p:txBody>
+          <a:bodyPr/>
+          <a:lstStyle/>
+          <a:p>
+            <a:r>
+              <a:rPr lang="en-US" dirty="0"/>
+              <a:t>Sketch of UI, show what we want it to look like</a:t>
+            </a:r>
+          </a:p>
+        </p:txBody>
+      </p:sp>
+      <p:sp>
+        <p:nvSpPr>
+          <p:cNvPr id="4" name="Slide Number Placeholder 3">
+            <a:extLst>
+              <a:ext uri="{FF2B5EF4-FFF2-40B4-BE49-F238E27FC236}">
+                <a16:creationId xmlns:a16="http://schemas.microsoft.com/office/drawing/2014/main" id="{729B7677-C252-BD44-E1D6-738279DB49D7}"/>
+              </a:ext>
+            </a:extLst>
+          </p:cNvPr>
+          <p:cNvSpPr>
+            <a:spLocks noGrp="1"/>
+          </p:cNvSpPr>
+          <p:nvPr>
+            <p:ph type="sldNum" sz="quarter" idx="5"/>
+          </p:nvPr>
+        </p:nvSpPr>
+        <p:spPr/>
+        <p:txBody>
+          <a:bodyPr/>
+          <a:lstStyle/>
+          <a:p>
+            <a:fld id="{269ED01E-914A-41E4-88A0-C6BC45F53370}" type="slidenum">
+              <a:rPr lang="en-US" smtClean="0"/>
+              <a:t>9</a:t>
+            </a:fld>
+            <a:endParaRPr lang="en-US"/>
+          </a:p>
+        </p:txBody>
+      </p:sp>
+    </p:spTree>
+    <p:extLst>
+      <p:ext uri="{BB962C8B-B14F-4D97-AF65-F5344CB8AC3E}">
+        <p14:creationId xmlns:p14="http://schemas.microsoft.com/office/powerpoint/2010/main" val="2230273140"/>
+      </p:ext>
+    </p:extLst>
+  </p:cSld>
+  <p:clrMapOvr>
+    <a:masterClrMapping/>
+  </p:clrMapOvr>
+</p:notes>
+</file>
+
+<file path=ppt/notesSlides/notesSlide6.xml><?xml version="1.0" encoding="utf-8"?>
+<p:notes xmlns:a="http://schemas.openxmlformats.org/drawingml/2006/main" xmlns:r="http://schemas.openxmlformats.org/officeDocument/2006/relationships" xmlns:p="http://schemas.openxmlformats.org/presentationml/2006/main">
+  <p:cSld>
+    <p:spTree>
+      <p:nvGrpSpPr>
         <p:cNvPr id="1" name=""/>
         <p:cNvGrpSpPr/>
         <p:nvPr/>
@@ -731,7 +1064,7 @@
           <a:p>
             <a:fld id="{269ED01E-914A-41E4-88A0-C6BC45F53370}" type="slidenum">
               <a:rPr lang="en-US" smtClean="0"/>
-              <a:t>7</a:t>
+              <a:t>10</a:t>
             </a:fld>
             <a:endParaRPr lang="en-US"/>
           </a:p>
@@ -750,7 +1083,7 @@
 </p:notes>
 </file>
 
-<file path=ppt/notesSlides/notesSlide4.xml><?xml version="1.0" encoding="utf-8"?>
+<file path=ppt/notesSlides/notesSlide7.xml><?xml version="1.0" encoding="utf-8"?>
 <p:notes xmlns:a="http://schemas.openxmlformats.org/drawingml/2006/main" xmlns:r="http://schemas.openxmlformats.org/officeDocument/2006/relationships" xmlns:p="http://schemas.openxmlformats.org/presentationml/2006/main">
   <p:cSld>
     <p:spTree>
@@ -842,7 +1175,7 @@
           <a:p>
             <a:fld id="{269ED01E-914A-41E4-88A0-C6BC45F53370}" type="slidenum">
               <a:rPr lang="en-US" smtClean="0"/>
-              <a:t>8</a:t>
+              <a:t>11</a:t>
             </a:fld>
             <a:endParaRPr lang="en-US"/>
           </a:p>
@@ -852,339 +1185,6 @@
     <p:extLst>
       <p:ext uri="{BB962C8B-B14F-4D97-AF65-F5344CB8AC3E}">
         <p14:creationId xmlns:p14="http://schemas.microsoft.com/office/powerpoint/2010/main" val="88797735"/>
-      </p:ext>
-    </p:extLst>
-  </p:cSld>
-  <p:clrMapOvr>
-    <a:masterClrMapping/>
-  </p:clrMapOvr>
-</p:notes>
-</file>
-
-<file path=ppt/notesSlides/notesSlide5.xml><?xml version="1.0" encoding="utf-8"?>
-<p:notes xmlns:a="http://schemas.openxmlformats.org/drawingml/2006/main" xmlns:r="http://schemas.openxmlformats.org/officeDocument/2006/relationships" xmlns:p="http://schemas.openxmlformats.org/presentationml/2006/main">
-  <p:cSld>
-    <p:spTree>
-      <p:nvGrpSpPr>
-        <p:cNvPr id="1" name="">
-          <a:extLst>
-            <a:ext uri="{FF2B5EF4-FFF2-40B4-BE49-F238E27FC236}">
-              <a16:creationId xmlns:a16="http://schemas.microsoft.com/office/drawing/2014/main" id="{1D7245B7-3D8A-8032-03F4-33B854321006}"/>
-            </a:ext>
-          </a:extLst>
-        </p:cNvPr>
-        <p:cNvGrpSpPr/>
-        <p:nvPr/>
-      </p:nvGrpSpPr>
-      <p:grpSpPr>
-        <a:xfrm>
-          <a:off x="0" y="0"/>
-          <a:ext cx="0" cy="0"/>
-          <a:chOff x="0" y="0"/>
-          <a:chExt cx="0" cy="0"/>
-        </a:xfrm>
-      </p:grpSpPr>
-      <p:sp>
-        <p:nvSpPr>
-          <p:cNvPr id="2" name="Slide Image Placeholder 1">
-            <a:extLst>
-              <a:ext uri="{FF2B5EF4-FFF2-40B4-BE49-F238E27FC236}">
-                <a16:creationId xmlns:a16="http://schemas.microsoft.com/office/drawing/2014/main" id="{25C6BC70-9552-09E2-0132-76BA9EA604B0}"/>
-              </a:ext>
-            </a:extLst>
-          </p:cNvPr>
-          <p:cNvSpPr>
-            <a:spLocks noGrp="1" noRot="1" noChangeAspect="1"/>
-          </p:cNvSpPr>
-          <p:nvPr>
-            <p:ph type="sldImg"/>
-          </p:nvPr>
-        </p:nvSpPr>
-        <p:spPr/>
-      </p:sp>
-      <p:sp>
-        <p:nvSpPr>
-          <p:cNvPr id="3" name="Notes Placeholder 2">
-            <a:extLst>
-              <a:ext uri="{FF2B5EF4-FFF2-40B4-BE49-F238E27FC236}">
-                <a16:creationId xmlns:a16="http://schemas.microsoft.com/office/drawing/2014/main" id="{5DE4CDBF-D4E2-1072-D835-5D8F0C40A857}"/>
-              </a:ext>
-            </a:extLst>
-          </p:cNvPr>
-          <p:cNvSpPr>
-            <a:spLocks noGrp="1"/>
-          </p:cNvSpPr>
-          <p:nvPr>
-            <p:ph type="body" idx="1"/>
-          </p:nvPr>
-        </p:nvSpPr>
-        <p:spPr/>
-        <p:txBody>
-          <a:bodyPr/>
-          <a:lstStyle/>
-          <a:p>
-            <a:r>
-              <a:rPr lang="en-US" dirty="0"/>
-              <a:t>Sketch of UI, show what we want it to look like</a:t>
-            </a:r>
-          </a:p>
-        </p:txBody>
-      </p:sp>
-      <p:sp>
-        <p:nvSpPr>
-          <p:cNvPr id="4" name="Slide Number Placeholder 3">
-            <a:extLst>
-              <a:ext uri="{FF2B5EF4-FFF2-40B4-BE49-F238E27FC236}">
-                <a16:creationId xmlns:a16="http://schemas.microsoft.com/office/drawing/2014/main" id="{CCA56F95-4142-614B-0AB3-D322E87CB4D7}"/>
-              </a:ext>
-            </a:extLst>
-          </p:cNvPr>
-          <p:cNvSpPr>
-            <a:spLocks noGrp="1"/>
-          </p:cNvSpPr>
-          <p:nvPr>
-            <p:ph type="sldNum" sz="quarter" idx="5"/>
-          </p:nvPr>
-        </p:nvSpPr>
-        <p:spPr/>
-        <p:txBody>
-          <a:bodyPr/>
-          <a:lstStyle/>
-          <a:p>
-            <a:fld id="{269ED01E-914A-41E4-88A0-C6BC45F53370}" type="slidenum">
-              <a:rPr lang="en-US" smtClean="0"/>
-              <a:t>9</a:t>
-            </a:fld>
-            <a:endParaRPr lang="en-US"/>
-          </a:p>
-        </p:txBody>
-      </p:sp>
-    </p:spTree>
-    <p:extLst>
-      <p:ext uri="{BB962C8B-B14F-4D97-AF65-F5344CB8AC3E}">
-        <p14:creationId xmlns:p14="http://schemas.microsoft.com/office/powerpoint/2010/main" val="747901256"/>
-      </p:ext>
-    </p:extLst>
-  </p:cSld>
-  <p:clrMapOvr>
-    <a:masterClrMapping/>
-  </p:clrMapOvr>
-</p:notes>
-</file>
-
-<file path=ppt/notesSlides/notesSlide6.xml><?xml version="1.0" encoding="utf-8"?>
-<p:notes xmlns:a="http://schemas.openxmlformats.org/drawingml/2006/main" xmlns:r="http://schemas.openxmlformats.org/officeDocument/2006/relationships" xmlns:p="http://schemas.openxmlformats.org/presentationml/2006/main">
-  <p:cSld>
-    <p:spTree>
-      <p:nvGrpSpPr>
-        <p:cNvPr id="1" name="">
-          <a:extLst>
-            <a:ext uri="{FF2B5EF4-FFF2-40B4-BE49-F238E27FC236}">
-              <a16:creationId xmlns:a16="http://schemas.microsoft.com/office/drawing/2014/main" id="{377AACC5-A7FB-200E-5EA1-6A75548EDA53}"/>
-            </a:ext>
-          </a:extLst>
-        </p:cNvPr>
-        <p:cNvGrpSpPr/>
-        <p:nvPr/>
-      </p:nvGrpSpPr>
-      <p:grpSpPr>
-        <a:xfrm>
-          <a:off x="0" y="0"/>
-          <a:ext cx="0" cy="0"/>
-          <a:chOff x="0" y="0"/>
-          <a:chExt cx="0" cy="0"/>
-        </a:xfrm>
-      </p:grpSpPr>
-      <p:sp>
-        <p:nvSpPr>
-          <p:cNvPr id="2" name="Slide Image Placeholder 1">
-            <a:extLst>
-              <a:ext uri="{FF2B5EF4-FFF2-40B4-BE49-F238E27FC236}">
-                <a16:creationId xmlns:a16="http://schemas.microsoft.com/office/drawing/2014/main" id="{310A09DC-800F-2354-F496-FE621C156D8A}"/>
-              </a:ext>
-            </a:extLst>
-          </p:cNvPr>
-          <p:cNvSpPr>
-            <a:spLocks noGrp="1" noRot="1" noChangeAspect="1"/>
-          </p:cNvSpPr>
-          <p:nvPr>
-            <p:ph type="sldImg"/>
-          </p:nvPr>
-        </p:nvSpPr>
-        <p:spPr/>
-      </p:sp>
-      <p:sp>
-        <p:nvSpPr>
-          <p:cNvPr id="3" name="Notes Placeholder 2">
-            <a:extLst>
-              <a:ext uri="{FF2B5EF4-FFF2-40B4-BE49-F238E27FC236}">
-                <a16:creationId xmlns:a16="http://schemas.microsoft.com/office/drawing/2014/main" id="{58DED33A-1E02-D300-3CE2-EA66F3797700}"/>
-              </a:ext>
-            </a:extLst>
-          </p:cNvPr>
-          <p:cNvSpPr>
-            <a:spLocks noGrp="1"/>
-          </p:cNvSpPr>
-          <p:nvPr>
-            <p:ph type="body" idx="1"/>
-          </p:nvPr>
-        </p:nvSpPr>
-        <p:spPr/>
-        <p:txBody>
-          <a:bodyPr/>
-          <a:lstStyle/>
-          <a:p>
-            <a:r>
-              <a:rPr lang="en-US" dirty="0"/>
-              <a:t>Sketch of UI, show what we want it to look like</a:t>
-            </a:r>
-          </a:p>
-        </p:txBody>
-      </p:sp>
-      <p:sp>
-        <p:nvSpPr>
-          <p:cNvPr id="4" name="Slide Number Placeholder 3">
-            <a:extLst>
-              <a:ext uri="{FF2B5EF4-FFF2-40B4-BE49-F238E27FC236}">
-                <a16:creationId xmlns:a16="http://schemas.microsoft.com/office/drawing/2014/main" id="{30EB9F64-8659-F14D-480E-4259F49B888B}"/>
-              </a:ext>
-            </a:extLst>
-          </p:cNvPr>
-          <p:cNvSpPr>
-            <a:spLocks noGrp="1"/>
-          </p:cNvSpPr>
-          <p:nvPr>
-            <p:ph type="sldNum" sz="quarter" idx="5"/>
-          </p:nvPr>
-        </p:nvSpPr>
-        <p:spPr/>
-        <p:txBody>
-          <a:bodyPr/>
-          <a:lstStyle/>
-          <a:p>
-            <a:fld id="{269ED01E-914A-41E4-88A0-C6BC45F53370}" type="slidenum">
-              <a:rPr lang="en-US" smtClean="0"/>
-              <a:t>10</a:t>
-            </a:fld>
-            <a:endParaRPr lang="en-US"/>
-          </a:p>
-        </p:txBody>
-      </p:sp>
-    </p:spTree>
-    <p:extLst>
-      <p:ext uri="{BB962C8B-B14F-4D97-AF65-F5344CB8AC3E}">
-        <p14:creationId xmlns:p14="http://schemas.microsoft.com/office/powerpoint/2010/main" val="2755344917"/>
-      </p:ext>
-    </p:extLst>
-  </p:cSld>
-  <p:clrMapOvr>
-    <a:masterClrMapping/>
-  </p:clrMapOvr>
-</p:notes>
-</file>
-
-<file path=ppt/notesSlides/notesSlide7.xml><?xml version="1.0" encoding="utf-8"?>
-<p:notes xmlns:a="http://schemas.openxmlformats.org/drawingml/2006/main" xmlns:r="http://schemas.openxmlformats.org/officeDocument/2006/relationships" xmlns:p="http://schemas.openxmlformats.org/presentationml/2006/main">
-  <p:cSld>
-    <p:spTree>
-      <p:nvGrpSpPr>
-        <p:cNvPr id="1" name="">
-          <a:extLst>
-            <a:ext uri="{FF2B5EF4-FFF2-40B4-BE49-F238E27FC236}">
-              <a16:creationId xmlns:a16="http://schemas.microsoft.com/office/drawing/2014/main" id="{98C5076A-1D4F-834C-3AE3-837DA5A18215}"/>
-            </a:ext>
-          </a:extLst>
-        </p:cNvPr>
-        <p:cNvGrpSpPr/>
-        <p:nvPr/>
-      </p:nvGrpSpPr>
-      <p:grpSpPr>
-        <a:xfrm>
-          <a:off x="0" y="0"/>
-          <a:ext cx="0" cy="0"/>
-          <a:chOff x="0" y="0"/>
-          <a:chExt cx="0" cy="0"/>
-        </a:xfrm>
-      </p:grpSpPr>
-      <p:sp>
-        <p:nvSpPr>
-          <p:cNvPr id="2" name="Slide Image Placeholder 1">
-            <a:extLst>
-              <a:ext uri="{FF2B5EF4-FFF2-40B4-BE49-F238E27FC236}">
-                <a16:creationId xmlns:a16="http://schemas.microsoft.com/office/drawing/2014/main" id="{9721C253-4650-B304-9F8B-34BBA090048C}"/>
-              </a:ext>
-            </a:extLst>
-          </p:cNvPr>
-          <p:cNvSpPr>
-            <a:spLocks noGrp="1" noRot="1" noChangeAspect="1"/>
-          </p:cNvSpPr>
-          <p:nvPr>
-            <p:ph type="sldImg"/>
-          </p:nvPr>
-        </p:nvSpPr>
-        <p:spPr/>
-      </p:sp>
-      <p:sp>
-        <p:nvSpPr>
-          <p:cNvPr id="3" name="Notes Placeholder 2">
-            <a:extLst>
-              <a:ext uri="{FF2B5EF4-FFF2-40B4-BE49-F238E27FC236}">
-                <a16:creationId xmlns:a16="http://schemas.microsoft.com/office/drawing/2014/main" id="{08500FF0-5FA4-EDD7-901D-F10189155CB5}"/>
-              </a:ext>
-            </a:extLst>
-          </p:cNvPr>
-          <p:cNvSpPr>
-            <a:spLocks noGrp="1"/>
-          </p:cNvSpPr>
-          <p:nvPr>
-            <p:ph type="body" idx="1"/>
-          </p:nvPr>
-        </p:nvSpPr>
-        <p:spPr/>
-        <p:txBody>
-          <a:bodyPr/>
-          <a:lstStyle/>
-          <a:p>
-            <a:r>
-              <a:rPr lang="en-US" dirty="0"/>
-              <a:t>Sketch of UI, show what we want it to look like</a:t>
-            </a:r>
-          </a:p>
-        </p:txBody>
-      </p:sp>
-      <p:sp>
-        <p:nvSpPr>
-          <p:cNvPr id="4" name="Slide Number Placeholder 3">
-            <a:extLst>
-              <a:ext uri="{FF2B5EF4-FFF2-40B4-BE49-F238E27FC236}">
-                <a16:creationId xmlns:a16="http://schemas.microsoft.com/office/drawing/2014/main" id="{729B7677-C252-BD44-E1D6-738279DB49D7}"/>
-              </a:ext>
-            </a:extLst>
-          </p:cNvPr>
-          <p:cNvSpPr>
-            <a:spLocks noGrp="1"/>
-          </p:cNvSpPr>
-          <p:nvPr>
-            <p:ph type="sldNum" sz="quarter" idx="5"/>
-          </p:nvPr>
-        </p:nvSpPr>
-        <p:spPr/>
-        <p:txBody>
-          <a:bodyPr/>
-          <a:lstStyle/>
-          <a:p>
-            <a:fld id="{269ED01E-914A-41E4-88A0-C6BC45F53370}" type="slidenum">
-              <a:rPr lang="en-US" smtClean="0"/>
-              <a:t>11</a:t>
-            </a:fld>
-            <a:endParaRPr lang="en-US"/>
-          </a:p>
-        </p:txBody>
-      </p:sp>
-    </p:spTree>
-    <p:extLst>
-      <p:ext uri="{BB962C8B-B14F-4D97-AF65-F5344CB8AC3E}">
-        <p14:creationId xmlns:p14="http://schemas.microsoft.com/office/powerpoint/2010/main" val="2230273140"/>
       </p:ext>
     </p:extLst>
   </p:cSld>
@@ -5300,7 +5300,7 @@
         <p:cNvPr id="1" name="">
           <a:extLst>
             <a:ext uri="{FF2B5EF4-FFF2-40B4-BE49-F238E27FC236}">
-              <a16:creationId xmlns:a16="http://schemas.microsoft.com/office/drawing/2014/main" id="{BC2AB332-2400-FA8E-BE32-C1400637A499}"/>
+              <a16:creationId xmlns:a16="http://schemas.microsoft.com/office/drawing/2014/main" id="{B4C98F31-40D5-F7C1-EFDB-C579570D6D8F}"/>
             </a:ext>
           </a:extLst>
         </p:cNvPr>
@@ -5320,7 +5320,7 @@
           <p:cNvPr id="2" name="Title 1">
             <a:extLst>
               <a:ext uri="{FF2B5EF4-FFF2-40B4-BE49-F238E27FC236}">
-                <a16:creationId xmlns:a16="http://schemas.microsoft.com/office/drawing/2014/main" id="{DF0462F8-8465-9133-CCE5-11738113DA73}"/>
+                <a16:creationId xmlns:a16="http://schemas.microsoft.com/office/drawing/2014/main" id="{B443A5E3-728B-5C50-D629-CBA2EBAB681A}"/>
               </a:ext>
             </a:extLst>
           </p:cNvPr>
@@ -5338,277 +5338,477 @@
           <a:p>
             <a:r>
               <a:rPr lang="en-US" dirty="0"/>
-              <a:t>Functional Requirements cont.</a:t>
-            </a:r>
-          </a:p>
-        </p:txBody>
-      </p:sp>
-      <p:sp>
-        <p:nvSpPr>
-          <p:cNvPr id="9" name="TextBox 8">
+              <a:t>External Interface</a:t>
+            </a:r>
+          </a:p>
+        </p:txBody>
+      </p:sp>
+      <p:graphicFrame>
+        <p:nvGraphicFramePr>
+          <p:cNvPr id="3" name="Table 2">
             <a:extLst>
               <a:ext uri="{FF2B5EF4-FFF2-40B4-BE49-F238E27FC236}">
-                <a16:creationId xmlns:a16="http://schemas.microsoft.com/office/drawing/2014/main" id="{D1E80910-C870-7160-FBBF-A85E6A668CA7}"/>
+                <a16:creationId xmlns:a16="http://schemas.microsoft.com/office/drawing/2014/main" id="{9CA18B5D-6BD9-CA18-F968-1C0D4F0BE7F8}"/>
               </a:ext>
             </a:extLst>
           </p:cNvPr>
-          <p:cNvSpPr txBox="1"/>
-          <p:nvPr/>
-        </p:nvSpPr>
-        <p:spPr>
-          <a:xfrm>
-            <a:off x="1097280" y="1737360"/>
-            <a:ext cx="6267450" cy="3083921"/>
-          </a:xfrm>
-          <a:prstGeom prst="rect">
-            <a:avLst/>
-          </a:prstGeom>
-          <a:noFill/>
-        </p:spPr>
-        <p:txBody>
-          <a:bodyPr wrap="square" rtlCol="0">
-            <a:spAutoFit/>
-          </a:bodyPr>
-          <a:lstStyle/>
-          <a:p>
-            <a:pPr marL="285750" indent="-285750">
-              <a:lnSpc>
-                <a:spcPct val="200000"/>
-              </a:lnSpc>
-              <a:buFont typeface="Arial" panose="020B0604020202020204" pitchFamily="34" charset="0"/>
-              <a:buChar char="•"/>
-            </a:pPr>
-            <a:r>
-              <a:rPr lang="en-US" sz="2000" dirty="0"/>
-              <a:t>File sharing</a:t>
-            </a:r>
-          </a:p>
-          <a:p>
-            <a:pPr marL="285750" indent="-285750">
-              <a:lnSpc>
-                <a:spcPct val="200000"/>
-              </a:lnSpc>
-              <a:buFont typeface="Arial" panose="020B0604020202020204" pitchFamily="34" charset="0"/>
-              <a:buChar char="•"/>
-            </a:pPr>
-            <a:r>
-              <a:rPr lang="en-US" sz="2000" dirty="0"/>
-              <a:t>Administrative tools</a:t>
-            </a:r>
-          </a:p>
-          <a:p>
-            <a:pPr marL="285750" indent="-285750">
-              <a:lnSpc>
-                <a:spcPct val="200000"/>
-              </a:lnSpc>
-              <a:buFont typeface="Arial" panose="020B0604020202020204" pitchFamily="34" charset="0"/>
-              <a:buChar char="•"/>
-            </a:pPr>
-            <a:r>
-              <a:rPr lang="en-US" sz="2000" dirty="0"/>
-              <a:t>System requirements</a:t>
-            </a:r>
-          </a:p>
-          <a:p>
-            <a:pPr marL="285750" indent="-285750">
-              <a:lnSpc>
-                <a:spcPct val="200000"/>
-              </a:lnSpc>
-              <a:buFont typeface="Arial" panose="020B0604020202020204" pitchFamily="34" charset="0"/>
-              <a:buChar char="•"/>
-            </a:pPr>
-            <a:r>
-              <a:rPr lang="en-US" sz="2000" dirty="0"/>
-              <a:t>Data storage</a:t>
-            </a:r>
-          </a:p>
-          <a:p>
-            <a:pPr marL="285750" indent="-285750">
-              <a:lnSpc>
-                <a:spcPct val="200000"/>
-              </a:lnSpc>
-              <a:buFont typeface="Arial" panose="020B0604020202020204" pitchFamily="34" charset="0"/>
-              <a:buChar char="•"/>
-            </a:pPr>
-            <a:r>
-              <a:rPr lang="en-US" sz="2000" dirty="0"/>
-              <a:t>Security</a:t>
-            </a:r>
-          </a:p>
-        </p:txBody>
-      </p:sp>
+          <p:cNvGraphicFramePr>
+            <a:graphicFrameLocks noGrp="1"/>
+          </p:cNvGraphicFramePr>
+          <p:nvPr>
+            <p:extLst>
+              <p:ext uri="{D42A27DB-BD31-4B8C-83A1-F6EECF244321}">
+                <p14:modId xmlns:p14="http://schemas.microsoft.com/office/powerpoint/2010/main" val="1499875323"/>
+              </p:ext>
+            </p:extLst>
+          </p:nvPr>
+        </p:nvGraphicFramePr>
+        <p:xfrm>
+          <a:off x="868680" y="2139256"/>
+          <a:ext cx="10515600" cy="3571240"/>
+        </p:xfrm>
+        <a:graphic>
+          <a:graphicData uri="http://schemas.openxmlformats.org/drawingml/2006/table">
+            <a:tbl>
+              <a:tblPr firstRow="1" bandRow="1">
+                <a:tableStyleId>{5C22544A-7EE6-4342-B048-85BDC9FD1C3A}</a:tableStyleId>
+              </a:tblPr>
+              <a:tblGrid>
+                <a:gridCol w="1719944">
+                  <a:extLst>
+                    <a:ext uri="{9D8B030D-6E8A-4147-A177-3AD203B41FA5}">
+                      <a16:colId xmlns:a16="http://schemas.microsoft.com/office/drawing/2014/main" val="4174102130"/>
+                    </a:ext>
+                  </a:extLst>
+                </a:gridCol>
+                <a:gridCol w="1948543">
+                  <a:extLst>
+                    <a:ext uri="{9D8B030D-6E8A-4147-A177-3AD203B41FA5}">
+                      <a16:colId xmlns:a16="http://schemas.microsoft.com/office/drawing/2014/main" val="1712366548"/>
+                    </a:ext>
+                  </a:extLst>
+                </a:gridCol>
+                <a:gridCol w="5072743">
+                  <a:extLst>
+                    <a:ext uri="{9D8B030D-6E8A-4147-A177-3AD203B41FA5}">
+                      <a16:colId xmlns:a16="http://schemas.microsoft.com/office/drawing/2014/main" val="911734909"/>
+                    </a:ext>
+                  </a:extLst>
+                </a:gridCol>
+                <a:gridCol w="1774370">
+                  <a:extLst>
+                    <a:ext uri="{9D8B030D-6E8A-4147-A177-3AD203B41FA5}">
+                      <a16:colId xmlns:a16="http://schemas.microsoft.com/office/drawing/2014/main" val="3654786738"/>
+                    </a:ext>
+                  </a:extLst>
+                </a:gridCol>
+              </a:tblGrid>
+              <a:tr h="370840">
+                <a:tc>
+                  <a:txBody>
+                    <a:bodyPr/>
+                    <a:lstStyle/>
+                    <a:p>
+                      <a:pPr algn="ctr"/>
+                      <a:r>
+                        <a:rPr lang="en-US" dirty="0"/>
+                        <a:t>Request #</a:t>
+                      </a:r>
+                    </a:p>
+                  </a:txBody>
+                  <a:tcPr/>
+                </a:tc>
+                <a:tc>
+                  <a:txBody>
+                    <a:bodyPr/>
+                    <a:lstStyle/>
+                    <a:p>
+                      <a:pPr algn="ctr"/>
+                      <a:r>
+                        <a:rPr lang="en-US" dirty="0"/>
+                        <a:t>Feature</a:t>
+                      </a:r>
+                    </a:p>
+                  </a:txBody>
+                  <a:tcPr/>
+                </a:tc>
+                <a:tc>
+                  <a:txBody>
+                    <a:bodyPr/>
+                    <a:lstStyle/>
+                    <a:p>
+                      <a:pPr algn="ctr"/>
+                      <a:r>
+                        <a:rPr lang="en-US" sz="1600" dirty="0"/>
+                        <a:t>External Interface Sentence</a:t>
+                      </a:r>
+                    </a:p>
+                  </a:txBody>
+                  <a:tcPr/>
+                </a:tc>
+                <a:tc>
+                  <a:txBody>
+                    <a:bodyPr/>
+                    <a:lstStyle/>
+                    <a:p>
+                      <a:pPr algn="ctr"/>
+                      <a:r>
+                        <a:rPr lang="en-US" dirty="0"/>
+                        <a:t>Priority</a:t>
+                      </a:r>
+                    </a:p>
+                  </a:txBody>
+                  <a:tcPr/>
+                </a:tc>
+                <a:extLst>
+                  <a:ext uri="{0D108BD9-81ED-4DB2-BD59-A6C34878D82A}">
+                    <a16:rowId xmlns:a16="http://schemas.microsoft.com/office/drawing/2014/main" val="1075072847"/>
+                  </a:ext>
+                </a:extLst>
+              </a:tr>
+              <a:tr h="370840">
+                <a:tc>
+                  <a:txBody>
+                    <a:bodyPr/>
+                    <a:lstStyle/>
+                    <a:p>
+                      <a:pPr algn="ctr"/>
+                      <a:r>
+                        <a:rPr lang="en-US" dirty="0"/>
+                        <a:t>EIR#1</a:t>
+                      </a:r>
+                    </a:p>
+                  </a:txBody>
+                  <a:tcPr/>
+                </a:tc>
+                <a:tc>
+                  <a:txBody>
+                    <a:bodyPr/>
+                    <a:lstStyle/>
+                    <a:p>
+                      <a:pPr algn="ctr"/>
+                      <a:r>
+                        <a:rPr lang="en-US" dirty="0"/>
+                        <a:t>User Interface</a:t>
+                      </a:r>
+                    </a:p>
+                  </a:txBody>
+                  <a:tcPr/>
+                </a:tc>
+                <a:tc>
+                  <a:txBody>
+                    <a:bodyPr/>
+                    <a:lstStyle/>
+                    <a:p>
+                      <a:pPr algn="l"/>
+                      <a:r>
+                        <a:rPr lang="en-US" sz="1800" kern="1200" dirty="0">
+                          <a:solidFill>
+                            <a:schemeClr val="dk1"/>
+                          </a:solidFill>
+                          <a:effectLst/>
+                          <a:latin typeface="+mn-lt"/>
+                          <a:ea typeface="+mn-ea"/>
+                          <a:cs typeface="+mn-cs"/>
+                        </a:rPr>
+                        <a:t>The system must run on a web browser via desktop and tablet interfaces.</a:t>
+                      </a:r>
+                      <a:endParaRPr lang="en-US" sz="1800" dirty="0"/>
+                    </a:p>
+                  </a:txBody>
+                  <a:tcPr/>
+                </a:tc>
+                <a:tc>
+                  <a:txBody>
+                    <a:bodyPr/>
+                    <a:lstStyle/>
+                    <a:p>
+                      <a:pPr algn="ctr"/>
+                      <a:r>
+                        <a:rPr lang="en-US"/>
+                        <a:t>High</a:t>
+                      </a:r>
+                      <a:endParaRPr lang="en-US" dirty="0"/>
+                    </a:p>
+                  </a:txBody>
+                  <a:tcPr/>
+                </a:tc>
+                <a:extLst>
+                  <a:ext uri="{0D108BD9-81ED-4DB2-BD59-A6C34878D82A}">
+                    <a16:rowId xmlns:a16="http://schemas.microsoft.com/office/drawing/2014/main" val="1021050612"/>
+                  </a:ext>
+                </a:extLst>
+              </a:tr>
+              <a:tr h="370840">
+                <a:tc>
+                  <a:txBody>
+                    <a:bodyPr/>
+                    <a:lstStyle/>
+                    <a:p>
+                      <a:pPr algn="ctr"/>
+                      <a:r>
+                        <a:rPr lang="en-US" dirty="0"/>
+                        <a:t>EIR#2</a:t>
+                      </a:r>
+                    </a:p>
+                  </a:txBody>
+                  <a:tcPr/>
+                </a:tc>
+                <a:tc>
+                  <a:txBody>
+                    <a:bodyPr/>
+                    <a:lstStyle/>
+                    <a:p>
+                      <a:pPr algn="ctr"/>
+                      <a:r>
+                        <a:rPr lang="en-US" dirty="0"/>
+                        <a:t>Hardware</a:t>
+                      </a:r>
+                    </a:p>
+                  </a:txBody>
+                  <a:tcPr/>
+                </a:tc>
+                <a:tc>
+                  <a:txBody>
+                    <a:bodyPr/>
+                    <a:lstStyle/>
+                    <a:p>
+                      <a:pPr algn="l"/>
+                      <a:r>
+                        <a:rPr lang="en-US" sz="1800" dirty="0"/>
+                        <a:t>The system must operate without the use of specialized hardware.</a:t>
+                      </a:r>
+                    </a:p>
+                  </a:txBody>
+                  <a:tcPr/>
+                </a:tc>
+                <a:tc>
+                  <a:txBody>
+                    <a:bodyPr/>
+                    <a:lstStyle/>
+                    <a:p>
+                      <a:pPr algn="ctr"/>
+                      <a:r>
+                        <a:rPr lang="en-US" dirty="0"/>
+                        <a:t>High</a:t>
+                      </a:r>
+                    </a:p>
+                  </a:txBody>
+                  <a:tcPr/>
+                </a:tc>
+                <a:extLst>
+                  <a:ext uri="{0D108BD9-81ED-4DB2-BD59-A6C34878D82A}">
+                    <a16:rowId xmlns:a16="http://schemas.microsoft.com/office/drawing/2014/main" val="1060847630"/>
+                  </a:ext>
+                </a:extLst>
+              </a:tr>
+              <a:tr h="370840">
+                <a:tc>
+                  <a:txBody>
+                    <a:bodyPr/>
+                    <a:lstStyle/>
+                    <a:p>
+                      <a:pPr algn="ctr"/>
+                      <a:r>
+                        <a:rPr lang="en-US" dirty="0"/>
+                        <a:t>EIR#3</a:t>
+                      </a:r>
+                    </a:p>
+                  </a:txBody>
+                  <a:tcPr/>
+                </a:tc>
+                <a:tc>
+                  <a:txBody>
+                    <a:bodyPr/>
+                    <a:lstStyle/>
+                    <a:p>
+                      <a:pPr algn="ctr"/>
+                      <a:r>
+                        <a:rPr lang="en-US" dirty="0"/>
+                        <a:t>Software</a:t>
+                      </a:r>
+                    </a:p>
+                  </a:txBody>
+                  <a:tcPr/>
+                </a:tc>
+                <a:tc>
+                  <a:txBody>
+                    <a:bodyPr/>
+                    <a:lstStyle/>
+                    <a:p>
+                      <a:pPr algn="l"/>
+                      <a:r>
+                        <a:rPr lang="en-US" sz="1800" dirty="0"/>
+                        <a:t>The system must utilize a React based frontend hosted on </a:t>
+                      </a:r>
+                      <a:r>
+                        <a:rPr lang="en-US" sz="1800" dirty="0" err="1"/>
+                        <a:t>Vercel</a:t>
+                      </a:r>
+                      <a:r>
+                        <a:rPr lang="en-US" sz="1800" dirty="0"/>
+                        <a:t>.</a:t>
+                      </a:r>
+                    </a:p>
+                  </a:txBody>
+                  <a:tcPr/>
+                </a:tc>
+                <a:tc>
+                  <a:txBody>
+                    <a:bodyPr/>
+                    <a:lstStyle/>
+                    <a:p>
+                      <a:pPr algn="ctr"/>
+                      <a:r>
+                        <a:rPr lang="en-US" dirty="0"/>
+                        <a:t>Medium</a:t>
+                      </a:r>
+                    </a:p>
+                  </a:txBody>
+                  <a:tcPr/>
+                </a:tc>
+                <a:extLst>
+                  <a:ext uri="{0D108BD9-81ED-4DB2-BD59-A6C34878D82A}">
+                    <a16:rowId xmlns:a16="http://schemas.microsoft.com/office/drawing/2014/main" val="3533730018"/>
+                  </a:ext>
+                </a:extLst>
+              </a:tr>
+              <a:tr h="370840">
+                <a:tc>
+                  <a:txBody>
+                    <a:bodyPr/>
+                    <a:lstStyle/>
+                    <a:p>
+                      <a:pPr algn="ctr"/>
+                      <a:r>
+                        <a:rPr lang="en-US" dirty="0"/>
+                        <a:t>EIR#4</a:t>
+                      </a:r>
+                    </a:p>
+                  </a:txBody>
+                  <a:tcPr/>
+                </a:tc>
+                <a:tc>
+                  <a:txBody>
+                    <a:bodyPr/>
+                    <a:lstStyle/>
+                    <a:p>
+                      <a:pPr algn="ctr"/>
+                      <a:r>
+                        <a:rPr lang="en-US" dirty="0"/>
+                        <a:t>Security</a:t>
+                      </a:r>
+                    </a:p>
+                  </a:txBody>
+                  <a:tcPr/>
+                </a:tc>
+                <a:tc>
+                  <a:txBody>
+                    <a:bodyPr/>
+                    <a:lstStyle/>
+                    <a:p>
+                      <a:pPr algn="l"/>
+                      <a:r>
+                        <a:rPr lang="en-US" sz="1800" dirty="0"/>
+                        <a:t>The system must utilize JSON Web Tokens to support secure authentication and session management.</a:t>
+                      </a:r>
+                    </a:p>
+                  </a:txBody>
+                  <a:tcPr/>
+                </a:tc>
+                <a:tc>
+                  <a:txBody>
+                    <a:bodyPr/>
+                    <a:lstStyle/>
+                    <a:p>
+                      <a:pPr algn="ctr"/>
+                      <a:r>
+                        <a:rPr lang="en-US" dirty="0"/>
+                        <a:t>High</a:t>
+                      </a:r>
+                    </a:p>
+                  </a:txBody>
+                  <a:tcPr/>
+                </a:tc>
+                <a:extLst>
+                  <a:ext uri="{0D108BD9-81ED-4DB2-BD59-A6C34878D82A}">
+                    <a16:rowId xmlns:a16="http://schemas.microsoft.com/office/drawing/2014/main" val="2152857240"/>
+                  </a:ext>
+                </a:extLst>
+              </a:tr>
+              <a:tr h="370840">
+                <a:tc>
+                  <a:txBody>
+                    <a:bodyPr/>
+                    <a:lstStyle/>
+                    <a:p>
+                      <a:pPr algn="ctr"/>
+                      <a:r>
+                        <a:rPr lang="en-US" dirty="0"/>
+                        <a:t>EIR#5</a:t>
+                      </a:r>
+                    </a:p>
+                  </a:txBody>
+                  <a:tcPr/>
+                </a:tc>
+                <a:tc>
+                  <a:txBody>
+                    <a:bodyPr/>
+                    <a:lstStyle/>
+                    <a:p>
+                      <a:pPr algn="ctr"/>
+                      <a:r>
+                        <a:rPr lang="en-US" dirty="0"/>
+                        <a:t>Communication</a:t>
+                      </a:r>
+                    </a:p>
+                  </a:txBody>
+                  <a:tcPr/>
+                </a:tc>
+                <a:tc>
+                  <a:txBody>
+                    <a:bodyPr/>
+                    <a:lstStyle/>
+                    <a:p>
+                      <a:pPr algn="l"/>
+                      <a:r>
+                        <a:rPr lang="en-US" sz="1800" dirty="0"/>
+                        <a:t>The system must allow real-time communication using Socket.io services.</a:t>
+                      </a:r>
+                    </a:p>
+                  </a:txBody>
+                  <a:tcPr/>
+                </a:tc>
+                <a:tc>
+                  <a:txBody>
+                    <a:bodyPr/>
+                    <a:lstStyle/>
+                    <a:p>
+                      <a:pPr algn="ctr"/>
+                      <a:r>
+                        <a:rPr lang="en-US" dirty="0"/>
+                        <a:t>High</a:t>
+                      </a:r>
+                    </a:p>
+                  </a:txBody>
+                  <a:tcPr/>
+                </a:tc>
+                <a:extLst>
+                  <a:ext uri="{0D108BD9-81ED-4DB2-BD59-A6C34878D82A}">
+                    <a16:rowId xmlns:a16="http://schemas.microsoft.com/office/drawing/2014/main" val="219484715"/>
+                  </a:ext>
+                </a:extLst>
+              </a:tr>
+            </a:tbl>
+          </a:graphicData>
+        </a:graphic>
+      </p:graphicFrame>
       <p:pic>
         <p:nvPicPr>
-          <p:cNvPr id="12" name="Picture 11" descr="A blue lock and shield with check mark&#10;&#10;AI-generated content may be incorrect.">
+          <p:cNvPr id="4" name="Picture 3" descr="A logo with a light bulb and text&#10;&#10;AI-generated content may be incorrect.">
             <a:extLst>
               <a:ext uri="{FF2B5EF4-FFF2-40B4-BE49-F238E27FC236}">
-                <a16:creationId xmlns:a16="http://schemas.microsoft.com/office/drawing/2014/main" id="{ECE98841-D245-BA0C-FBCE-5C6E05758561}"/>
-              </a:ext>
-            </a:extLst>
-          </p:cNvPr>
-          <p:cNvPicPr>
-            <a:picLocks noChangeAspect="1"/>
-          </p:cNvPicPr>
-          <p:nvPr/>
-        </p:nvPicPr>
-        <p:blipFill>
-          <a:blip r:embed="rId3">
-            <a:extLst>
-              <a:ext uri="{28A0092B-C50C-407E-A947-70E740481C1C}">
-                <a14:useLocalDpi xmlns:a14="http://schemas.microsoft.com/office/drawing/2010/main" val="0"/>
-              </a:ext>
-            </a:extLst>
-          </a:blip>
-          <a:stretch>
-            <a:fillRect/>
-          </a:stretch>
-        </p:blipFill>
-        <p:spPr>
-          <a:xfrm>
-            <a:off x="5396169" y="2552764"/>
-            <a:ext cx="1752472" cy="1752472"/>
-          </a:xfrm>
-          <a:prstGeom prst="rect">
-            <a:avLst/>
-          </a:prstGeom>
-        </p:spPr>
-      </p:pic>
-      <p:pic>
-        <p:nvPicPr>
-          <p:cNvPr id="14" name="Picture 13">
-            <a:extLst>
-              <a:ext uri="{FF2B5EF4-FFF2-40B4-BE49-F238E27FC236}">
-                <a16:creationId xmlns:a16="http://schemas.microsoft.com/office/drawing/2014/main" id="{92E8A1F5-B754-2AB1-2734-9C5FC5BAF2EB}"/>
-              </a:ext>
-            </a:extLst>
-          </p:cNvPr>
-          <p:cNvPicPr>
-            <a:picLocks noChangeAspect="1"/>
-          </p:cNvPicPr>
-          <p:nvPr/>
-        </p:nvPicPr>
-        <p:blipFill>
-          <a:blip r:embed="rId4"/>
-          <a:stretch>
-            <a:fillRect/>
-          </a:stretch>
-        </p:blipFill>
-        <p:spPr>
-          <a:xfrm>
-            <a:off x="7619621" y="2552764"/>
-            <a:ext cx="1752472" cy="1752472"/>
-          </a:xfrm>
-          <a:prstGeom prst="rect">
-            <a:avLst/>
-          </a:prstGeom>
-        </p:spPr>
-      </p:pic>
-      <p:pic>
-        <p:nvPicPr>
-          <p:cNvPr id="3" name="Picture 2" descr="A logo with a light bulb and text&#10;&#10;AI-generated content may be incorrect.">
-            <a:extLst>
-              <a:ext uri="{FF2B5EF4-FFF2-40B4-BE49-F238E27FC236}">
-                <a16:creationId xmlns:a16="http://schemas.microsoft.com/office/drawing/2014/main" id="{4071D38F-4514-2501-A71E-4063E8D25C58}"/>
-              </a:ext>
-            </a:extLst>
-          </p:cNvPr>
-          <p:cNvPicPr>
-            <a:picLocks noChangeAspect="1"/>
-          </p:cNvPicPr>
-          <p:nvPr/>
-        </p:nvPicPr>
-        <p:blipFill>
-          <a:blip r:embed="rId5">
-            <a:extLst>
-              <a:ext uri="{28A0092B-C50C-407E-A947-70E740481C1C}">
-                <a14:useLocalDpi xmlns:a14="http://schemas.microsoft.com/office/drawing/2010/main" val="0"/>
-              </a:ext>
-            </a:extLst>
-          </a:blip>
-          <a:stretch>
-            <a:fillRect/>
-          </a:stretch>
-        </p:blipFill>
-        <p:spPr>
-          <a:xfrm>
-            <a:off x="11354417" y="0"/>
-            <a:ext cx="837583" cy="837583"/>
-          </a:xfrm>
-          <a:prstGeom prst="rect">
-            <a:avLst/>
-          </a:prstGeom>
-        </p:spPr>
-      </p:pic>
-    </p:spTree>
-    <p:extLst>
-      <p:ext uri="{BB962C8B-B14F-4D97-AF65-F5344CB8AC3E}">
-        <p14:creationId xmlns:p14="http://schemas.microsoft.com/office/powerpoint/2010/main" val="3435960839"/>
-      </p:ext>
-    </p:extLst>
-  </p:cSld>
-  <p:clrMapOvr>
-    <a:masterClrMapping/>
-  </p:clrMapOvr>
-</p:sld>
-</file>
-
-<file path=ppt/slides/slide11.xml><?xml version="1.0" encoding="utf-8"?>
-<p:sld xmlns:a="http://schemas.openxmlformats.org/drawingml/2006/main" xmlns:r="http://schemas.openxmlformats.org/officeDocument/2006/relationships" xmlns:p="http://schemas.openxmlformats.org/presentationml/2006/main">
-  <p:cSld>
-    <p:spTree>
-      <p:nvGrpSpPr>
-        <p:cNvPr id="1" name="">
-          <a:extLst>
-            <a:ext uri="{FF2B5EF4-FFF2-40B4-BE49-F238E27FC236}">
-              <a16:creationId xmlns:a16="http://schemas.microsoft.com/office/drawing/2014/main" id="{1A30B569-EFAB-5D0B-5805-779BF4F6045A}"/>
-            </a:ext>
-          </a:extLst>
-        </p:cNvPr>
-        <p:cNvGrpSpPr/>
-        <p:nvPr/>
-      </p:nvGrpSpPr>
-      <p:grpSpPr>
-        <a:xfrm>
-          <a:off x="0" y="0"/>
-          <a:ext cx="0" cy="0"/>
-          <a:chOff x="0" y="0"/>
-          <a:chExt cx="0" cy="0"/>
-        </a:xfrm>
-      </p:grpSpPr>
-      <p:sp>
-        <p:nvSpPr>
-          <p:cNvPr id="2" name="Title 1">
-            <a:extLst>
-              <a:ext uri="{FF2B5EF4-FFF2-40B4-BE49-F238E27FC236}">
-                <a16:creationId xmlns:a16="http://schemas.microsoft.com/office/drawing/2014/main" id="{0953CBA4-4646-FBD2-58BA-9CAEB90DA639}"/>
-              </a:ext>
-            </a:extLst>
-          </p:cNvPr>
-          <p:cNvSpPr>
-            <a:spLocks noGrp="1"/>
-          </p:cNvSpPr>
-          <p:nvPr>
-            <p:ph type="title"/>
-          </p:nvPr>
-        </p:nvSpPr>
-        <p:spPr/>
-        <p:txBody>
-          <a:bodyPr/>
-          <a:lstStyle/>
-          <a:p>
-            <a:r>
-              <a:rPr lang="en-US" dirty="0"/>
-              <a:t>Nonfunctional Requirements</a:t>
-            </a:r>
-          </a:p>
-        </p:txBody>
-      </p:sp>
-      <p:pic>
-        <p:nvPicPr>
-          <p:cNvPr id="3" name="Picture 2" descr="A logo with a light bulb and text&#10;&#10;AI-generated content may be incorrect.">
-            <a:extLst>
-              <a:ext uri="{FF2B5EF4-FFF2-40B4-BE49-F238E27FC236}">
-                <a16:creationId xmlns:a16="http://schemas.microsoft.com/office/drawing/2014/main" id="{B0EF75C4-38CF-B684-CD2E-9E607FDF86E2}"/>
+                <a16:creationId xmlns:a16="http://schemas.microsoft.com/office/drawing/2014/main" id="{1F15CE3F-E8DF-6032-BBCF-19926C2BF22D}"/>
               </a:ext>
             </a:extLst>
           </p:cNvPr>
@@ -5642,7 +5842,178 @@
     </p:spTree>
     <p:extLst>
       <p:ext uri="{BB962C8B-B14F-4D97-AF65-F5344CB8AC3E}">
-        <p14:creationId xmlns:p14="http://schemas.microsoft.com/office/powerpoint/2010/main" val="739213906"/>
+        <p14:creationId xmlns:p14="http://schemas.microsoft.com/office/powerpoint/2010/main" val="3881191055"/>
+      </p:ext>
+    </p:extLst>
+  </p:cSld>
+  <p:clrMapOvr>
+    <a:masterClrMapping/>
+  </p:clrMapOvr>
+</p:sld>
+</file>
+
+<file path=ppt/slides/slide11.xml><?xml version="1.0" encoding="utf-8"?>
+<p:sld xmlns:a="http://schemas.openxmlformats.org/drawingml/2006/main" xmlns:r="http://schemas.openxmlformats.org/officeDocument/2006/relationships" xmlns:p="http://schemas.openxmlformats.org/presentationml/2006/main">
+  <p:cSld>
+    <p:spTree>
+      <p:nvGrpSpPr>
+        <p:cNvPr id="1" name="">
+          <a:extLst>
+            <a:ext uri="{FF2B5EF4-FFF2-40B4-BE49-F238E27FC236}">
+              <a16:creationId xmlns:a16="http://schemas.microsoft.com/office/drawing/2014/main" id="{E5953646-F365-0FA2-E400-70D722ACC491}"/>
+            </a:ext>
+          </a:extLst>
+        </p:cNvPr>
+        <p:cNvGrpSpPr/>
+        <p:nvPr/>
+      </p:nvGrpSpPr>
+      <p:grpSpPr>
+        <a:xfrm>
+          <a:off x="0" y="0"/>
+          <a:ext cx="0" cy="0"/>
+          <a:chOff x="0" y="0"/>
+          <a:chExt cx="0" cy="0"/>
+        </a:xfrm>
+      </p:grpSpPr>
+      <p:sp>
+        <p:nvSpPr>
+          <p:cNvPr id="2" name="Title 1">
+            <a:extLst>
+              <a:ext uri="{FF2B5EF4-FFF2-40B4-BE49-F238E27FC236}">
+                <a16:creationId xmlns:a16="http://schemas.microsoft.com/office/drawing/2014/main" id="{370E4F68-6963-9DBE-46A6-19710EBE33E2}"/>
+              </a:ext>
+            </a:extLst>
+          </p:cNvPr>
+          <p:cNvSpPr>
+            <a:spLocks noGrp="1"/>
+          </p:cNvSpPr>
+          <p:nvPr>
+            <p:ph type="title"/>
+          </p:nvPr>
+        </p:nvSpPr>
+        <p:spPr/>
+        <p:txBody>
+          <a:bodyPr/>
+          <a:lstStyle/>
+          <a:p>
+            <a:r>
+              <a:rPr lang="en-US" dirty="0"/>
+              <a:t>External Interface</a:t>
+            </a:r>
+          </a:p>
+        </p:txBody>
+      </p:sp>
+      <p:pic>
+        <p:nvPicPr>
+          <p:cNvPr id="4" name="Picture 3" descr="A screenshot of a computer&#10;&#10;AI-generated content may be incorrect.">
+            <a:extLst>
+              <a:ext uri="{FF2B5EF4-FFF2-40B4-BE49-F238E27FC236}">
+                <a16:creationId xmlns:a16="http://schemas.microsoft.com/office/drawing/2014/main" id="{8DC46D8D-83D9-A1E0-65D4-15DDF9B79D25}"/>
+              </a:ext>
+            </a:extLst>
+          </p:cNvPr>
+          <p:cNvPicPr>
+            <a:picLocks noChangeAspect="1"/>
+          </p:cNvPicPr>
+          <p:nvPr/>
+        </p:nvPicPr>
+        <p:blipFill>
+          <a:blip r:embed="rId3">
+            <a:extLst>
+              <a:ext uri="{28A0092B-C50C-407E-A947-70E740481C1C}">
+                <a14:useLocalDpi xmlns:a14="http://schemas.microsoft.com/office/drawing/2010/main" val="0"/>
+              </a:ext>
+            </a:extLst>
+          </a:blip>
+          <a:stretch>
+            <a:fillRect/>
+          </a:stretch>
+        </p:blipFill>
+        <p:spPr>
+          <a:xfrm>
+            <a:off x="1097280" y="2090239"/>
+            <a:ext cx="5551715" cy="3704445"/>
+          </a:xfrm>
+          <a:prstGeom prst="rect">
+            <a:avLst/>
+          </a:prstGeom>
+        </p:spPr>
+      </p:pic>
+      <p:sp>
+        <p:nvSpPr>
+          <p:cNvPr id="5" name="TextBox 4">
+            <a:extLst>
+              <a:ext uri="{FF2B5EF4-FFF2-40B4-BE49-F238E27FC236}">
+                <a16:creationId xmlns:a16="http://schemas.microsoft.com/office/drawing/2014/main" id="{F93FD042-7B7A-1AE5-57C8-ACF8C04FC254}"/>
+              </a:ext>
+            </a:extLst>
+          </p:cNvPr>
+          <p:cNvSpPr txBox="1"/>
+          <p:nvPr/>
+        </p:nvSpPr>
+        <p:spPr>
+          <a:xfrm>
+            <a:off x="7609731" y="2274838"/>
+            <a:ext cx="3744686" cy="2308324"/>
+          </a:xfrm>
+          <a:prstGeom prst="rect">
+            <a:avLst/>
+          </a:prstGeom>
+          <a:noFill/>
+        </p:spPr>
+        <p:txBody>
+          <a:bodyPr wrap="square" rtlCol="0">
+            <a:spAutoFit/>
+          </a:bodyPr>
+          <a:lstStyle/>
+          <a:p>
+            <a:r>
+              <a:rPr lang="en-US" dirty="0"/>
+              <a:t>To the left is an example of the interface we plan to implement. Here is the messaging page, where users can message other individual users or complete groups. You can view your message history, create quizzes, flashcards and polls with each messaging subpage, as well.</a:t>
+            </a:r>
+          </a:p>
+        </p:txBody>
+      </p:sp>
+      <p:pic>
+        <p:nvPicPr>
+          <p:cNvPr id="3" name="Picture 2" descr="A logo with a light bulb and text&#10;&#10;AI-generated content may be incorrect.">
+            <a:extLst>
+              <a:ext uri="{FF2B5EF4-FFF2-40B4-BE49-F238E27FC236}">
+                <a16:creationId xmlns:a16="http://schemas.microsoft.com/office/drawing/2014/main" id="{AD4499B7-0923-C343-A39C-E60EFB19352E}"/>
+              </a:ext>
+            </a:extLst>
+          </p:cNvPr>
+          <p:cNvPicPr>
+            <a:picLocks noChangeAspect="1"/>
+          </p:cNvPicPr>
+          <p:nvPr/>
+        </p:nvPicPr>
+        <p:blipFill>
+          <a:blip r:embed="rId4">
+            <a:extLst>
+              <a:ext uri="{28A0092B-C50C-407E-A947-70E740481C1C}">
+                <a14:useLocalDpi xmlns:a14="http://schemas.microsoft.com/office/drawing/2010/main" val="0"/>
+              </a:ext>
+            </a:extLst>
+          </a:blip>
+          <a:stretch>
+            <a:fillRect/>
+          </a:stretch>
+        </p:blipFill>
+        <p:spPr>
+          <a:xfrm>
+            <a:off x="11354417" y="0"/>
+            <a:ext cx="837583" cy="837583"/>
+          </a:xfrm>
+          <a:prstGeom prst="rect">
+            <a:avLst/>
+          </a:prstGeom>
+        </p:spPr>
+      </p:pic>
+    </p:spTree>
+    <p:extLst>
+      <p:ext uri="{BB962C8B-B14F-4D97-AF65-F5344CB8AC3E}">
+        <p14:creationId xmlns:p14="http://schemas.microsoft.com/office/powerpoint/2010/main" val="3620250242"/>
       </p:ext>
     </p:extLst>
   </p:cSld>
@@ -8299,737 +8670,6 @@
         <p:cNvPr id="1" name="">
           <a:extLst>
             <a:ext uri="{FF2B5EF4-FFF2-40B4-BE49-F238E27FC236}">
-              <a16:creationId xmlns:a16="http://schemas.microsoft.com/office/drawing/2014/main" id="{B4C98F31-40D5-F7C1-EFDB-C579570D6D8F}"/>
-            </a:ext>
-          </a:extLst>
-        </p:cNvPr>
-        <p:cNvGrpSpPr/>
-        <p:nvPr/>
-      </p:nvGrpSpPr>
-      <p:grpSpPr>
-        <a:xfrm>
-          <a:off x="0" y="0"/>
-          <a:ext cx="0" cy="0"/>
-          <a:chOff x="0" y="0"/>
-          <a:chExt cx="0" cy="0"/>
-        </a:xfrm>
-      </p:grpSpPr>
-      <p:sp>
-        <p:nvSpPr>
-          <p:cNvPr id="2" name="Title 1">
-            <a:extLst>
-              <a:ext uri="{FF2B5EF4-FFF2-40B4-BE49-F238E27FC236}">
-                <a16:creationId xmlns:a16="http://schemas.microsoft.com/office/drawing/2014/main" id="{B443A5E3-728B-5C50-D629-CBA2EBAB681A}"/>
-              </a:ext>
-            </a:extLst>
-          </p:cNvPr>
-          <p:cNvSpPr>
-            <a:spLocks noGrp="1"/>
-          </p:cNvSpPr>
-          <p:nvPr>
-            <p:ph type="title"/>
-          </p:nvPr>
-        </p:nvSpPr>
-        <p:spPr/>
-        <p:txBody>
-          <a:bodyPr/>
-          <a:lstStyle/>
-          <a:p>
-            <a:r>
-              <a:rPr lang="en-US" dirty="0"/>
-              <a:t>External Interface</a:t>
-            </a:r>
-          </a:p>
-        </p:txBody>
-      </p:sp>
-      <p:graphicFrame>
-        <p:nvGraphicFramePr>
-          <p:cNvPr id="3" name="Table 2">
-            <a:extLst>
-              <a:ext uri="{FF2B5EF4-FFF2-40B4-BE49-F238E27FC236}">
-                <a16:creationId xmlns:a16="http://schemas.microsoft.com/office/drawing/2014/main" id="{9CA18B5D-6BD9-CA18-F968-1C0D4F0BE7F8}"/>
-              </a:ext>
-            </a:extLst>
-          </p:cNvPr>
-          <p:cNvGraphicFramePr>
-            <a:graphicFrameLocks noGrp="1"/>
-          </p:cNvGraphicFramePr>
-          <p:nvPr>
-            <p:extLst>
-              <p:ext uri="{D42A27DB-BD31-4B8C-83A1-F6EECF244321}">
-                <p14:modId xmlns:p14="http://schemas.microsoft.com/office/powerpoint/2010/main" val="1499875323"/>
-              </p:ext>
-            </p:extLst>
-          </p:nvPr>
-        </p:nvGraphicFramePr>
-        <p:xfrm>
-          <a:off x="868680" y="2139256"/>
-          <a:ext cx="10515600" cy="3571240"/>
-        </p:xfrm>
-        <a:graphic>
-          <a:graphicData uri="http://schemas.openxmlformats.org/drawingml/2006/table">
-            <a:tbl>
-              <a:tblPr firstRow="1" bandRow="1">
-                <a:tableStyleId>{5C22544A-7EE6-4342-B048-85BDC9FD1C3A}</a:tableStyleId>
-              </a:tblPr>
-              <a:tblGrid>
-                <a:gridCol w="1719944">
-                  <a:extLst>
-                    <a:ext uri="{9D8B030D-6E8A-4147-A177-3AD203B41FA5}">
-                      <a16:colId xmlns:a16="http://schemas.microsoft.com/office/drawing/2014/main" val="4174102130"/>
-                    </a:ext>
-                  </a:extLst>
-                </a:gridCol>
-                <a:gridCol w="1948543">
-                  <a:extLst>
-                    <a:ext uri="{9D8B030D-6E8A-4147-A177-3AD203B41FA5}">
-                      <a16:colId xmlns:a16="http://schemas.microsoft.com/office/drawing/2014/main" val="1712366548"/>
-                    </a:ext>
-                  </a:extLst>
-                </a:gridCol>
-                <a:gridCol w="5072743">
-                  <a:extLst>
-                    <a:ext uri="{9D8B030D-6E8A-4147-A177-3AD203B41FA5}">
-                      <a16:colId xmlns:a16="http://schemas.microsoft.com/office/drawing/2014/main" val="911734909"/>
-                    </a:ext>
-                  </a:extLst>
-                </a:gridCol>
-                <a:gridCol w="1774370">
-                  <a:extLst>
-                    <a:ext uri="{9D8B030D-6E8A-4147-A177-3AD203B41FA5}">
-                      <a16:colId xmlns:a16="http://schemas.microsoft.com/office/drawing/2014/main" val="3654786738"/>
-                    </a:ext>
-                  </a:extLst>
-                </a:gridCol>
-              </a:tblGrid>
-              <a:tr h="370840">
-                <a:tc>
-                  <a:txBody>
-                    <a:bodyPr/>
-                    <a:lstStyle/>
-                    <a:p>
-                      <a:pPr algn="ctr"/>
-                      <a:r>
-                        <a:rPr lang="en-US" dirty="0"/>
-                        <a:t>Request #</a:t>
-                      </a:r>
-                    </a:p>
-                  </a:txBody>
-                  <a:tcPr/>
-                </a:tc>
-                <a:tc>
-                  <a:txBody>
-                    <a:bodyPr/>
-                    <a:lstStyle/>
-                    <a:p>
-                      <a:pPr algn="ctr"/>
-                      <a:r>
-                        <a:rPr lang="en-US" dirty="0"/>
-                        <a:t>Feature</a:t>
-                      </a:r>
-                    </a:p>
-                  </a:txBody>
-                  <a:tcPr/>
-                </a:tc>
-                <a:tc>
-                  <a:txBody>
-                    <a:bodyPr/>
-                    <a:lstStyle/>
-                    <a:p>
-                      <a:pPr algn="ctr"/>
-                      <a:r>
-                        <a:rPr lang="en-US" sz="1600" dirty="0"/>
-                        <a:t>External Interface Sentence</a:t>
-                      </a:r>
-                    </a:p>
-                  </a:txBody>
-                  <a:tcPr/>
-                </a:tc>
-                <a:tc>
-                  <a:txBody>
-                    <a:bodyPr/>
-                    <a:lstStyle/>
-                    <a:p>
-                      <a:pPr algn="ctr"/>
-                      <a:r>
-                        <a:rPr lang="en-US" dirty="0"/>
-                        <a:t>Priority</a:t>
-                      </a:r>
-                    </a:p>
-                  </a:txBody>
-                  <a:tcPr/>
-                </a:tc>
-                <a:extLst>
-                  <a:ext uri="{0D108BD9-81ED-4DB2-BD59-A6C34878D82A}">
-                    <a16:rowId xmlns:a16="http://schemas.microsoft.com/office/drawing/2014/main" val="1075072847"/>
-                  </a:ext>
-                </a:extLst>
-              </a:tr>
-              <a:tr h="370840">
-                <a:tc>
-                  <a:txBody>
-                    <a:bodyPr/>
-                    <a:lstStyle/>
-                    <a:p>
-                      <a:pPr algn="ctr"/>
-                      <a:r>
-                        <a:rPr lang="en-US" dirty="0"/>
-                        <a:t>EIR#1</a:t>
-                      </a:r>
-                    </a:p>
-                  </a:txBody>
-                  <a:tcPr/>
-                </a:tc>
-                <a:tc>
-                  <a:txBody>
-                    <a:bodyPr/>
-                    <a:lstStyle/>
-                    <a:p>
-                      <a:pPr algn="ctr"/>
-                      <a:r>
-                        <a:rPr lang="en-US" dirty="0"/>
-                        <a:t>User Interface</a:t>
-                      </a:r>
-                    </a:p>
-                  </a:txBody>
-                  <a:tcPr/>
-                </a:tc>
-                <a:tc>
-                  <a:txBody>
-                    <a:bodyPr/>
-                    <a:lstStyle/>
-                    <a:p>
-                      <a:pPr algn="l"/>
-                      <a:r>
-                        <a:rPr lang="en-US" sz="1800" kern="1200" dirty="0">
-                          <a:solidFill>
-                            <a:schemeClr val="dk1"/>
-                          </a:solidFill>
-                          <a:effectLst/>
-                          <a:latin typeface="+mn-lt"/>
-                          <a:ea typeface="+mn-ea"/>
-                          <a:cs typeface="+mn-cs"/>
-                        </a:rPr>
-                        <a:t>The system must run on a web browser via desktop and tablet interfaces.</a:t>
-                      </a:r>
-                      <a:endParaRPr lang="en-US" sz="1800" dirty="0"/>
-                    </a:p>
-                  </a:txBody>
-                  <a:tcPr/>
-                </a:tc>
-                <a:tc>
-                  <a:txBody>
-                    <a:bodyPr/>
-                    <a:lstStyle/>
-                    <a:p>
-                      <a:pPr algn="ctr"/>
-                      <a:r>
-                        <a:rPr lang="en-US"/>
-                        <a:t>High</a:t>
-                      </a:r>
-                      <a:endParaRPr lang="en-US" dirty="0"/>
-                    </a:p>
-                  </a:txBody>
-                  <a:tcPr/>
-                </a:tc>
-                <a:extLst>
-                  <a:ext uri="{0D108BD9-81ED-4DB2-BD59-A6C34878D82A}">
-                    <a16:rowId xmlns:a16="http://schemas.microsoft.com/office/drawing/2014/main" val="1021050612"/>
-                  </a:ext>
-                </a:extLst>
-              </a:tr>
-              <a:tr h="370840">
-                <a:tc>
-                  <a:txBody>
-                    <a:bodyPr/>
-                    <a:lstStyle/>
-                    <a:p>
-                      <a:pPr algn="ctr"/>
-                      <a:r>
-                        <a:rPr lang="en-US" dirty="0"/>
-                        <a:t>EIR#2</a:t>
-                      </a:r>
-                    </a:p>
-                  </a:txBody>
-                  <a:tcPr/>
-                </a:tc>
-                <a:tc>
-                  <a:txBody>
-                    <a:bodyPr/>
-                    <a:lstStyle/>
-                    <a:p>
-                      <a:pPr algn="ctr"/>
-                      <a:r>
-                        <a:rPr lang="en-US" dirty="0"/>
-                        <a:t>Hardware</a:t>
-                      </a:r>
-                    </a:p>
-                  </a:txBody>
-                  <a:tcPr/>
-                </a:tc>
-                <a:tc>
-                  <a:txBody>
-                    <a:bodyPr/>
-                    <a:lstStyle/>
-                    <a:p>
-                      <a:pPr algn="l"/>
-                      <a:r>
-                        <a:rPr lang="en-US" sz="1800" dirty="0"/>
-                        <a:t>The system must operate without the use of specialized hardware.</a:t>
-                      </a:r>
-                    </a:p>
-                  </a:txBody>
-                  <a:tcPr/>
-                </a:tc>
-                <a:tc>
-                  <a:txBody>
-                    <a:bodyPr/>
-                    <a:lstStyle/>
-                    <a:p>
-                      <a:pPr algn="ctr"/>
-                      <a:r>
-                        <a:rPr lang="en-US" dirty="0"/>
-                        <a:t>High</a:t>
-                      </a:r>
-                    </a:p>
-                  </a:txBody>
-                  <a:tcPr/>
-                </a:tc>
-                <a:extLst>
-                  <a:ext uri="{0D108BD9-81ED-4DB2-BD59-A6C34878D82A}">
-                    <a16:rowId xmlns:a16="http://schemas.microsoft.com/office/drawing/2014/main" val="1060847630"/>
-                  </a:ext>
-                </a:extLst>
-              </a:tr>
-              <a:tr h="370840">
-                <a:tc>
-                  <a:txBody>
-                    <a:bodyPr/>
-                    <a:lstStyle/>
-                    <a:p>
-                      <a:pPr algn="ctr"/>
-                      <a:r>
-                        <a:rPr lang="en-US" dirty="0"/>
-                        <a:t>EIR#3</a:t>
-                      </a:r>
-                    </a:p>
-                  </a:txBody>
-                  <a:tcPr/>
-                </a:tc>
-                <a:tc>
-                  <a:txBody>
-                    <a:bodyPr/>
-                    <a:lstStyle/>
-                    <a:p>
-                      <a:pPr algn="ctr"/>
-                      <a:r>
-                        <a:rPr lang="en-US" dirty="0"/>
-                        <a:t>Software</a:t>
-                      </a:r>
-                    </a:p>
-                  </a:txBody>
-                  <a:tcPr/>
-                </a:tc>
-                <a:tc>
-                  <a:txBody>
-                    <a:bodyPr/>
-                    <a:lstStyle/>
-                    <a:p>
-                      <a:pPr algn="l"/>
-                      <a:r>
-                        <a:rPr lang="en-US" sz="1800" dirty="0"/>
-                        <a:t>The system must utilize a React based frontend hosted on </a:t>
-                      </a:r>
-                      <a:r>
-                        <a:rPr lang="en-US" sz="1800" dirty="0" err="1"/>
-                        <a:t>Vercel</a:t>
-                      </a:r>
-                      <a:r>
-                        <a:rPr lang="en-US" sz="1800" dirty="0"/>
-                        <a:t>.</a:t>
-                      </a:r>
-                    </a:p>
-                  </a:txBody>
-                  <a:tcPr/>
-                </a:tc>
-                <a:tc>
-                  <a:txBody>
-                    <a:bodyPr/>
-                    <a:lstStyle/>
-                    <a:p>
-                      <a:pPr algn="ctr"/>
-                      <a:r>
-                        <a:rPr lang="en-US" dirty="0"/>
-                        <a:t>Medium</a:t>
-                      </a:r>
-                    </a:p>
-                  </a:txBody>
-                  <a:tcPr/>
-                </a:tc>
-                <a:extLst>
-                  <a:ext uri="{0D108BD9-81ED-4DB2-BD59-A6C34878D82A}">
-                    <a16:rowId xmlns:a16="http://schemas.microsoft.com/office/drawing/2014/main" val="3533730018"/>
-                  </a:ext>
-                </a:extLst>
-              </a:tr>
-              <a:tr h="370840">
-                <a:tc>
-                  <a:txBody>
-                    <a:bodyPr/>
-                    <a:lstStyle/>
-                    <a:p>
-                      <a:pPr algn="ctr"/>
-                      <a:r>
-                        <a:rPr lang="en-US" dirty="0"/>
-                        <a:t>EIR#4</a:t>
-                      </a:r>
-                    </a:p>
-                  </a:txBody>
-                  <a:tcPr/>
-                </a:tc>
-                <a:tc>
-                  <a:txBody>
-                    <a:bodyPr/>
-                    <a:lstStyle/>
-                    <a:p>
-                      <a:pPr algn="ctr"/>
-                      <a:r>
-                        <a:rPr lang="en-US" dirty="0"/>
-                        <a:t>Security</a:t>
-                      </a:r>
-                    </a:p>
-                  </a:txBody>
-                  <a:tcPr/>
-                </a:tc>
-                <a:tc>
-                  <a:txBody>
-                    <a:bodyPr/>
-                    <a:lstStyle/>
-                    <a:p>
-                      <a:pPr algn="l"/>
-                      <a:r>
-                        <a:rPr lang="en-US" sz="1800" dirty="0"/>
-                        <a:t>The system must utilize JSON Web Tokens to support secure authentication and session management.</a:t>
-                      </a:r>
-                    </a:p>
-                  </a:txBody>
-                  <a:tcPr/>
-                </a:tc>
-                <a:tc>
-                  <a:txBody>
-                    <a:bodyPr/>
-                    <a:lstStyle/>
-                    <a:p>
-                      <a:pPr algn="ctr"/>
-                      <a:r>
-                        <a:rPr lang="en-US" dirty="0"/>
-                        <a:t>High</a:t>
-                      </a:r>
-                    </a:p>
-                  </a:txBody>
-                  <a:tcPr/>
-                </a:tc>
-                <a:extLst>
-                  <a:ext uri="{0D108BD9-81ED-4DB2-BD59-A6C34878D82A}">
-                    <a16:rowId xmlns:a16="http://schemas.microsoft.com/office/drawing/2014/main" val="2152857240"/>
-                  </a:ext>
-                </a:extLst>
-              </a:tr>
-              <a:tr h="370840">
-                <a:tc>
-                  <a:txBody>
-                    <a:bodyPr/>
-                    <a:lstStyle/>
-                    <a:p>
-                      <a:pPr algn="ctr"/>
-                      <a:r>
-                        <a:rPr lang="en-US" dirty="0"/>
-                        <a:t>EIR#5</a:t>
-                      </a:r>
-                    </a:p>
-                  </a:txBody>
-                  <a:tcPr/>
-                </a:tc>
-                <a:tc>
-                  <a:txBody>
-                    <a:bodyPr/>
-                    <a:lstStyle/>
-                    <a:p>
-                      <a:pPr algn="ctr"/>
-                      <a:r>
-                        <a:rPr lang="en-US" dirty="0"/>
-                        <a:t>Communication</a:t>
-                      </a:r>
-                    </a:p>
-                  </a:txBody>
-                  <a:tcPr/>
-                </a:tc>
-                <a:tc>
-                  <a:txBody>
-                    <a:bodyPr/>
-                    <a:lstStyle/>
-                    <a:p>
-                      <a:pPr algn="l"/>
-                      <a:r>
-                        <a:rPr lang="en-US" sz="1800" dirty="0"/>
-                        <a:t>The system must allow real-time communication using Socket.io services.</a:t>
-                      </a:r>
-                    </a:p>
-                  </a:txBody>
-                  <a:tcPr/>
-                </a:tc>
-                <a:tc>
-                  <a:txBody>
-                    <a:bodyPr/>
-                    <a:lstStyle/>
-                    <a:p>
-                      <a:pPr algn="ctr"/>
-                      <a:r>
-                        <a:rPr lang="en-US" dirty="0"/>
-                        <a:t>High</a:t>
-                      </a:r>
-                    </a:p>
-                  </a:txBody>
-                  <a:tcPr/>
-                </a:tc>
-                <a:extLst>
-                  <a:ext uri="{0D108BD9-81ED-4DB2-BD59-A6C34878D82A}">
-                    <a16:rowId xmlns:a16="http://schemas.microsoft.com/office/drawing/2014/main" val="219484715"/>
-                  </a:ext>
-                </a:extLst>
-              </a:tr>
-            </a:tbl>
-          </a:graphicData>
-        </a:graphic>
-      </p:graphicFrame>
-      <p:pic>
-        <p:nvPicPr>
-          <p:cNvPr id="4" name="Picture 3" descr="A logo with a light bulb and text&#10;&#10;AI-generated content may be incorrect.">
-            <a:extLst>
-              <a:ext uri="{FF2B5EF4-FFF2-40B4-BE49-F238E27FC236}">
-                <a16:creationId xmlns:a16="http://schemas.microsoft.com/office/drawing/2014/main" id="{1F15CE3F-E8DF-6032-BBCF-19926C2BF22D}"/>
-              </a:ext>
-            </a:extLst>
-          </p:cNvPr>
-          <p:cNvPicPr>
-            <a:picLocks noChangeAspect="1"/>
-          </p:cNvPicPr>
-          <p:nvPr/>
-        </p:nvPicPr>
-        <p:blipFill>
-          <a:blip r:embed="rId3">
-            <a:extLst>
-              <a:ext uri="{28A0092B-C50C-407E-A947-70E740481C1C}">
-                <a14:useLocalDpi xmlns:a14="http://schemas.microsoft.com/office/drawing/2010/main" val="0"/>
-              </a:ext>
-            </a:extLst>
-          </a:blip>
-          <a:stretch>
-            <a:fillRect/>
-          </a:stretch>
-        </p:blipFill>
-        <p:spPr>
-          <a:xfrm>
-            <a:off x="11354417" y="0"/>
-            <a:ext cx="837583" cy="837583"/>
-          </a:xfrm>
-          <a:prstGeom prst="rect">
-            <a:avLst/>
-          </a:prstGeom>
-        </p:spPr>
-      </p:pic>
-    </p:spTree>
-    <p:extLst>
-      <p:ext uri="{BB962C8B-B14F-4D97-AF65-F5344CB8AC3E}">
-        <p14:creationId xmlns:p14="http://schemas.microsoft.com/office/powerpoint/2010/main" val="3881191055"/>
-      </p:ext>
-    </p:extLst>
-  </p:cSld>
-  <p:clrMapOvr>
-    <a:masterClrMapping/>
-  </p:clrMapOvr>
-</p:sld>
-</file>
-
-<file path=ppt/slides/slide8.xml><?xml version="1.0" encoding="utf-8"?>
-<p:sld xmlns:a="http://schemas.openxmlformats.org/drawingml/2006/main" xmlns:r="http://schemas.openxmlformats.org/officeDocument/2006/relationships" xmlns:p="http://schemas.openxmlformats.org/presentationml/2006/main">
-  <p:cSld>
-    <p:spTree>
-      <p:nvGrpSpPr>
-        <p:cNvPr id="1" name="">
-          <a:extLst>
-            <a:ext uri="{FF2B5EF4-FFF2-40B4-BE49-F238E27FC236}">
-              <a16:creationId xmlns:a16="http://schemas.microsoft.com/office/drawing/2014/main" id="{E5953646-F365-0FA2-E400-70D722ACC491}"/>
-            </a:ext>
-          </a:extLst>
-        </p:cNvPr>
-        <p:cNvGrpSpPr/>
-        <p:nvPr/>
-      </p:nvGrpSpPr>
-      <p:grpSpPr>
-        <a:xfrm>
-          <a:off x="0" y="0"/>
-          <a:ext cx="0" cy="0"/>
-          <a:chOff x="0" y="0"/>
-          <a:chExt cx="0" cy="0"/>
-        </a:xfrm>
-      </p:grpSpPr>
-      <p:sp>
-        <p:nvSpPr>
-          <p:cNvPr id="2" name="Title 1">
-            <a:extLst>
-              <a:ext uri="{FF2B5EF4-FFF2-40B4-BE49-F238E27FC236}">
-                <a16:creationId xmlns:a16="http://schemas.microsoft.com/office/drawing/2014/main" id="{370E4F68-6963-9DBE-46A6-19710EBE33E2}"/>
-              </a:ext>
-            </a:extLst>
-          </p:cNvPr>
-          <p:cNvSpPr>
-            <a:spLocks noGrp="1"/>
-          </p:cNvSpPr>
-          <p:nvPr>
-            <p:ph type="title"/>
-          </p:nvPr>
-        </p:nvSpPr>
-        <p:spPr/>
-        <p:txBody>
-          <a:bodyPr/>
-          <a:lstStyle/>
-          <a:p>
-            <a:r>
-              <a:rPr lang="en-US" dirty="0"/>
-              <a:t>External Interface</a:t>
-            </a:r>
-          </a:p>
-        </p:txBody>
-      </p:sp>
-      <p:pic>
-        <p:nvPicPr>
-          <p:cNvPr id="4" name="Picture 3" descr="A screenshot of a computer&#10;&#10;AI-generated content may be incorrect.">
-            <a:extLst>
-              <a:ext uri="{FF2B5EF4-FFF2-40B4-BE49-F238E27FC236}">
-                <a16:creationId xmlns:a16="http://schemas.microsoft.com/office/drawing/2014/main" id="{8DC46D8D-83D9-A1E0-65D4-15DDF9B79D25}"/>
-              </a:ext>
-            </a:extLst>
-          </p:cNvPr>
-          <p:cNvPicPr>
-            <a:picLocks noChangeAspect="1"/>
-          </p:cNvPicPr>
-          <p:nvPr/>
-        </p:nvPicPr>
-        <p:blipFill>
-          <a:blip r:embed="rId3">
-            <a:extLst>
-              <a:ext uri="{28A0092B-C50C-407E-A947-70E740481C1C}">
-                <a14:useLocalDpi xmlns:a14="http://schemas.microsoft.com/office/drawing/2010/main" val="0"/>
-              </a:ext>
-            </a:extLst>
-          </a:blip>
-          <a:stretch>
-            <a:fillRect/>
-          </a:stretch>
-        </p:blipFill>
-        <p:spPr>
-          <a:xfrm>
-            <a:off x="1097280" y="2090239"/>
-            <a:ext cx="5551715" cy="3704445"/>
-          </a:xfrm>
-          <a:prstGeom prst="rect">
-            <a:avLst/>
-          </a:prstGeom>
-        </p:spPr>
-      </p:pic>
-      <p:sp>
-        <p:nvSpPr>
-          <p:cNvPr id="5" name="TextBox 4">
-            <a:extLst>
-              <a:ext uri="{FF2B5EF4-FFF2-40B4-BE49-F238E27FC236}">
-                <a16:creationId xmlns:a16="http://schemas.microsoft.com/office/drawing/2014/main" id="{F93FD042-7B7A-1AE5-57C8-ACF8C04FC254}"/>
-              </a:ext>
-            </a:extLst>
-          </p:cNvPr>
-          <p:cNvSpPr txBox="1"/>
-          <p:nvPr/>
-        </p:nvSpPr>
-        <p:spPr>
-          <a:xfrm>
-            <a:off x="7609731" y="2274838"/>
-            <a:ext cx="3744686" cy="2308324"/>
-          </a:xfrm>
-          <a:prstGeom prst="rect">
-            <a:avLst/>
-          </a:prstGeom>
-          <a:noFill/>
-        </p:spPr>
-        <p:txBody>
-          <a:bodyPr wrap="square" rtlCol="0">
-            <a:spAutoFit/>
-          </a:bodyPr>
-          <a:lstStyle/>
-          <a:p>
-            <a:r>
-              <a:rPr lang="en-US" dirty="0"/>
-              <a:t>To the left is an example of the interface we plan to implement. Here is the messaging page, where users can message other individual users or complete groups. You can view your message history, create quizzes, flashcards and polls with each messaging subpage, as well.</a:t>
-            </a:r>
-          </a:p>
-        </p:txBody>
-      </p:sp>
-      <p:pic>
-        <p:nvPicPr>
-          <p:cNvPr id="3" name="Picture 2" descr="A logo with a light bulb and text&#10;&#10;AI-generated content may be incorrect.">
-            <a:extLst>
-              <a:ext uri="{FF2B5EF4-FFF2-40B4-BE49-F238E27FC236}">
-                <a16:creationId xmlns:a16="http://schemas.microsoft.com/office/drawing/2014/main" id="{AD4499B7-0923-C343-A39C-E60EFB19352E}"/>
-              </a:ext>
-            </a:extLst>
-          </p:cNvPr>
-          <p:cNvPicPr>
-            <a:picLocks noChangeAspect="1"/>
-          </p:cNvPicPr>
-          <p:nvPr/>
-        </p:nvPicPr>
-        <p:blipFill>
-          <a:blip r:embed="rId4">
-            <a:extLst>
-              <a:ext uri="{28A0092B-C50C-407E-A947-70E740481C1C}">
-                <a14:useLocalDpi xmlns:a14="http://schemas.microsoft.com/office/drawing/2010/main" val="0"/>
-              </a:ext>
-            </a:extLst>
-          </a:blip>
-          <a:stretch>
-            <a:fillRect/>
-          </a:stretch>
-        </p:blipFill>
-        <p:spPr>
-          <a:xfrm>
-            <a:off x="11354417" y="0"/>
-            <a:ext cx="837583" cy="837583"/>
-          </a:xfrm>
-          <a:prstGeom prst="rect">
-            <a:avLst/>
-          </a:prstGeom>
-        </p:spPr>
-      </p:pic>
-    </p:spTree>
-    <p:extLst>
-      <p:ext uri="{BB962C8B-B14F-4D97-AF65-F5344CB8AC3E}">
-        <p14:creationId xmlns:p14="http://schemas.microsoft.com/office/powerpoint/2010/main" val="3620250242"/>
-      </p:ext>
-    </p:extLst>
-  </p:cSld>
-  <p:clrMapOvr>
-    <a:masterClrMapping/>
-  </p:clrMapOvr>
-</p:sld>
-</file>
-
-<file path=ppt/slides/slide9.xml><?xml version="1.0" encoding="utf-8"?>
-<p:sld xmlns:a="http://schemas.openxmlformats.org/drawingml/2006/main" xmlns:r="http://schemas.openxmlformats.org/officeDocument/2006/relationships" xmlns:p="http://schemas.openxmlformats.org/presentationml/2006/main">
-  <p:cSld>
-    <p:spTree>
-      <p:nvGrpSpPr>
-        <p:cNvPr id="1" name="">
-          <a:extLst>
-            <a:ext uri="{FF2B5EF4-FFF2-40B4-BE49-F238E27FC236}">
               <a16:creationId xmlns:a16="http://schemas.microsoft.com/office/drawing/2014/main" id="{1A469E13-23B5-9F02-3CD9-1613E4BC7B82}"/>
             </a:ext>
           </a:extLst>
@@ -9316,6 +8956,510 @@
     <p:extLst>
       <p:ext uri="{BB962C8B-B14F-4D97-AF65-F5344CB8AC3E}">
         <p14:creationId xmlns:p14="http://schemas.microsoft.com/office/powerpoint/2010/main" val="4161723360"/>
+      </p:ext>
+    </p:extLst>
+  </p:cSld>
+  <p:clrMapOvr>
+    <a:masterClrMapping/>
+  </p:clrMapOvr>
+</p:sld>
+</file>
+
+<file path=ppt/slides/slide8.xml><?xml version="1.0" encoding="utf-8"?>
+<p:sld xmlns:a="http://schemas.openxmlformats.org/drawingml/2006/main" xmlns:r="http://schemas.openxmlformats.org/officeDocument/2006/relationships" xmlns:p="http://schemas.openxmlformats.org/presentationml/2006/main">
+  <p:cSld>
+    <p:spTree>
+      <p:nvGrpSpPr>
+        <p:cNvPr id="1" name="">
+          <a:extLst>
+            <a:ext uri="{FF2B5EF4-FFF2-40B4-BE49-F238E27FC236}">
+              <a16:creationId xmlns:a16="http://schemas.microsoft.com/office/drawing/2014/main" id="{BC2AB332-2400-FA8E-BE32-C1400637A499}"/>
+            </a:ext>
+          </a:extLst>
+        </p:cNvPr>
+        <p:cNvGrpSpPr/>
+        <p:nvPr/>
+      </p:nvGrpSpPr>
+      <p:grpSpPr>
+        <a:xfrm>
+          <a:off x="0" y="0"/>
+          <a:ext cx="0" cy="0"/>
+          <a:chOff x="0" y="0"/>
+          <a:chExt cx="0" cy="0"/>
+        </a:xfrm>
+      </p:grpSpPr>
+      <p:sp>
+        <p:nvSpPr>
+          <p:cNvPr id="2" name="Title 1">
+            <a:extLst>
+              <a:ext uri="{FF2B5EF4-FFF2-40B4-BE49-F238E27FC236}">
+                <a16:creationId xmlns:a16="http://schemas.microsoft.com/office/drawing/2014/main" id="{DF0462F8-8465-9133-CCE5-11738113DA73}"/>
+              </a:ext>
+            </a:extLst>
+          </p:cNvPr>
+          <p:cNvSpPr>
+            <a:spLocks noGrp="1"/>
+          </p:cNvSpPr>
+          <p:nvPr>
+            <p:ph type="title"/>
+          </p:nvPr>
+        </p:nvSpPr>
+        <p:spPr/>
+        <p:txBody>
+          <a:bodyPr/>
+          <a:lstStyle/>
+          <a:p>
+            <a:r>
+              <a:rPr lang="en-US" dirty="0"/>
+              <a:t>Functional Requirements cont.</a:t>
+            </a:r>
+          </a:p>
+        </p:txBody>
+      </p:sp>
+      <p:sp>
+        <p:nvSpPr>
+          <p:cNvPr id="9" name="TextBox 8">
+            <a:extLst>
+              <a:ext uri="{FF2B5EF4-FFF2-40B4-BE49-F238E27FC236}">
+                <a16:creationId xmlns:a16="http://schemas.microsoft.com/office/drawing/2014/main" id="{D1E80910-C870-7160-FBBF-A85E6A668CA7}"/>
+              </a:ext>
+            </a:extLst>
+          </p:cNvPr>
+          <p:cNvSpPr txBox="1"/>
+          <p:nvPr/>
+        </p:nvSpPr>
+        <p:spPr>
+          <a:xfrm>
+            <a:off x="1097280" y="1737360"/>
+            <a:ext cx="6267450" cy="3083921"/>
+          </a:xfrm>
+          <a:prstGeom prst="rect">
+            <a:avLst/>
+          </a:prstGeom>
+          <a:noFill/>
+        </p:spPr>
+        <p:txBody>
+          <a:bodyPr wrap="square" rtlCol="0">
+            <a:spAutoFit/>
+          </a:bodyPr>
+          <a:lstStyle/>
+          <a:p>
+            <a:pPr marL="285750" indent="-285750">
+              <a:lnSpc>
+                <a:spcPct val="200000"/>
+              </a:lnSpc>
+              <a:buFont typeface="Arial" panose="020B0604020202020204" pitchFamily="34" charset="0"/>
+              <a:buChar char="•"/>
+            </a:pPr>
+            <a:r>
+              <a:rPr lang="en-US" sz="2000" dirty="0"/>
+              <a:t>File sharing</a:t>
+            </a:r>
+          </a:p>
+          <a:p>
+            <a:pPr marL="285750" indent="-285750">
+              <a:lnSpc>
+                <a:spcPct val="200000"/>
+              </a:lnSpc>
+              <a:buFont typeface="Arial" panose="020B0604020202020204" pitchFamily="34" charset="0"/>
+              <a:buChar char="•"/>
+            </a:pPr>
+            <a:r>
+              <a:rPr lang="en-US" sz="2000" dirty="0"/>
+              <a:t>Administrative tools</a:t>
+            </a:r>
+          </a:p>
+          <a:p>
+            <a:pPr marL="285750" indent="-285750">
+              <a:lnSpc>
+                <a:spcPct val="200000"/>
+              </a:lnSpc>
+              <a:buFont typeface="Arial" panose="020B0604020202020204" pitchFamily="34" charset="0"/>
+              <a:buChar char="•"/>
+            </a:pPr>
+            <a:r>
+              <a:rPr lang="en-US" sz="2000" dirty="0"/>
+              <a:t>System requirements</a:t>
+            </a:r>
+          </a:p>
+          <a:p>
+            <a:pPr marL="285750" indent="-285750">
+              <a:lnSpc>
+                <a:spcPct val="200000"/>
+              </a:lnSpc>
+              <a:buFont typeface="Arial" panose="020B0604020202020204" pitchFamily="34" charset="0"/>
+              <a:buChar char="•"/>
+            </a:pPr>
+            <a:r>
+              <a:rPr lang="en-US" sz="2000" dirty="0"/>
+              <a:t>Data storage</a:t>
+            </a:r>
+          </a:p>
+          <a:p>
+            <a:pPr marL="285750" indent="-285750">
+              <a:lnSpc>
+                <a:spcPct val="200000"/>
+              </a:lnSpc>
+              <a:buFont typeface="Arial" panose="020B0604020202020204" pitchFamily="34" charset="0"/>
+              <a:buChar char="•"/>
+            </a:pPr>
+            <a:r>
+              <a:rPr lang="en-US" sz="2000" dirty="0"/>
+              <a:t>Security</a:t>
+            </a:r>
+          </a:p>
+        </p:txBody>
+      </p:sp>
+      <p:pic>
+        <p:nvPicPr>
+          <p:cNvPr id="12" name="Picture 11" descr="A blue lock and shield with check mark&#10;&#10;AI-generated content may be incorrect.">
+            <a:extLst>
+              <a:ext uri="{FF2B5EF4-FFF2-40B4-BE49-F238E27FC236}">
+                <a16:creationId xmlns:a16="http://schemas.microsoft.com/office/drawing/2014/main" id="{ECE98841-D245-BA0C-FBCE-5C6E05758561}"/>
+              </a:ext>
+            </a:extLst>
+          </p:cNvPr>
+          <p:cNvPicPr>
+            <a:picLocks noChangeAspect="1"/>
+          </p:cNvPicPr>
+          <p:nvPr/>
+        </p:nvPicPr>
+        <p:blipFill>
+          <a:blip r:embed="rId3">
+            <a:extLst>
+              <a:ext uri="{28A0092B-C50C-407E-A947-70E740481C1C}">
+                <a14:useLocalDpi xmlns:a14="http://schemas.microsoft.com/office/drawing/2010/main" val="0"/>
+              </a:ext>
+            </a:extLst>
+          </a:blip>
+          <a:stretch>
+            <a:fillRect/>
+          </a:stretch>
+        </p:blipFill>
+        <p:spPr>
+          <a:xfrm>
+            <a:off x="5396169" y="2552764"/>
+            <a:ext cx="1752472" cy="1752472"/>
+          </a:xfrm>
+          <a:prstGeom prst="rect">
+            <a:avLst/>
+          </a:prstGeom>
+        </p:spPr>
+      </p:pic>
+      <p:pic>
+        <p:nvPicPr>
+          <p:cNvPr id="14" name="Picture 13">
+            <a:extLst>
+              <a:ext uri="{FF2B5EF4-FFF2-40B4-BE49-F238E27FC236}">
+                <a16:creationId xmlns:a16="http://schemas.microsoft.com/office/drawing/2014/main" id="{92E8A1F5-B754-2AB1-2734-9C5FC5BAF2EB}"/>
+              </a:ext>
+            </a:extLst>
+          </p:cNvPr>
+          <p:cNvPicPr>
+            <a:picLocks noChangeAspect="1"/>
+          </p:cNvPicPr>
+          <p:nvPr/>
+        </p:nvPicPr>
+        <p:blipFill>
+          <a:blip r:embed="rId4"/>
+          <a:stretch>
+            <a:fillRect/>
+          </a:stretch>
+        </p:blipFill>
+        <p:spPr>
+          <a:xfrm>
+            <a:off x="7619621" y="2552764"/>
+            <a:ext cx="1752472" cy="1752472"/>
+          </a:xfrm>
+          <a:prstGeom prst="rect">
+            <a:avLst/>
+          </a:prstGeom>
+        </p:spPr>
+      </p:pic>
+      <p:pic>
+        <p:nvPicPr>
+          <p:cNvPr id="3" name="Picture 2" descr="A logo with a light bulb and text&#10;&#10;AI-generated content may be incorrect.">
+            <a:extLst>
+              <a:ext uri="{FF2B5EF4-FFF2-40B4-BE49-F238E27FC236}">
+                <a16:creationId xmlns:a16="http://schemas.microsoft.com/office/drawing/2014/main" id="{4071D38F-4514-2501-A71E-4063E8D25C58}"/>
+              </a:ext>
+            </a:extLst>
+          </p:cNvPr>
+          <p:cNvPicPr>
+            <a:picLocks noChangeAspect="1"/>
+          </p:cNvPicPr>
+          <p:nvPr/>
+        </p:nvPicPr>
+        <p:blipFill>
+          <a:blip r:embed="rId5">
+            <a:extLst>
+              <a:ext uri="{28A0092B-C50C-407E-A947-70E740481C1C}">
+                <a14:useLocalDpi xmlns:a14="http://schemas.microsoft.com/office/drawing/2010/main" val="0"/>
+              </a:ext>
+            </a:extLst>
+          </a:blip>
+          <a:stretch>
+            <a:fillRect/>
+          </a:stretch>
+        </p:blipFill>
+        <p:spPr>
+          <a:xfrm>
+            <a:off x="11354417" y="0"/>
+            <a:ext cx="837583" cy="837583"/>
+          </a:xfrm>
+          <a:prstGeom prst="rect">
+            <a:avLst/>
+          </a:prstGeom>
+        </p:spPr>
+      </p:pic>
+    </p:spTree>
+    <p:extLst>
+      <p:ext uri="{BB962C8B-B14F-4D97-AF65-F5344CB8AC3E}">
+        <p14:creationId xmlns:p14="http://schemas.microsoft.com/office/powerpoint/2010/main" val="3435960839"/>
+      </p:ext>
+    </p:extLst>
+  </p:cSld>
+  <p:clrMapOvr>
+    <a:masterClrMapping/>
+  </p:clrMapOvr>
+</p:sld>
+</file>
+
+<file path=ppt/slides/slide9.xml><?xml version="1.0" encoding="utf-8"?>
+<p:sld xmlns:a="http://schemas.openxmlformats.org/drawingml/2006/main" xmlns:r="http://schemas.openxmlformats.org/officeDocument/2006/relationships" xmlns:p="http://schemas.openxmlformats.org/presentationml/2006/main">
+  <p:cSld>
+    <p:spTree>
+      <p:nvGrpSpPr>
+        <p:cNvPr id="1" name="">
+          <a:extLst>
+            <a:ext uri="{FF2B5EF4-FFF2-40B4-BE49-F238E27FC236}">
+              <a16:creationId xmlns:a16="http://schemas.microsoft.com/office/drawing/2014/main" id="{1A30B569-EFAB-5D0B-5805-779BF4F6045A}"/>
+            </a:ext>
+          </a:extLst>
+        </p:cNvPr>
+        <p:cNvGrpSpPr/>
+        <p:nvPr/>
+      </p:nvGrpSpPr>
+      <p:grpSpPr>
+        <a:xfrm>
+          <a:off x="0" y="0"/>
+          <a:ext cx="0" cy="0"/>
+          <a:chOff x="0" y="0"/>
+          <a:chExt cx="0" cy="0"/>
+        </a:xfrm>
+      </p:grpSpPr>
+      <p:sp>
+        <p:nvSpPr>
+          <p:cNvPr id="2" name="Title 1">
+            <a:extLst>
+              <a:ext uri="{FF2B5EF4-FFF2-40B4-BE49-F238E27FC236}">
+                <a16:creationId xmlns:a16="http://schemas.microsoft.com/office/drawing/2014/main" id="{0953CBA4-4646-FBD2-58BA-9CAEB90DA639}"/>
+              </a:ext>
+            </a:extLst>
+          </p:cNvPr>
+          <p:cNvSpPr>
+            <a:spLocks noGrp="1"/>
+          </p:cNvSpPr>
+          <p:nvPr>
+            <p:ph type="title"/>
+          </p:nvPr>
+        </p:nvSpPr>
+        <p:spPr/>
+        <p:txBody>
+          <a:bodyPr/>
+          <a:lstStyle/>
+          <a:p>
+            <a:r>
+              <a:rPr lang="en-US" dirty="0"/>
+              <a:t>Nonfunctional Requirements</a:t>
+            </a:r>
+          </a:p>
+        </p:txBody>
+      </p:sp>
+      <p:pic>
+        <p:nvPicPr>
+          <p:cNvPr id="3" name="Picture 2" descr="A logo with a light bulb and text&#10;&#10;AI-generated content may be incorrect.">
+            <a:extLst>
+              <a:ext uri="{FF2B5EF4-FFF2-40B4-BE49-F238E27FC236}">
+                <a16:creationId xmlns:a16="http://schemas.microsoft.com/office/drawing/2014/main" id="{B0EF75C4-38CF-B684-CD2E-9E607FDF86E2}"/>
+              </a:ext>
+            </a:extLst>
+          </p:cNvPr>
+          <p:cNvPicPr>
+            <a:picLocks noChangeAspect="1"/>
+          </p:cNvPicPr>
+          <p:nvPr/>
+        </p:nvPicPr>
+        <p:blipFill>
+          <a:blip r:embed="rId3">
+            <a:extLst>
+              <a:ext uri="{28A0092B-C50C-407E-A947-70E740481C1C}">
+                <a14:useLocalDpi xmlns:a14="http://schemas.microsoft.com/office/drawing/2010/main" val="0"/>
+              </a:ext>
+            </a:extLst>
+          </a:blip>
+          <a:stretch>
+            <a:fillRect/>
+          </a:stretch>
+        </p:blipFill>
+        <p:spPr>
+          <a:xfrm>
+            <a:off x="11354417" y="0"/>
+            <a:ext cx="837583" cy="837583"/>
+          </a:xfrm>
+          <a:prstGeom prst="rect">
+            <a:avLst/>
+          </a:prstGeom>
+        </p:spPr>
+      </p:pic>
+      <p:sp>
+        <p:nvSpPr>
+          <p:cNvPr id="4" name="TextBox 3">
+            <a:extLst>
+              <a:ext uri="{FF2B5EF4-FFF2-40B4-BE49-F238E27FC236}">
+                <a16:creationId xmlns:a16="http://schemas.microsoft.com/office/drawing/2014/main" id="{26533C51-4C05-291F-EC90-687738912887}"/>
+              </a:ext>
+            </a:extLst>
+          </p:cNvPr>
+          <p:cNvSpPr txBox="1"/>
+          <p:nvPr/>
+        </p:nvSpPr>
+        <p:spPr>
+          <a:xfrm>
+            <a:off x="1230923" y="2074985"/>
+            <a:ext cx="10058400" cy="5909310"/>
+          </a:xfrm>
+          <a:prstGeom prst="rect">
+            <a:avLst/>
+          </a:prstGeom>
+          <a:noFill/>
+        </p:spPr>
+        <p:txBody>
+          <a:bodyPr wrap="square" rtlCol="0">
+            <a:spAutoFit/>
+          </a:bodyPr>
+          <a:lstStyle/>
+          <a:p>
+            <a:pPr marL="285750" indent="-285750">
+              <a:lnSpc>
+                <a:spcPct val="200000"/>
+              </a:lnSpc>
+              <a:buFont typeface="Arial" panose="020B0604020202020204" pitchFamily="34" charset="0"/>
+              <a:buChar char="•"/>
+            </a:pPr>
+            <a:r>
+              <a:rPr lang="en-US" sz="2000" dirty="0"/>
+              <a:t>Performance</a:t>
+            </a:r>
+          </a:p>
+          <a:p>
+            <a:pPr marL="285750" indent="-285750">
+              <a:lnSpc>
+                <a:spcPct val="200000"/>
+              </a:lnSpc>
+              <a:buFont typeface="Arial" panose="020B0604020202020204" pitchFamily="34" charset="0"/>
+              <a:buChar char="•"/>
+            </a:pPr>
+            <a:r>
+              <a:rPr lang="en-US" sz="2000" dirty="0"/>
+              <a:t>Security</a:t>
+            </a:r>
+          </a:p>
+          <a:p>
+            <a:pPr marL="285750" indent="-285750">
+              <a:lnSpc>
+                <a:spcPct val="200000"/>
+              </a:lnSpc>
+              <a:buFont typeface="Arial" panose="020B0604020202020204" pitchFamily="34" charset="0"/>
+              <a:buChar char="•"/>
+            </a:pPr>
+            <a:r>
+              <a:rPr lang="en-US" sz="2000" dirty="0"/>
+              <a:t>Usability</a:t>
+            </a:r>
+          </a:p>
+          <a:p>
+            <a:pPr marL="285750" indent="-285750">
+              <a:lnSpc>
+                <a:spcPct val="200000"/>
+              </a:lnSpc>
+              <a:buFont typeface="Arial" panose="020B0604020202020204" pitchFamily="34" charset="0"/>
+              <a:buChar char="•"/>
+            </a:pPr>
+            <a:r>
+              <a:rPr lang="en-US" sz="2000" dirty="0"/>
+              <a:t>Compatibility</a:t>
+            </a:r>
+          </a:p>
+          <a:p>
+            <a:pPr marL="285750" indent="-285750">
+              <a:lnSpc>
+                <a:spcPct val="200000"/>
+              </a:lnSpc>
+              <a:buFont typeface="Arial" panose="020B0604020202020204" pitchFamily="34" charset="0"/>
+              <a:buChar char="•"/>
+            </a:pPr>
+            <a:r>
+              <a:rPr lang="en-US" sz="2000" dirty="0"/>
+              <a:t>Privacy</a:t>
+            </a:r>
+          </a:p>
+          <a:p>
+            <a:pPr marL="285750" indent="-285750">
+              <a:lnSpc>
+                <a:spcPct val="200000"/>
+              </a:lnSpc>
+              <a:buFont typeface="Arial" panose="020B0604020202020204" pitchFamily="34" charset="0"/>
+              <a:buChar char="•"/>
+            </a:pPr>
+            <a:r>
+              <a:rPr lang="en-US" sz="2000" dirty="0"/>
+              <a:t>Scalability</a:t>
+            </a:r>
+          </a:p>
+          <a:p>
+            <a:pPr marL="285750" indent="-285750">
+              <a:lnSpc>
+                <a:spcPct val="200000"/>
+              </a:lnSpc>
+              <a:buFont typeface="Arial" panose="020B0604020202020204" pitchFamily="34" charset="0"/>
+              <a:buChar char="•"/>
+            </a:pPr>
+            <a:endParaRPr lang="en-US" sz="2000" dirty="0"/>
+          </a:p>
+          <a:p>
+            <a:pPr marL="285750" indent="-285750">
+              <a:lnSpc>
+                <a:spcPct val="200000"/>
+              </a:lnSpc>
+              <a:buFont typeface="Arial" panose="020B0604020202020204" pitchFamily="34" charset="0"/>
+              <a:buChar char="•"/>
+            </a:pPr>
+            <a:endParaRPr lang="en-US" sz="2000" dirty="0"/>
+          </a:p>
+          <a:p>
+            <a:pPr marL="285750" indent="-285750">
+              <a:lnSpc>
+                <a:spcPct val="200000"/>
+              </a:lnSpc>
+              <a:buFont typeface="Arial" panose="020B0604020202020204" pitchFamily="34" charset="0"/>
+              <a:buChar char="•"/>
+            </a:pPr>
+            <a:endParaRPr lang="en-US" sz="2000" dirty="0"/>
+          </a:p>
+          <a:p>
+            <a:pPr marL="285750" indent="-285750">
+              <a:buFont typeface="Arial" panose="020B0604020202020204" pitchFamily="34" charset="0"/>
+              <a:buChar char="•"/>
+            </a:pPr>
+            <a:endParaRPr lang="en-US" dirty="0"/>
+          </a:p>
+        </p:txBody>
+      </p:sp>
+    </p:spTree>
+    <p:extLst>
+      <p:ext uri="{BB962C8B-B14F-4D97-AF65-F5344CB8AC3E}">
+        <p14:creationId xmlns:p14="http://schemas.microsoft.com/office/powerpoint/2010/main" val="1802189812"/>
       </p:ext>
     </p:extLst>
   </p:cSld>

</xml_diff>